<commit_message>
Lab deck slide 2: a how-to-read line under Tobler's formula (s, flat and 20% climb speeds); plain-words speaker notes incl. what sac_scale is
Co-Authored-By: Claude Opus 5.5 <noreply@anthropic.com>
</commit_message>
<xml_diff>
--- a/meeting_plots/oct23_lab/Zhou_LabMeeting_23Oct.pptx
+++ b/meeting_plots/oct23_lab/Zhou_LabMeeting_23Oct.pptx
@@ -113,29 +113,29 @@
   <p:extLst>
     <p:ext uri="{521415D9-36F7-43E2-AB2F-B90AF26B5E84}">
       <p14:sectionLst xmlns:p14="http://schemas.microsoft.com/office/powerpoint/2010/main">
-        <p14:section name="Introduction" id="{dcbe3465-e0cc-e3bd-9a67-46780cabefa6}">
+        <p14:section name="Introduction" id="{843211b6-7766-b617-e802-99db6fd4d674}">
           <p14:sldIdLst>
             <p14:sldId id="256"/>
           </p14:sldIdLst>
         </p14:section>
-        <p14:section name="Problem and goal" id="{1f9eb309-5f59-04b6-4293-1c77ecb8ac4c}">
+        <p14:section name="Problem and goal" id="{3809864b-6f8d-8704-c417-b5e7c01920ff}">
           <p14:sldIdLst>
             <p14:sldId id="257"/>
             <p14:sldId id="258"/>
           </p14:sldIdLst>
         </p14:section>
-        <p14:section name="What I built" id="{530ca134-3aa5-ae40-d094-1bfb23f5e171}">
+        <p14:section name="What I built" id="{2caea34b-b388-1ac8-82b1-72b4396183bc}">
           <p14:sldIdLst>
             <p14:sldId id="259"/>
           </p14:sldIdLst>
         </p14:section>
-        <p14:section name="Findings" id="{b8396b90-63a2-7a56-e4e5-e176f44f9369}">
+        <p14:section name="Findings" id="{0893200d-0da0-618c-7d4f-5ae3440dbbac}">
           <p14:sldIdLst>
             <p14:sldId id="260"/>
             <p14:sldId id="261"/>
           </p14:sldIdLst>
         </p14:section>
-        <p14:section name="Next steps" id="{cc24e977-bb7c-5d75-0a6a-57581e286301}">
+        <p14:section name="Next steps" id="{dd91c72d-cb00-b17a-5379-2b7a9c301a8a}">
           <p14:sldIdLst>
             <p14:sldId id="262"/>
           </p14:sldIdLst>
@@ -974,7 +974,7 @@
           <a:p>
             <a:r>
               <a:rPr lang="en-US" dirty="0"/>
-              <a:t>GIS tools still estimate walking speed with Tobler's 1993 formula: 6 km/h at its peak, and the same curve for every trail. It was fit to figures in a cartography textbook, not to real hikes, and it is what search and rescue, wildfire escape routes and trail apps start from. Trail maps could add detail: OpenStreetMap has a difficulty tag. But as the chart shows, it covers 1.5% of walked trail in one region and 96% in another.</a:t>
+              <a:t>Today, if software estimates how long a hike takes, it usually uses Tobler's formula from 1993. v is walking speed, s is the slope. It says you're fastest, 6 km/h, on a gentle downhill, and slower the steeper it gets: about 5 km/h on flat ground, 2.5 on a 20% climb. There are three problems. It was fit to numbers in a cartography textbook, not to real hikes. It's one curve for every trail, so a rocky scramble and a smooth path get the same speed. And it's still what GIS tools use for search and rescue, wildfire escape routes and trail apps. Could the trail map fix this? OpenStreetMap has a difficulty grade called sac_scale, from the Swiss Alpine Club: from easy 'hiking' up to 'alpine hiking'. But this chart shows how much of the trail actually has it: 96% in the Adirondacks, under 2% in the Green Mountains. For most trails, the map can't tell you how hard they are.</a:t>
             </a:r>
             <a:endParaRPr lang="en-US" dirty="0"/>
           </a:p>
@@ -2553,11 +2553,11 @@
         <p:spPr>
           <a:xfrm>
             <a:off x="548640" y="1325880"/>
-            <a:ext cx="5486400" cy="1325880"/>
+            <a:ext cx="5486400" cy="1737360"/>
           </a:xfrm>
           <a:prstGeom prst="roundRect">
             <a:avLst>
-              <a:gd name="adj" fmla="val 6897"/>
+              <a:gd name="adj" fmla="val 5263"/>
             </a:avLst>
           </a:prstGeom>
           <a:solidFill>
@@ -2668,13 +2668,60 @@
       </p:sp>
       <p:sp>
         <p:nvSpPr>
-          <p:cNvPr id="6" name="Problem marker 1"/>
+          <p:cNvPr id="6" name="Formula how to read"/>
+          <p:cNvSpPr txBox="1"/>
+          <p:nvPr/>
+        </p:nvSpPr>
+        <p:spPr>
+          <a:xfrm>
+            <a:off x="822960" y="2514600"/>
+            <a:ext cx="4937760" cy="457200"/>
+          </a:xfrm>
+          <a:prstGeom prst="rect">
+            <a:avLst/>
+          </a:prstGeom>
+          <a:noFill/>
+          <a:ln/>
+        </p:spPr>
+        <p:txBody>
+          <a:bodyPr wrap="square" lIns="0" tIns="0" rIns="0" bIns="0" rtlCol="0" anchor="t"/>
+          <a:lstStyle/>
+          <a:p>
+            <a:pPr indent="0" marL="0">
+              <a:buNone/>
+            </a:pPr>
+            <a:r>
+              <a:rPr lang="en-US" sz="1400" dirty="0">
+                <a:solidFill>
+                  <a:schemeClr val="tx1"/>
+                </a:solidFill>
+              </a:rPr>
+              <a:t>s = slope (0.10 = 10% uphill).  </a:t>
+            </a:r>
+            <a:pPr indent="0" marL="0">
+              <a:buNone/>
+            </a:pPr>
+            <a:r>
+              <a:rPr lang="en-US" sz="1400" dirty="0">
+                <a:solidFill>
+                  <a:schemeClr val="accent4"/>
+                </a:solidFill>
+              </a:rPr>
+              <a:t>Fastest at a gentle downhill: 6 km/h. Flat: 5.0 km/h. 20% climb: 2.5 km/h.</a:t>
+            </a:r>
+            <a:endParaRPr lang="en-US" sz="1400" dirty="0"/>
+          </a:p>
+        </p:txBody>
+      </p:sp>
+      <p:sp>
+        <p:nvSpPr>
+          <p:cNvPr id="7" name="Problem marker 1"/>
           <p:cNvSpPr/>
           <p:nvPr/>
         </p:nvSpPr>
         <p:spPr>
           <a:xfrm>
-            <a:off x="566928" y="3008376"/>
+            <a:off x="566928" y="3374136"/>
             <a:ext cx="164592" cy="164592"/>
           </a:xfrm>
           <a:prstGeom prst="ellipse">
@@ -2688,13 +2735,13 @@
       </p:sp>
       <p:sp>
         <p:nvSpPr>
-          <p:cNvPr id="7" name="Problem 1"/>
+          <p:cNvPr id="8" name="Problem 1"/>
           <p:cNvSpPr txBox="1"/>
           <p:nvPr/>
         </p:nvSpPr>
         <p:spPr>
           <a:xfrm>
-            <a:off x="914400" y="2926080"/>
+            <a:off x="914400" y="3291840"/>
             <a:ext cx="5120640" cy="658368"/>
           </a:xfrm>
           <a:prstGeom prst="rect">
@@ -2738,13 +2785,13 @@
       </p:sp>
       <p:sp>
         <p:nvSpPr>
-          <p:cNvPr id="8" name="Problem marker 2"/>
+          <p:cNvPr id="9" name="Problem marker 2"/>
           <p:cNvSpPr/>
           <p:nvPr/>
         </p:nvSpPr>
         <p:spPr>
           <a:xfrm>
-            <a:off x="566928" y="3758184"/>
+            <a:off x="566928" y="4087368"/>
             <a:ext cx="164592" cy="164592"/>
           </a:xfrm>
           <a:prstGeom prst="ellipse">
@@ -2758,13 +2805,13 @@
       </p:sp>
       <p:sp>
         <p:nvSpPr>
-          <p:cNvPr id="9" name="Problem 2"/>
+          <p:cNvPr id="10" name="Problem 2"/>
           <p:cNvSpPr txBox="1"/>
           <p:nvPr/>
         </p:nvSpPr>
         <p:spPr>
           <a:xfrm>
-            <a:off x="914400" y="3675888"/>
+            <a:off x="914400" y="4005072"/>
             <a:ext cx="5120640" cy="658368"/>
           </a:xfrm>
           <a:prstGeom prst="rect">
@@ -2808,13 +2855,13 @@
       </p:sp>
       <p:sp>
         <p:nvSpPr>
-          <p:cNvPr id="10" name="Problem marker 3"/>
+          <p:cNvPr id="11" name="Problem marker 3"/>
           <p:cNvSpPr/>
           <p:nvPr/>
         </p:nvSpPr>
         <p:spPr>
           <a:xfrm>
-            <a:off x="566928" y="4507992"/>
+            <a:off x="566928" y="4800600"/>
             <a:ext cx="164592" cy="164592"/>
           </a:xfrm>
           <a:prstGeom prst="ellipse">
@@ -2828,13 +2875,13 @@
       </p:sp>
       <p:sp>
         <p:nvSpPr>
-          <p:cNvPr id="11" name="Problem 3"/>
+          <p:cNvPr id="12" name="Problem 3"/>
           <p:cNvSpPr txBox="1"/>
           <p:nvPr/>
         </p:nvSpPr>
         <p:spPr>
           <a:xfrm>
-            <a:off x="914400" y="4425696"/>
+            <a:off x="914400" y="4718304"/>
             <a:ext cx="5120640" cy="658368"/>
           </a:xfrm>
           <a:prstGeom prst="rect">
@@ -2878,13 +2925,13 @@
       </p:sp>
       <p:sp>
         <p:nvSpPr>
-          <p:cNvPr id="12" name="Tag coverage note"/>
+          <p:cNvPr id="13" name="Tag coverage note"/>
           <p:cNvSpPr txBox="1"/>
           <p:nvPr/>
         </p:nvSpPr>
         <p:spPr>
           <a:xfrm>
-            <a:off x="548640" y="5349240"/>
+            <a:off x="548640" y="5440680"/>
             <a:ext cx="5486400" cy="731520"/>
           </a:xfrm>
           <a:prstGeom prst="rect">
@@ -2947,7 +2994,7 @@
       </p:sp>
       <p:graphicFrame>
         <p:nvGraphicFramePr>
-          <p:cNvPr id="13" name="Tag coverage chart" descr=""/>
+          <p:cNvPr id="14" name="Tag coverage chart" descr=""/>
           <p:cNvGraphicFramePr/>
           <p:nvPr/>
         </p:nvGraphicFramePr>

</xml_diff>

<commit_message>
Lab deck slide 3: goal says how the test works (train on 16 regions, test on the 17th); plain-words speaker notes
Co-Authored-By: Claude Opus 5.5 <noreply@anthropic.com>
</commit_message>
<xml_diff>
--- a/meeting_plots/oct23_lab/Zhou_LabMeeting_23Oct.pptx
+++ b/meeting_plots/oct23_lab/Zhou_LabMeeting_23Oct.pptx
@@ -113,29 +113,29 @@
   <p:extLst>
     <p:ext uri="{521415D9-36F7-43E2-AB2F-B90AF26B5E84}">
       <p14:sectionLst xmlns:p14="http://schemas.microsoft.com/office/powerpoint/2010/main">
-        <p14:section name="Introduction" id="{843211b6-7766-b617-e802-99db6fd4d674}">
+        <p14:section name="Introduction" id="{ed761a67-f39d-bd52-fd64-094e1fe025a7}">
           <p14:sldIdLst>
             <p14:sldId id="256"/>
           </p14:sldIdLst>
         </p14:section>
-        <p14:section name="Problem and goal" id="{3809864b-6f8d-8704-c417-b5e7c01920ff}">
+        <p14:section name="Problem and goal" id="{8f7f1ebd-23dc-7b53-7836-5f32323810fd}">
           <p14:sldIdLst>
             <p14:sldId id="257"/>
             <p14:sldId id="258"/>
           </p14:sldIdLst>
         </p14:section>
-        <p14:section name="What I built" id="{2caea34b-b388-1ac8-82b1-72b4396183bc}">
+        <p14:section name="What I built" id="{6864332e-2d8b-971e-6b85-bd5b684948aa}">
           <p14:sldIdLst>
             <p14:sldId id="259"/>
           </p14:sldIdLst>
         </p14:section>
-        <p14:section name="Findings" id="{0893200d-0da0-618c-7d4f-5ae3440dbbac}">
+        <p14:section name="Findings" id="{5c28d17f-47e2-1771-1945-d53a5d61c4b1}">
           <p14:sldIdLst>
             <p14:sldId id="260"/>
             <p14:sldId id="261"/>
           </p14:sldIdLst>
         </p14:section>
-        <p14:section name="Next steps" id="{dd91c72d-cb00-b17a-5379-2b7a9c301a8a}">
+        <p14:section name="Next steps" id="{3292455c-d44a-2f62-3670-0175e67247a1}">
           <p14:sldIdLst>
             <p14:sldId id="262"/>
           </p14:sldIdLst>
@@ -1062,7 +1062,7 @@
           <a:p>
             <a:r>
               <a:rPr lang="en-US" dirty="0"/>
-              <a:t>Crowdsourced GPS studies already show Tobler is too fast, and newer models add inputs like OSM terrain classes, weather or lidar. STRIDE models speed from lidar using timed field walks, and our lab's RasterNet learns road speed from lidar and imagery. But these studies fit and test in one area, with random splits. Nobody has tested whether such a model works in a region it has never seen, or compared map tags with remote sensing directly. That is the goal: four models that differ only in what they can see, tested on regions held out entirely.</a:t>
+              <a:t>How have people tackled this before? Some refit the slope curve with data from fitness apps like Strava and AllTrails, and found Tobler is too fast, but they still use slope only. Others add more inputs: trail types and lidar in England, weather and other factors in Hong Kong. But they test on the same area they trained on, so the test trails sit right next to the training trails. STRIDE builds a lidar model from timed field walks, and our lab's RasterNet predicts road speed from lidar and aerial imagery. What's missing: nobody has checked whether these models work in a region they've never seen, which is where predictions are actually needed, and nobody has compared the map's tags with remote sensing head to head. So our goal: predict the speed on every 50 m of trail, with a range, from what's visible from above, and test it on a region the model never saw: train on 16 regions, test on the 17th. We compare four models that learn the same way but see different inputs: slope only, the map's tags, remote sensing, or both.</a:t>
             </a:r>
             <a:endParaRPr lang="en-US" dirty="0"/>
           </a:p>
@@ -3545,7 +3545,7 @@
                 <a:ea typeface="+mj-lt" pitchFamily="34" charset="-122"/>
                 <a:cs typeface="+mj-lt" pitchFamily="34" charset="-120"/>
               </a:rPr>
-              <a:t>Predict the speed of every 50 m of trail, with its uncertainty, from what can be seen from above, and test it in regions the model never saw.</a:t>
+              <a:t>Predict the speed of every 50 m of trail, with its uncertainty, from what can be seen from above. Test it on regions the model never saw: train on 16, test on the 17th.</a:t>
             </a:r>
             <a:endParaRPr lang="en-US" sz="2000" dirty="0"/>
           </a:p>

</xml_diff>

<commit_message>
Lab deck slide 4: plain 'hikes' label; plain-words speaker notes with answers to likely follow-ups
Co-Authored-By: Claude Opus 5.5 <noreply@anthropic.com>
</commit_message>
<xml_diff>
--- a/meeting_plots/oct23_lab/Zhou_LabMeeting_23Oct.pptx
+++ b/meeting_plots/oct23_lab/Zhou_LabMeeting_23Oct.pptx
@@ -113,29 +113,29 @@
   <p:extLst>
     <p:ext uri="{521415D9-36F7-43E2-AB2F-B90AF26B5E84}">
       <p14:sectionLst xmlns:p14="http://schemas.microsoft.com/office/powerpoint/2010/main">
-        <p14:section name="Introduction" id="{ed761a67-f39d-bd52-fd64-094e1fe025a7}">
+        <p14:section name="Introduction" id="{4aad3e49-700e-4754-17f7-bf623e4012ab}">
           <p14:sldIdLst>
             <p14:sldId id="256"/>
           </p14:sldIdLst>
         </p14:section>
-        <p14:section name="Problem and goal" id="{8f7f1ebd-23dc-7b53-7836-5f32323810fd}">
+        <p14:section name="Problem and goal" id="{290060ef-4a3e-ef9c-34ae-5b5628fcaa95}">
           <p14:sldIdLst>
             <p14:sldId id="257"/>
             <p14:sldId id="258"/>
           </p14:sldIdLst>
         </p14:section>
-        <p14:section name="What I built" id="{6864332e-2d8b-971e-6b85-bd5b684948aa}">
+        <p14:section name="What I built" id="{2cafd3f1-675f-226b-862f-ef49fd8da66f}">
           <p14:sldIdLst>
             <p14:sldId id="259"/>
           </p14:sldIdLst>
         </p14:section>
-        <p14:section name="Findings" id="{5c28d17f-47e2-1771-1945-d53a5d61c4b1}">
+        <p14:section name="Findings" id="{fa21799a-9b50-1923-c6cb-98536d5bfea6}">
           <p14:sldIdLst>
             <p14:sldId id="260"/>
             <p14:sldId id="261"/>
           </p14:sldIdLst>
         </p14:section>
-        <p14:section name="Next steps" id="{3292455c-d44a-2f62-3670-0175e67247a1}">
+        <p14:section name="Next steps" id="{803d3f78-45b1-3fee-bc6f-7be33f4bf9cf}">
           <p14:sldIdLst>
             <p14:sldId id="262"/>
           </p14:sldIdLst>
@@ -1150,7 +1150,7 @@
           <a:p>
             <a:r>
               <a:rPr lang="en-US" dirty="0"/>
-              <a:t>I built the dataset from public OpenStreetMap GPS traces in 17 mountain regions in the US and Canada, plus the lab's crawl of 1.5 million original uploads. The pipeline cleans each trace, removes stops, matches it to the trail network with a hidden Markov model, and cuts it into 50 m segments. Each segment gets its speed, slope, OSM tags, terrain from 1 m lidar and 5 m elevation, vegetation and satellite embeddings. That's 290,640 segments from 1,992 hikes.</a:t>
+              <a:t>Here's the data. I used public GPS tracks that hikers upload to OpenStreetMap, from 17 mountain regions in the US and Canada; bigger circles mean more hours of hiking. For each track, the pipeline at the bottom removes GPS glitches and stops, because we want walking speed, not lunch breaks. Then it snaps the points onto the trail map, the way a car's navigation snaps you to the road, and cuts the hike into 50-meter pieces. Each piece gets its speed and slope, plus what the map says about the trail and what lidar and satellites see. In total that's 290,640 pieces from about 2,000 hikes: 14,500 km and 4,700 hours of walking. The inset is the White Mountains, with every piece colored by speed. (If asked: a group that uploads several tracks of the same walk counts as one hike; snapping uses a hidden Markov model; 85 to 99% of points match, depending on the region.)</a:t>
             </a:r>
             <a:endParaRPr lang="en-US" dirty="0"/>
           </a:p>
@@ -4190,7 +4190,7 @@
                   <a:schemeClr val="tx1"/>
                 </a:solidFill>
               </a:rPr>
-              <a:t>hikes (outings)</a:t>
+              <a:t>hikes</a:t>
             </a:r>
             <a:endParaRPr lang="en-US" sz="1500" dirty="0"/>
           </a:p>

</xml_diff>

<commit_message>
Lab deck slide 5: plain wording for the Tobler comparison; plain-words speaker notes with answers to likely follow-ups
Co-Authored-By: Claude Opus 5.5 <noreply@anthropic.com>
</commit_message>
<xml_diff>
--- a/meeting_plots/oct23_lab/Zhou_LabMeeting_23Oct.pptx
+++ b/meeting_plots/oct23_lab/Zhou_LabMeeting_23Oct.pptx
@@ -113,29 +113,29 @@
   <p:extLst>
     <p:ext uri="{521415D9-36F7-43E2-AB2F-B90AF26B5E84}">
       <p14:sectionLst xmlns:p14="http://schemas.microsoft.com/office/powerpoint/2010/main">
-        <p14:section name="Introduction" id="{4aad3e49-700e-4754-17f7-bf623e4012ab}">
+        <p14:section name="Introduction" id="{62dd8a2a-9a49-5a2b-938f-38b80a7ad2a6}">
           <p14:sldIdLst>
             <p14:sldId id="256"/>
           </p14:sldIdLst>
         </p14:section>
-        <p14:section name="Problem and goal" id="{290060ef-4a3e-ef9c-34ae-5b5628fcaa95}">
+        <p14:section name="Problem and goal" id="{77c0655e-71b5-d2c7-d04f-16981867c7aa}">
           <p14:sldIdLst>
             <p14:sldId id="257"/>
             <p14:sldId id="258"/>
           </p14:sldIdLst>
         </p14:section>
-        <p14:section name="What I built" id="{2cafd3f1-675f-226b-862f-ef49fd8da66f}">
+        <p14:section name="What I built" id="{55d244ad-f894-fa30-4a07-5b56a9339411}">
           <p14:sldIdLst>
             <p14:sldId id="259"/>
           </p14:sldIdLst>
         </p14:section>
-        <p14:section name="Findings" id="{fa21799a-9b50-1923-c6cb-98536d5bfea6}">
+        <p14:section name="Findings" id="{1bb8e09b-d0df-a914-e2dc-588ad4cb067f}">
           <p14:sldIdLst>
             <p14:sldId id="260"/>
             <p14:sldId id="261"/>
           </p14:sldIdLst>
         </p14:section>
-        <p14:section name="Next steps" id="{803d3f78-45b1-3fee-bc6f-7be33f4bf9cf}">
+        <p14:section name="Next steps" id="{254f7583-7be7-214d-9c4e-617ecee8608a}">
           <p14:sldIdLst>
             <p14:sldId id="262"/>
           </p14:sldIdLst>
@@ -1238,7 +1238,7 @@
           <a:p>
             <a:r>
               <a:rPr lang="en-US" dirty="0"/>
-              <a:t>First finding. Real hikers peak around 4.2 km/h, not 6, and the top of the curve is rounded. From hikes where the same person walked the same trail both ways, going down is only 8 to 23% faster than going up; Tobler assumes 42% at every grade. Scored in regions the model never saw, Tobler is worse than a refitted slope curve in all 17 regions.</a:t>
+              <a:t>First finding. Each gray dot is the typical speed of real hikers at one slope, downhill on the left, uphill on the right; the band is where the middle half of hikers fall. The dashed line is Tobler. Tobler peaks at 6 km/h with a sharp point. Real hikers top out around 4.2, and the top is rounded, so on everyday trail Tobler is about 20% too fast. The bottom panel uses hikes where the same person walked up and back down the same trail, so fitness and pack weight cancel out. Going down is only 8% faster on gentle grades and about 23% on steep ones; Tobler assumes 42% everywhere. And in all 17 regions, Tobler predicts worse than a simple curve fitted to the other regions. (If asked: 2,763 up-and-back pairs from 1,145 hikes; Campbell's AllTrails curve, in orange, matches near flat but is about 20% too fast on climbs steeper than 25%; on those steep climbs Tobler is actually about 18% too slow.)</a:t>
             </a:r>
             <a:endParaRPr lang="en-US" dirty="0"/>
           </a:p>
@@ -5140,7 +5140,7 @@
                   <a:schemeClr val="tx1"/>
                 </a:solidFill>
               </a:rPr>
-              <a:t>regions where Tobler predicts worse than a refitted slope curve</a:t>
+              <a:t>regions where Tobler predicts worse than a curve fitted to the other regions</a:t>
             </a:r>
             <a:endParaRPr lang="en-US" sz="1500" dirty="0"/>
           </a:p>
@@ -5154,7 +5154,7 @@
                   <a:schemeClr val="accent4"/>
                 </a:solidFill>
               </a:rPr>
-              <a:t>−12.5% overall (CRPS skill)</a:t>
+              <a:t>12.5% worse overall (CRPS score)</a:t>
             </a:r>
             <a:endParaRPr lang="en-US" sz="1500" dirty="0"/>
           </a:p>

</xml_diff>

<commit_message>
Lab deck simplified for a 5-6 min talk: one message per slide, at most two numbers each
Three slide-sized charts with large type (speed vs slope, terrain vs tags
per held-out region, region map); shorter speaker notes (~4-5 min); the
details cut from the slides are now in QA_prep.md. PDF backup updated.

Co-Authored-By: Claude Opus 5.5 <noreply@anthropic.com>
</commit_message>
<xml_diff>
--- a/meeting_plots/oct23_lab/Zhou_LabMeeting_23Oct.pptx
+++ b/meeting_plots/oct23_lab/Zhou_LabMeeting_23Oct.pptx
@@ -113,29 +113,29 @@
   <p:extLst>
     <p:ext uri="{521415D9-36F7-43E2-AB2F-B90AF26B5E84}">
       <p14:sectionLst xmlns:p14="http://schemas.microsoft.com/office/powerpoint/2010/main">
-        <p14:section name="Introduction" id="{62dd8a2a-9a49-5a2b-938f-38b80a7ad2a6}">
+        <p14:section name="Introduction" id="{7f881998-8734-1d41-334a-84f690222abd}">
           <p14:sldIdLst>
             <p14:sldId id="256"/>
           </p14:sldIdLst>
         </p14:section>
-        <p14:section name="Problem and goal" id="{77c0655e-71b5-d2c7-d04f-16981867c7aa}">
+        <p14:section name="Problem and goal" id="{682bfd78-cec6-dcd8-c678-70eb091723b0}">
           <p14:sldIdLst>
             <p14:sldId id="257"/>
             <p14:sldId id="258"/>
           </p14:sldIdLst>
         </p14:section>
-        <p14:section name="What I built" id="{55d244ad-f894-fa30-4a07-5b56a9339411}">
+        <p14:section name="Data" id="{790c32de-8408-63d5-b131-1a6870d9b38c}">
           <p14:sldIdLst>
             <p14:sldId id="259"/>
           </p14:sldIdLst>
         </p14:section>
-        <p14:section name="Findings" id="{1bb8e09b-d0df-a914-e2dc-588ad4cb067f}">
+        <p14:section name="Findings" id="{41ee531d-3375-953c-8ae0-f98808053dad}">
           <p14:sldIdLst>
             <p14:sldId id="260"/>
             <p14:sldId id="261"/>
           </p14:sldIdLst>
         </p14:section>
-        <p14:section name="Next steps" id="{254f7583-7be7-214d-9c4e-617ecee8608a}">
+        <p14:section name="Next steps" id="{dd8d1044-a34d-703f-a098-fdb9682d4286}">
           <p14:sldIdLst>
             <p14:sldId id="262"/>
           </p14:sldIdLst>
@@ -147,348 +147,6 @@
     </p:ext>
   </p:extLst>
 </p:presentation>
-</file>
-
-<file path=ppt/charts/chart1.xml><?xml version="1.0" encoding="utf-8"?>
-<c:chartSpace xmlns:c="http://schemas.openxmlformats.org/drawingml/2006/chart" xmlns:a="http://schemas.openxmlformats.org/drawingml/2006/main" xmlns:r="http://schemas.openxmlformats.org/officeDocument/2006/relationships">
-  <c:date1904 val="0"/>
-  <c:roundedCorners val="1"/>
-  <c:chart>
-    <c:title>
-      <c:tx>
-        <c:rich>
-          <a:bodyPr/>
-          <a:lstStyle/>
-          <a:p>
-            <a:pPr>
-              <a:defRPr sz="1400" b="0" i="0" u="none" strike="noStrike">
-                <a:solidFill>
-                  <a:schemeClr val="tx2"/>
-                </a:solidFill>
-                <a:latin typeface="+mn-lt"/>
-              </a:defRPr>
-            </a:pPr>
-            <a:r>
-              <a:rPr sz="1400" b="0" i="0" u="none" strike="noStrike">
-                <a:solidFill>
-                  <a:schemeClr val="tx2"/>
-                </a:solidFill>
-                <a:latin typeface="+mn-lt"/>
-              </a:rPr>
-              <a:t>Walked trail with a difficulty tag (sac_scale), by region</a:t>
-            </a:r>
-          </a:p>
-        </c:rich>
-      </c:tx>
-      <c:layout/>
-      <c:overlay val="0"/>
-    </c:title>
-    <c:autoTitleDeleted val="0"/>
-    <c:plotArea>
-      <c:layout/>
-      <c:barChart>
-        <c:barDir val="bar"/>
-        <c:grouping val="clustered"/>
-        <c:varyColors val="0"/>
-        <c:ser>
-          <c:idx val="0"/>
-          <c:order val="0"/>
-          <c:tx>
-            <c:strRef>
-              <c:f>Sheet1!$B$1</c:f>
-              <c:strCache>
-                <c:ptCount val="1"/>
-                <c:pt idx="0">
-                  <c:v>Walked trail with sac_scale (%)</c:v>
-                </c:pt>
-              </c:strCache>
-            </c:strRef>
-          </c:tx>
-          <c:spPr>
-            <a:solidFill>
-              <a:schemeClr val="accent2"/>
-            </a:solidFill>
-            <a:effectLst/>
-          </c:spPr>
-          <c:invertIfNegative val="0"/>
-          <c:dLbls>
-            <c:numFmt formatCode="0.0&quot;%&quot;" sourceLinked="0"/>
-            <c:txPr>
-              <a:bodyPr/>
-              <a:lstStyle/>
-              <a:p>
-                <a:pPr>
-                  <a:defRPr b="0" i="0" strike="noStrike" sz="1000" u="none">
-                    <a:solidFill>
-                      <a:schemeClr val="tx1"/>
-                    </a:solidFill>
-                    <a:latin typeface="+mn-lt"/>
-                  </a:defRPr>
-                </a:pPr>
-              </a:p>
-            </c:txPr>
-            <c:showLegendKey val="0"/>
-            <c:showVal val="1"/>
-            <c:showCatName val="0"/>
-            <c:showSerName val="0"/>
-            <c:showPercent val="0"/>
-            <c:showBubbleSize val="0"/>
-            <c:showLeaderLines val="0"/>
-          </c:dLbls>
-          <c:cat>
-            <c:multiLvlStrRef>
-              <c:f>Sheet1!$A$2:$A$18</c:f>
-              <c:multiLvlStrCache>
-                <c:ptCount val="17"/>
-                <c:lvl>
-                  <c:pt idx="0">
-                    <c:v>Green Mtns</c:v>
-                  </c:pt>
-                  <c:pt idx="1">
-                    <c:v>Bay Area</c:v>
-                  </c:pt>
-                  <c:pt idx="2">
-                    <c:v>Smokies</c:v>
-                  </c:pt>
-                  <c:pt idx="3">
-                    <c:v>Col. Gorge</c:v>
-                  </c:pt>
-                  <c:pt idx="4">
-                    <c:v>Tahoe</c:v>
-                  </c:pt>
-                  <c:pt idx="5">
-                    <c:v>Yosemite</c:v>
-                  </c:pt>
-                  <c:pt idx="6">
-                    <c:v>Pisgah</c:v>
-                  </c:pt>
-                  <c:pt idx="7">
-                    <c:v>Shenandoah</c:v>
-                  </c:pt>
-                  <c:pt idx="8">
-                    <c:v>Cascades</c:v>
-                  </c:pt>
-                  <c:pt idx="9">
-                    <c:v>San Gabriels</c:v>
-                  </c:pt>
-                  <c:pt idx="10">
-                    <c:v>White Mtns</c:v>
-                  </c:pt>
-                  <c:pt idx="11">
-                    <c:v>Front Range</c:v>
-                  </c:pt>
-                  <c:pt idx="12">
-                    <c:v>Olympic</c:v>
-                  </c:pt>
-                  <c:pt idx="13">
-                    <c:v>Catskills</c:v>
-                  </c:pt>
-                  <c:pt idx="14">
-                    <c:v>North Shore</c:v>
-                  </c:pt>
-                  <c:pt idx="15">
-                    <c:v>Wasatch</c:v>
-                  </c:pt>
-                  <c:pt idx="16">
-                    <c:v>Adirondacks</c:v>
-                  </c:pt>
-                </c:lvl>
-              </c:multiLvlStrCache>
-            </c:multiLvlStrRef>
-          </c:cat>
-          <c:val>
-            <c:numRef>
-              <c:f>Sheet1!$B$2:$B$18</c:f>
-              <c:numCache>
-                <c:formatCode>General</c:formatCode>
-                <c:ptCount val="17"/>
-                <c:pt idx="0">
-                  <c:v>1.5</c:v>
-                </c:pt>
-                <c:pt idx="1">
-                  <c:v>4.9</c:v>
-                </c:pt>
-                <c:pt idx="2">
-                  <c:v>5.9</c:v>
-                </c:pt>
-                <c:pt idx="3">
-                  <c:v>6.7</c:v>
-                </c:pt>
-                <c:pt idx="4">
-                  <c:v>13.8</c:v>
-                </c:pt>
-                <c:pt idx="5">
-                  <c:v>30.3</c:v>
-                </c:pt>
-                <c:pt idx="6">
-                  <c:v>31.4</c:v>
-                </c:pt>
-                <c:pt idx="7">
-                  <c:v>32.9</c:v>
-                </c:pt>
-                <c:pt idx="8">
-                  <c:v>44.1</c:v>
-                </c:pt>
-                <c:pt idx="9">
-                  <c:v>46.3</c:v>
-                </c:pt>
-                <c:pt idx="10">
-                  <c:v>50.7</c:v>
-                </c:pt>
-                <c:pt idx="11">
-                  <c:v>52</c:v>
-                </c:pt>
-                <c:pt idx="12">
-                  <c:v>52.2</c:v>
-                </c:pt>
-                <c:pt idx="13">
-                  <c:v>61.5</c:v>
-                </c:pt>
-                <c:pt idx="14">
-                  <c:v>62.7</c:v>
-                </c:pt>
-                <c:pt idx="15">
-                  <c:v>86.3</c:v>
-                </c:pt>
-                <c:pt idx="16">
-                  <c:v>96.2</c:v>
-                </c:pt>
-              </c:numCache>
-            </c:numRef>
-          </c:val>
-        </c:ser>
-        <c:dLbls>
-          <c:numFmt formatCode="0.0&quot;%&quot;" sourceLinked="0"/>
-          <c:txPr>
-            <a:bodyPr/>
-            <a:lstStyle/>
-            <a:p>
-              <a:pPr>
-                <a:defRPr b="0" i="0" strike="noStrike" sz="1000" u="none">
-                  <a:solidFill>
-                    <a:schemeClr val="tx1"/>
-                  </a:solidFill>
-                  <a:latin typeface="+mn-lt"/>
-                </a:defRPr>
-              </a:pPr>
-            </a:p>
-          </c:txPr>
-          <c:showLegendKey val="0"/>
-          <c:showVal val="1"/>
-          <c:showCatName val="0"/>
-          <c:showSerName val="0"/>
-          <c:showPercent val="0"/>
-          <c:showBubbleSize val="0"/>
-          <c:showLeaderLines val="0"/>
-        </c:dLbls>
-        <c:gapWidth val="45"/>
-        <c:overlap val="0"/>
-        <c:axId val="2094734554"/>
-        <c:axId val="2094734552"/>
-        <c:axId val="2094734556"/>
-      </c:barChart>
-      <c:catAx>
-        <c:axId val="2094734554"/>
-        <c:scaling>
-          <c:orientation val="minMax"/>
-        </c:scaling>
-        <c:delete val="0"/>
-        <c:axPos val="l"/>
-        <c:numFmt formatCode="General" sourceLinked="1"/>
-        <c:majorTickMark val="out"/>
-        <c:minorTickMark val="none"/>
-        <c:tickLblPos val="nextTo"/>
-        <c:spPr>
-          <a:ln w="12700" cap="flat">
-            <a:noFill/>
-            <a:prstDash val="solid"/>
-            <a:round/>
-          </a:ln>
-        </c:spPr>
-        <c:txPr>
-          <a:bodyPr/>
-          <a:lstStyle/>
-          <a:p>
-            <a:pPr>
-              <a:defRPr sz="1100" b="0" i="0" u="none" strike="noStrike">
-                <a:solidFill>
-                  <a:schemeClr val="tx1"/>
-                </a:solidFill>
-                <a:latin typeface="+mn-lt"/>
-              </a:defRPr>
-            </a:pPr>
-            <a:endParaRPr lang="en-US"/>
-          </a:p>
-        </c:txPr>
-        <c:crossAx val="2094734552"/>
-        <c:crosses val="autoZero"/>
-        <c:auto val="1"/>
-        <c:lblAlgn val="ctr"/>
-        <c:noMultiLvlLbl val="1"/>
-      </c:catAx>
-      <c:valAx>
-        <c:axId val="2094734552"/>
-        <c:scaling>
-          <c:orientation val="minMax"/>
-          <c:max val="112"/>
-          <c:min val="0"/>
-        </c:scaling>
-        <c:delete val="1"/>
-        <c:axPos val="b"/>
-        <c:numFmt formatCode="General" sourceLinked="0"/>
-        <c:majorTickMark val="out"/>
-        <c:minorTickMark val="none"/>
-        <c:tickLblPos val="low"/>
-        <c:spPr>
-          <a:ln w="12700" cap="flat">
-            <a:solidFill>
-              <a:srgbClr val="888888"/>
-            </a:solidFill>
-            <a:prstDash val="solid"/>
-            <a:round/>
-          </a:ln>
-        </c:spPr>
-        <c:txPr>
-          <a:bodyPr/>
-          <a:lstStyle/>
-          <a:p>
-            <a:pPr>
-              <a:defRPr sz="1200" b="0" i="0" u="none" strike="noStrike">
-                <a:solidFill>
-                  <a:srgbClr val="000000"/>
-                </a:solidFill>
-                <a:latin typeface="Arial"/>
-              </a:defRPr>
-            </a:pPr>
-            <a:endParaRPr lang="en-US"/>
-          </a:p>
-        </c:txPr>
-        <c:crossAx val="2094734554"/>
-        <c:crosses val="autoZero"/>
-        <c:crossBetween val="between"/>
-      </c:valAx>
-      <c:spPr>
-        <a:noFill/>
-        <a:ln>
-          <a:noFill/>
-        </a:ln>
-        <a:effectLst/>
-      </c:spPr>
-    </c:plotArea>
-    <c:plotVisOnly val="1"/>
-    <c:dispBlanksAs val="span"/>
-  </c:chart>
-  <c:spPr>
-    <a:noFill/>
-    <a:ln>
-      <a:noFill/>
-    </a:ln>
-    <a:effectLst/>
-  </c:spPr>
-  <c:externalData r:id="rId1">
-    <c:autoUpdate val="0"/>
-  </c:externalData>
-</c:chartSpace>
 </file>
 
 <file path=ppt/notesMasters/notesMaster1.xml><?xml version="1.0" encoding="utf-8"?>
@@ -886,7 +544,7 @@
           <a:p>
             <a:r>
               <a:rPr lang="en-US" dirty="0"/>
-              <a:t>Hi everyone, I'm Brian. With Danni and Tianyi I'm working on predicting how fast people hike, from public GPS traces and remote sensing. In five minutes: the problem, what's been done, what I built, two findings, and next steps.</a:t>
+              <a:t>Hi, I'm Brian. With Danni and Tianyi I'm studying how fast people hike, and whether lidar and other remote sensing can predict it better than the trail map. In five minutes: the problem, the data, two results, and what's next.</a:t>
             </a:r>
             <a:endParaRPr lang="en-US" dirty="0"/>
           </a:p>
@@ -974,7 +632,7 @@
           <a:p>
             <a:r>
               <a:rPr lang="en-US" dirty="0"/>
-              <a:t>Today, if software estimates how long a hike takes, it usually uses Tobler's formula from 1993. v is walking speed, s is the slope. It says you're fastest, 6 km/h, on a gentle downhill, and slower the steeper it gets: about 5 km/h on flat ground, 2.5 on a 20% climb. There are three problems. It was fit to numbers in a cartography textbook, not to real hikes. It's one curve for every trail, so a rocky scramble and a smooth path get the same speed. And it's still what GIS tools use for search and rescue, wildfire escape routes and trail apps. Could the trail map fix this? OpenStreetMap has a difficulty grade called sac_scale, from the Swiss Alpine Club: from easy 'hiking' up to 'alpine hiking'. But this chart shows how much of the trail actually has it: 96% in the Adirondacks, under 2% in the Green Mountains. For most trails, the map can't tell you how hard they are.</a:t>
+              <a:t>Software that estimates hiking time, like GIS travel-time tools, mostly still uses Tobler's formula from 1993. Speed depends only on slope: fastest, about 6 km/h, on a gentle downhill. Two problems: it was fit to a textbook table, not to real hikes, and slope is its only input. Could the trail map fill the gap? OpenStreetMap has a difficulty tag, but it covers 96% of walked trail in the Adirondacks and only 1.5% in the Green Mountains. (If asked: the tag is sac_scale, the Swiss Alpine Club's grade; flat ground is 5 km/h in Tobler, a 20% climb 2.5 km/h.)</a:t>
             </a:r>
             <a:endParaRPr lang="en-US" dirty="0"/>
           </a:p>
@@ -1062,7 +720,7 @@
           <a:p>
             <a:r>
               <a:rPr lang="en-US" dirty="0"/>
-              <a:t>How have people tackled this before? Some refit the slope curve with data from fitness apps like Strava and AllTrails, and found Tobler is too fast, but they still use slope only. Others add more inputs: trail types and lidar in England, weather and other factors in Hong Kong. But they test on the same area they trained on, so the test trails sit right next to the training trails. STRIDE builds a lidar model from timed field walks, and our lab's RasterNet predicts road speed from lidar and aerial imagery. What's missing: nobody has checked whether these models work in a region they've never seen, which is where predictions are actually needed, and nobody has compared the map's tags with remote sensing head to head. So our goal: predict the speed on every 50 m of trail, with a range, from what's visible from above, and test it on a region the model never saw: train on 16 regions, test on the 17th. We compare four models that learn the same way but see different inputs: slope only, the map's tags, remote sensing, or both.</a:t>
+              <a:t>Earlier work either refits the slope curve with data from fitness apps, or adds map and lidar inputs, but it always tests in the same area it trained on. The real use is a place with no data, so that's our test: train on 16 regions, predict the 17th, and repeat for every region. We compare four models that learn the same way but see different inputs: slope only, the map's tags, remote sensing, or both. (If asked: STRIDE is a lidar walking-speed model from timed field walks; RasterNet is our lab's road-speed model from lidar and overhead imagery.)</a:t>
             </a:r>
             <a:endParaRPr lang="en-US" dirty="0"/>
           </a:p>
@@ -1150,7 +808,7 @@
           <a:p>
             <a:r>
               <a:rPr lang="en-US" dirty="0"/>
-              <a:t>Here's the data. I used public GPS tracks that hikers upload to OpenStreetMap, from 17 mountain regions in the US and Canada; bigger circles mean more hours of hiking. For each track, the pipeline at the bottom removes GPS glitches and stops, because we want walking speed, not lunch breaks. Then it snaps the points onto the trail map, the way a car's navigation snaps you to the road, and cuts the hike into 50-meter pieces. Each piece gets its speed and slope, plus what the map says about the trail and what lidar and satellites see. In total that's 290,640 pieces from about 2,000 hikes: 14,500 km and 4,700 hours of walking. The inset is the White Mountains, with every piece colored by speed. (If asked: a group that uploads several tracks of the same walk counts as one hike; snapping uses a hidden Markov model; 85 to 99% of points match, depending on the region.)</a:t>
+              <a:t>The data are public GPS tracks that hikers upload to OpenStreetMap, from 17 mountain regions in the US and Canada; bigger circles mean more hours of hiking. I clean each track, remove stops, snap it to the trail map, and cut it into 50-meter pieces, each with a measured speed. That's about 2,000 hikes and 290,000 pieces. (If asked: 14,500 km and 4,700 hours of walking; snapping uses a hidden Markov model, and 85 to 99% of points match, by region.)</a:t>
             </a:r>
             <a:endParaRPr lang="en-US" dirty="0"/>
           </a:p>
@@ -1238,7 +896,7 @@
           <a:p>
             <a:r>
               <a:rPr lang="en-US" dirty="0"/>
-              <a:t>First finding. Each gray dot is the typical speed of real hikers at one slope, downhill on the left, uphill on the right; the band is where the middle half of hikers fall. The dashed line is Tobler. Tobler peaks at 6 km/h with a sharp point. Real hikers top out around 4.2, and the top is rounded, so on everyday trail Tobler is about 20% too fast. The bottom panel uses hikes where the same person walked up and back down the same trail, so fitness and pack weight cancel out. Going down is only 8% faster on gentle grades and about 23% on steep ones; Tobler assumes 42% everywhere. And in all 17 regions, Tobler predicts worse than a simple curve fitted to the other regions. (If asked: 2,763 up-and-back pairs from 1,145 hikes; Campbell's AllTrails curve, in orange, matches near flat but is about 20% too fast on climbs steeper than 25%; on those steep climbs Tobler is actually about 18% too slow.)</a:t>
+              <a:t>First result. The dots are real hikers' typical speed at each slope, downhill on the left, uphill on the right; the dashed line is Tobler. Real hikers top out around 4.2 km/h, not 6, so on everyday trail Tobler is about 20% too fast. And it predicts worse than a simple curve fitted to real hikes in all 17 regions. (If asked: going down is 8 to 23% faster than going up for the same hiker on the same trail, while Tobler assumes 42%; overall Tobler scores 12.5% worse.)</a:t>
             </a:r>
             <a:endParaRPr lang="en-US" dirty="0"/>
           </a:p>
@@ -1326,7 +984,7 @@
           <a:p>
             <a:r>
               <a:rPr lang="en-US" dirty="0"/>
-              <a:t>The main result. Each bar is a model's skill over a slope-only curve: light bars are new hikes in regions the model knows, dark bars are regions it never saw. Terrain from elevation keeps its gain in new regions, about 2 to 3%, and on the right it beats the map tags in 16 of 17 held-out regions. Tags lose most of their gain. This holds for newer hikes, any GPS rate, whole zones held out, and even with all of a region's hikers removed from training. Vegetation and satellite embeddings help inside a region but don't transfer.</a:t>
+              <a:t>The main result. Each row is one region the model never saw; further right means better predictions than slope alone. Blue is terrain from elevation data, orange is the map's tags. Terrain wins in 16 of 17 regions: about 2 to 3% better than slope alone, while the tags gain under 1%. (If asked: the score is CRPS on the predicted speed distribution, and RMSE agrees; it holds with all of a region's hikers removed from training; vegetation and satellite embeddings help inside a region but don't transfer.)</a:t>
             </a:r>
             <a:endParaRPr lang="en-US" dirty="0"/>
           </a:p>
@@ -1414,7 +1072,7 @@
           <a:p>
             <a:r>
               <a:rPr lang="en-US" dirty="0"/>
-              <a:t>Where we are: the dataset, the covariates, the four-model comparison and the curves are done, and there's a first paper draft. Next, in weeks 10 and 11, the plan's main model: Tobler's form with its constants learned from the terrain, plus a variance head, in PyTorch. That's Gate 2 on November 6: does it beat boosted trees? Week 12: an imagery arm with NAIP and a frozen pretrained encoder. Then the full draft and IGARSS in January. One question for you: which pretrained aerial-imagery encoder would you use for that?</a:t>
+              <a:t>So far: the dataset, the four-model comparison, and a first paper draft. Next, in weeks 10 and 11: keep Tobler's shape but learn its constants from the terrain, with an uncertainty estimate. Week 12: add aerial imagery. Then the paper for IGARSS in January. One question for you: which pretrained encoder would you use for 1 m aerial imagery along trails? (If asked: the check on 6 November is whether that model beats boosted trees.)</a:t>
             </a:r>
             <a:endParaRPr lang="en-US" dirty="0"/>
           </a:p>
@@ -2472,7 +2130,7 @@
                   <a:schemeClr val="accent5"/>
                 </a:solidFill>
               </a:rPr>
-              <a:t>Background: 10 m contours of Tuckerman and Huntington ravines, Mt Washington, NH, from USGS 3DEP 1 m lidar.  Slides prepared with help from Claude (Anthropic).</a:t>
+              <a:t>Background: lidar contours of Mt Washington, NH (USGS 3DEP).  Slides made with help from Claude (Anthropic).</a:t>
             </a:r>
             <a:endParaRPr lang="en-US" sz="1000" dirty="0"/>
           </a:p>
@@ -2552,12 +2210,12 @@
         </p:nvSpPr>
         <p:spPr>
           <a:xfrm>
-            <a:off x="548640" y="1325880"/>
-            <a:ext cx="5486400" cy="1737360"/>
+            <a:off x="548640" y="1371600"/>
+            <a:ext cx="5669280" cy="1965960"/>
           </a:xfrm>
           <a:prstGeom prst="roundRect">
             <a:avLst>
-              <a:gd name="adj" fmla="val 5263"/>
+              <a:gd name="adj" fmla="val 4651"/>
             </a:avLst>
           </a:prstGeom>
           <a:solidFill>
@@ -2574,8 +2232,8 @@
         </p:nvSpPr>
         <p:spPr>
           <a:xfrm>
-            <a:off x="822960" y="1481328"/>
-            <a:ext cx="4937760" cy="274320"/>
+            <a:off x="822960" y="1554480"/>
+            <a:ext cx="5120640" cy="274320"/>
           </a:xfrm>
           <a:prstGeom prst="rect">
             <a:avLst/>
@@ -2610,8 +2268,8 @@
         </p:nvSpPr>
         <p:spPr>
           <a:xfrm>
-            <a:off x="822960" y="1810512"/>
-            <a:ext cx="4937760" cy="685800"/>
+            <a:off x="822960" y="1874520"/>
+            <a:ext cx="5120640" cy="777240"/>
           </a:xfrm>
           <a:prstGeom prst="rect">
             <a:avLst/>
@@ -2627,7 +2285,7 @@
               <a:buNone/>
             </a:pPr>
             <a:r>
-              <a:rPr lang="en-US" sz="3000" dirty="0">
+              <a:rPr lang="en-US" sz="3200" dirty="0">
                 <a:solidFill>
                   <a:schemeClr val="tx1"/>
                 </a:solidFill>
@@ -2641,7 +2299,7 @@
               <a:buNone/>
             </a:pPr>
             <a:r>
-              <a:rPr lang="en-US" sz="3000" baseline="30000" dirty="0">
+              <a:rPr lang="en-US" sz="3200" baseline="30000" dirty="0">
                 <a:solidFill>
                   <a:schemeClr val="tx1"/>
                 </a:solidFill>
@@ -2662,7 +2320,7 @@
               </a:rPr>
               <a:t>   km/h</a:t>
             </a:r>
-            <a:endParaRPr lang="en-US" sz="3000" dirty="0"/>
+            <a:endParaRPr lang="en-US" sz="3200" dirty="0"/>
           </a:p>
         </p:txBody>
       </p:sp>
@@ -2674,8 +2332,8 @@
         </p:nvSpPr>
         <p:spPr>
           <a:xfrm>
-            <a:off x="822960" y="2514600"/>
-            <a:ext cx="4937760" cy="457200"/>
+            <a:off x="822960" y="2743200"/>
+            <a:ext cx="5120640" cy="365760"/>
           </a:xfrm>
           <a:prstGeom prst="rect">
             <a:avLst/>
@@ -2691,25 +2349,14 @@
               <a:buNone/>
             </a:pPr>
             <a:r>
-              <a:rPr lang="en-US" sz="1400" dirty="0">
-                <a:solidFill>
-                  <a:schemeClr val="tx1"/>
-                </a:solidFill>
-              </a:rPr>
-              <a:t>s = slope (0.10 = 10% uphill).  </a:t>
-            </a:r>
-            <a:pPr indent="0" marL="0">
-              <a:buNone/>
-            </a:pPr>
-            <a:r>
-              <a:rPr lang="en-US" sz="1400" dirty="0">
+              <a:rPr lang="en-US" sz="1600" dirty="0">
                 <a:solidFill>
                   <a:schemeClr val="accent4"/>
                 </a:solidFill>
               </a:rPr>
-              <a:t>Fastest at a gentle downhill: 6 km/h. Flat: 5.0 km/h. 20% climb: 2.5 km/h.</a:t>
-            </a:r>
-            <a:endParaRPr lang="en-US" sz="1400" dirty="0"/>
+              <a:t>s = slope.  Fastest, 6 km/h, on a gentle downhill.</a:t>
+            </a:r>
+            <a:endParaRPr lang="en-US" sz="1600" dirty="0"/>
           </a:p>
         </p:txBody>
       </p:sp>
@@ -2721,8 +2368,8 @@
         </p:nvSpPr>
         <p:spPr>
           <a:xfrm>
-            <a:off x="566928" y="3374136"/>
-            <a:ext cx="164592" cy="164592"/>
+            <a:off x="566928" y="3858768"/>
+            <a:ext cx="182880" cy="182880"/>
           </a:xfrm>
           <a:prstGeom prst="ellipse">
             <a:avLst/>
@@ -2741,8 +2388,8 @@
         </p:nvSpPr>
         <p:spPr>
           <a:xfrm>
-            <a:off x="914400" y="3291840"/>
-            <a:ext cx="5120640" cy="658368"/>
+            <a:off x="960120" y="3749040"/>
+            <a:ext cx="5257800" cy="822960"/>
           </a:xfrm>
           <a:prstGeom prst="rect">
             <a:avLst/>
@@ -2758,28 +2405,28 @@
               <a:buNone/>
             </a:pPr>
             <a:r>
-              <a:rPr lang="en-US" sz="1600" b="1" dirty="0">
+              <a:rPr lang="en-US" sz="2000" b="1" dirty="0">
                 <a:solidFill>
                   <a:schemeClr val="tx2"/>
                 </a:solidFill>
               </a:rPr>
-              <a:t>Fit to figures in a Swiss cartography textbook</a:t>
-            </a:r>
-            <a:endParaRPr lang="en-US" sz="1600" dirty="0"/>
-          </a:p>
-          <a:p>
-            <a:pPr indent="0" marL="0">
-              <a:buNone/>
-            </a:pPr>
-            <a:r>
-              <a:rPr lang="en-US" sz="1400" dirty="0">
-                <a:solidFill>
-                  <a:schemeClr val="tx1"/>
-                </a:solidFill>
-              </a:rPr>
-              <a:t>not to observed hikes</a:t>
-            </a:r>
-            <a:endParaRPr lang="en-US" sz="1600" dirty="0"/>
+              <a:t>Fit to a textbook table</a:t>
+            </a:r>
+            <a:endParaRPr lang="en-US" sz="2000" dirty="0"/>
+          </a:p>
+          <a:p>
+            <a:pPr indent="0" marL="0">
+              <a:buNone/>
+            </a:pPr>
+            <a:r>
+              <a:rPr lang="en-US" sz="1600" dirty="0">
+                <a:solidFill>
+                  <a:schemeClr val="accent4"/>
+                </a:solidFill>
+              </a:rPr>
+              <a:t>not to real hikes</a:t>
+            </a:r>
+            <a:endParaRPr lang="en-US" sz="2000" dirty="0"/>
           </a:p>
         </p:txBody>
       </p:sp>
@@ -2791,8 +2438,8 @@
         </p:nvSpPr>
         <p:spPr>
           <a:xfrm>
-            <a:off x="566928" y="4087368"/>
-            <a:ext cx="164592" cy="164592"/>
+            <a:off x="566928" y="4956048"/>
+            <a:ext cx="182880" cy="182880"/>
           </a:xfrm>
           <a:prstGeom prst="ellipse">
             <a:avLst/>
@@ -2811,8 +2458,8 @@
         </p:nvSpPr>
         <p:spPr>
           <a:xfrm>
-            <a:off x="914400" y="4005072"/>
-            <a:ext cx="5120640" cy="658368"/>
+            <a:off x="960120" y="4846320"/>
+            <a:ext cx="5257800" cy="822960"/>
           </a:xfrm>
           <a:prstGeom prst="rect">
             <a:avLst/>
@@ -2828,186 +2475,311 @@
               <a:buNone/>
             </a:pPr>
             <a:r>
+              <a:rPr lang="en-US" sz="2000" b="1" dirty="0">
+                <a:solidFill>
+                  <a:schemeClr val="tx2"/>
+                </a:solidFill>
+              </a:rPr>
+              <a:t>Slope is its only input</a:t>
+            </a:r>
+            <a:endParaRPr lang="en-US" sz="2000" dirty="0"/>
+          </a:p>
+          <a:p>
+            <a:pPr indent="0" marL="0">
+              <a:buNone/>
+            </a:pPr>
+            <a:r>
+              <a:rPr lang="en-US" sz="1600" dirty="0">
+                <a:solidFill>
+                  <a:schemeClr val="accent4"/>
+                </a:solidFill>
+              </a:rPr>
+              <a:t>rocks, roots and brush are ignored</a:t>
+            </a:r>
+            <a:endParaRPr lang="en-US" sz="2000" dirty="0"/>
+          </a:p>
+        </p:txBody>
+      </p:sp>
+      <p:sp>
+        <p:nvSpPr>
+          <p:cNvPr id="11" name="Tag card"/>
+          <p:cNvSpPr/>
+          <p:nvPr/>
+        </p:nvSpPr>
+        <p:spPr>
+          <a:xfrm>
+            <a:off x="6675120" y="1371600"/>
+            <a:ext cx="4967935" cy="4389120"/>
+          </a:xfrm>
+          <a:prstGeom prst="roundRect">
+            <a:avLst>
+              <a:gd name="adj" fmla="val 2083"/>
+            </a:avLst>
+          </a:prstGeom>
+          <a:solidFill>
+            <a:schemeClr val="bg2"/>
+          </a:solidFill>
+          <a:ln/>
+        </p:spPr>
+      </p:sp>
+      <p:sp>
+        <p:nvSpPr>
+          <p:cNvPr id="12" name="Tag card label"/>
+          <p:cNvSpPr txBox="1"/>
+          <p:nvPr/>
+        </p:nvSpPr>
+        <p:spPr>
+          <a:xfrm>
+            <a:off x="6995160" y="1554480"/>
+            <a:ext cx="4327855" cy="274320"/>
+          </a:xfrm>
+          <a:prstGeom prst="rect">
+            <a:avLst/>
+          </a:prstGeom>
+          <a:noFill/>
+          <a:ln/>
+        </p:spPr>
+        <p:txBody>
+          <a:bodyPr wrap="square" lIns="0" tIns="0" rIns="0" bIns="0" rtlCol="0" anchor="t"/>
+          <a:lstStyle/>
+          <a:p>
+            <a:pPr indent="0" marL="0">
+              <a:buNone/>
+            </a:pPr>
+            <a:r>
+              <a:rPr lang="en-US" sz="1200" b="1" spc="150" kern="0" dirty="0">
+                <a:solidFill>
+                  <a:schemeClr val="accent3"/>
+                </a:solidFill>
+              </a:rPr>
+              <a:t>CAN THE TRAIL MAP HELP?</a:t>
+            </a:r>
+            <a:endParaRPr lang="en-US" sz="1200" dirty="0"/>
+          </a:p>
+        </p:txBody>
+      </p:sp>
+      <p:sp>
+        <p:nvSpPr>
+          <p:cNvPr id="13" name="Tag card lead"/>
+          <p:cNvSpPr txBox="1"/>
+          <p:nvPr/>
+        </p:nvSpPr>
+        <p:spPr>
+          <a:xfrm>
+            <a:off x="6995160" y="1874520"/>
+            <a:ext cx="4327855" cy="548640"/>
+          </a:xfrm>
+          <a:prstGeom prst="rect">
+            <a:avLst/>
+          </a:prstGeom>
+          <a:noFill/>
+          <a:ln/>
+        </p:spPr>
+        <p:txBody>
+          <a:bodyPr wrap="square" lIns="0" tIns="0" rIns="0" bIns="0" rtlCol="0" anchor="t"/>
+          <a:lstStyle/>
+          <a:p>
+            <a:pPr indent="0" marL="0">
+              <a:buNone/>
+            </a:pPr>
+            <a:r>
+              <a:rPr lang="en-US" sz="1600" dirty="0">
+                <a:solidFill>
+                  <a:schemeClr val="tx1"/>
+                </a:solidFill>
+              </a:rPr>
+              <a:t>Share of walked trail with OpenStreetMap's difficulty tag:</a:t>
+            </a:r>
+            <a:endParaRPr lang="en-US" sz="1600" dirty="0"/>
+          </a:p>
+        </p:txBody>
+      </p:sp>
+      <p:sp>
+        <p:nvSpPr>
+          <p:cNvPr id="14" name="Most tagged value"/>
+          <p:cNvSpPr txBox="1"/>
+          <p:nvPr/>
+        </p:nvSpPr>
+        <p:spPr>
+          <a:xfrm>
+            <a:off x="6995160" y="2468880"/>
+            <a:ext cx="4327855" cy="868680"/>
+          </a:xfrm>
+          <a:prstGeom prst="rect">
+            <a:avLst/>
+          </a:prstGeom>
+          <a:noFill/>
+          <a:ln/>
+        </p:spPr>
+        <p:txBody>
+          <a:bodyPr wrap="square" lIns="0" tIns="0" rIns="0" bIns="0" rtlCol="0" anchor="t"/>
+          <a:lstStyle/>
+          <a:p>
+            <a:pPr indent="0" marL="0">
+              <a:buNone/>
+            </a:pPr>
+            <a:r>
+              <a:rPr lang="en-US" sz="5400" b="1" dirty="0">
+                <a:solidFill>
+                  <a:schemeClr val="accent2"/>
+                </a:solidFill>
+                <a:latin typeface="+mj-lt" pitchFamily="34" charset="0"/>
+                <a:ea typeface="+mj-lt" pitchFamily="34" charset="-122"/>
+                <a:cs typeface="+mj-lt" pitchFamily="34" charset="-120"/>
+              </a:rPr>
+              <a:t>96%</a:t>
+            </a:r>
+            <a:endParaRPr lang="en-US" sz="5400" dirty="0"/>
+          </a:p>
+        </p:txBody>
+      </p:sp>
+      <p:sp>
+        <p:nvSpPr>
+          <p:cNvPr id="15" name="Most tagged label"/>
+          <p:cNvSpPr txBox="1"/>
+          <p:nvPr/>
+        </p:nvSpPr>
+        <p:spPr>
+          <a:xfrm>
+            <a:off x="6995160" y="3337560"/>
+            <a:ext cx="4327855" cy="685800"/>
+          </a:xfrm>
+          <a:prstGeom prst="rect">
+            <a:avLst/>
+          </a:prstGeom>
+          <a:noFill/>
+          <a:ln/>
+        </p:spPr>
+        <p:txBody>
+          <a:bodyPr wrap="square" lIns="0" tIns="0" rIns="0" bIns="0" rtlCol="0" anchor="t"/>
+          <a:lstStyle/>
+          <a:p>
+            <a:pPr indent="0" marL="0">
+              <a:buNone/>
+            </a:pPr>
+            <a:r>
+              <a:rPr lang="en-US" sz="1500" dirty="0">
+                <a:solidFill>
+                  <a:schemeClr val="tx1"/>
+                </a:solidFill>
+              </a:rPr>
+              <a:t>Adirondacks</a:t>
+            </a:r>
+            <a:endParaRPr lang="en-US" sz="1500" dirty="0"/>
+          </a:p>
+        </p:txBody>
+      </p:sp>
+      <p:sp>
+        <p:nvSpPr>
+          <p:cNvPr id="16" name="Least tagged value"/>
+          <p:cNvSpPr txBox="1"/>
+          <p:nvPr/>
+        </p:nvSpPr>
+        <p:spPr>
+          <a:xfrm>
+            <a:off x="6995160" y="3703320"/>
+            <a:ext cx="4327855" cy="868680"/>
+          </a:xfrm>
+          <a:prstGeom prst="rect">
+            <a:avLst/>
+          </a:prstGeom>
+          <a:noFill/>
+          <a:ln/>
+        </p:spPr>
+        <p:txBody>
+          <a:bodyPr wrap="square" lIns="0" tIns="0" rIns="0" bIns="0" rtlCol="0" anchor="t"/>
+          <a:lstStyle/>
+          <a:p>
+            <a:pPr indent="0" marL="0">
+              <a:buNone/>
+            </a:pPr>
+            <a:r>
+              <a:rPr lang="en-US" sz="5400" b="1" dirty="0">
+                <a:solidFill>
+                  <a:schemeClr val="accent2"/>
+                </a:solidFill>
+                <a:latin typeface="+mj-lt" pitchFamily="34" charset="0"/>
+                <a:ea typeface="+mj-lt" pitchFamily="34" charset="-122"/>
+                <a:cs typeface="+mj-lt" pitchFamily="34" charset="-120"/>
+              </a:rPr>
+              <a:t>1.5%</a:t>
+            </a:r>
+            <a:endParaRPr lang="en-US" sz="5400" dirty="0"/>
+          </a:p>
+        </p:txBody>
+      </p:sp>
+      <p:sp>
+        <p:nvSpPr>
+          <p:cNvPr id="17" name="Least tagged label"/>
+          <p:cNvSpPr txBox="1"/>
+          <p:nvPr/>
+        </p:nvSpPr>
+        <p:spPr>
+          <a:xfrm>
+            <a:off x="6995160" y="4572000"/>
+            <a:ext cx="4327855" cy="685800"/>
+          </a:xfrm>
+          <a:prstGeom prst="rect">
+            <a:avLst/>
+          </a:prstGeom>
+          <a:noFill/>
+          <a:ln/>
+        </p:spPr>
+        <p:txBody>
+          <a:bodyPr wrap="square" lIns="0" tIns="0" rIns="0" bIns="0" rtlCol="0" anchor="t"/>
+          <a:lstStyle/>
+          <a:p>
+            <a:pPr indent="0" marL="0">
+              <a:buNone/>
+            </a:pPr>
+            <a:r>
+              <a:rPr lang="en-US" sz="1500" dirty="0">
+                <a:solidFill>
+                  <a:schemeClr val="tx1"/>
+                </a:solidFill>
+              </a:rPr>
+              <a:t>Green Mountains</a:t>
+            </a:r>
+            <a:endParaRPr lang="en-US" sz="1500" dirty="0"/>
+          </a:p>
+        </p:txBody>
+      </p:sp>
+      <p:sp>
+        <p:nvSpPr>
+          <p:cNvPr id="18" name="Tag card takeaway"/>
+          <p:cNvSpPr txBox="1"/>
+          <p:nvPr/>
+        </p:nvSpPr>
+        <p:spPr>
+          <a:xfrm>
+            <a:off x="6995160" y="5029200"/>
+            <a:ext cx="4327855" cy="548640"/>
+          </a:xfrm>
+          <a:prstGeom prst="rect">
+            <a:avLst/>
+          </a:prstGeom>
+          <a:noFill/>
+          <a:ln/>
+        </p:spPr>
+        <p:txBody>
+          <a:bodyPr wrap="square" lIns="0" tIns="0" rIns="0" bIns="0" rtlCol="0" anchor="t"/>
+          <a:lstStyle/>
+          <a:p>
+            <a:pPr indent="0" marL="0">
+              <a:buNone/>
+            </a:pPr>
+            <a:r>
               <a:rPr lang="en-US" sz="1600" b="1" dirty="0">
                 <a:solidFill>
                   <a:schemeClr val="tx2"/>
                 </a:solidFill>
               </a:rPr>
-              <a:t>One curve for every trail</a:t>
+              <a:t>Often the map can't say how hard a trail is.</a:t>
             </a:r>
             <a:endParaRPr lang="en-US" sz="1600" dirty="0"/>
           </a:p>
-          <a:p>
-            <a:pPr indent="0" marL="0">
-              <a:buNone/>
-            </a:pPr>
-            <a:r>
-              <a:rPr lang="en-US" sz="1400" dirty="0">
-                <a:solidFill>
-                  <a:schemeClr val="tx1"/>
-                </a:solidFill>
-              </a:rPr>
-              <a:t>no rocks, roots, steps or vegetation</a:t>
-            </a:r>
-            <a:endParaRPr lang="en-US" sz="1600" dirty="0"/>
-          </a:p>
-        </p:txBody>
-      </p:sp>
-      <p:sp>
-        <p:nvSpPr>
-          <p:cNvPr id="11" name="Problem marker 3"/>
-          <p:cNvSpPr/>
-          <p:nvPr/>
-        </p:nvSpPr>
-        <p:spPr>
-          <a:xfrm>
-            <a:off x="566928" y="4800600"/>
-            <a:ext cx="164592" cy="164592"/>
-          </a:xfrm>
-          <a:prstGeom prst="ellipse">
-            <a:avLst/>
-          </a:prstGeom>
-          <a:solidFill>
-            <a:schemeClr val="tx2"/>
-          </a:solidFill>
-          <a:ln/>
-        </p:spPr>
-      </p:sp>
-      <p:sp>
-        <p:nvSpPr>
-          <p:cNvPr id="12" name="Problem 3"/>
-          <p:cNvSpPr txBox="1"/>
-          <p:nvPr/>
-        </p:nvSpPr>
-        <p:spPr>
-          <a:xfrm>
-            <a:off x="914400" y="4718304"/>
-            <a:ext cx="5120640" cy="658368"/>
-          </a:xfrm>
-          <a:prstGeom prst="rect">
-            <a:avLst/>
-          </a:prstGeom>
-          <a:noFill/>
-          <a:ln/>
-        </p:spPr>
-        <p:txBody>
-          <a:bodyPr wrap="square" lIns="0" tIns="0" rIns="0" bIns="0" rtlCol="0" anchor="t"/>
-          <a:lstStyle/>
-          <a:p>
-            <a:pPr indent="0" marL="0">
-              <a:buNone/>
-            </a:pPr>
-            <a:r>
-              <a:rPr lang="en-US" sz="1600" b="1" dirty="0">
-                <a:solidFill>
-                  <a:schemeClr val="tx2"/>
-                </a:solidFill>
-              </a:rPr>
-              <a:t>Still the default in GIS travel-time tools</a:t>
-            </a:r>
-            <a:endParaRPr lang="en-US" sz="1600" dirty="0"/>
-          </a:p>
-          <a:p>
-            <a:pPr indent="0" marL="0">
-              <a:buNone/>
-            </a:pPr>
-            <a:r>
-              <a:rPr lang="en-US" sz="1400" dirty="0">
-                <a:solidFill>
-                  <a:schemeClr val="tx1"/>
-                </a:solidFill>
-              </a:rPr>
-              <a:t>search and rescue, wildfire escape routes, trail apps</a:t>
-            </a:r>
-            <a:endParaRPr lang="en-US" sz="1600" dirty="0"/>
-          </a:p>
-        </p:txBody>
-      </p:sp>
-      <p:sp>
-        <p:nvSpPr>
-          <p:cNvPr id="13" name="Tag coverage note"/>
-          <p:cNvSpPr txBox="1"/>
-          <p:nvPr/>
-        </p:nvSpPr>
-        <p:spPr>
-          <a:xfrm>
-            <a:off x="548640" y="5440680"/>
-            <a:ext cx="5486400" cy="731520"/>
-          </a:xfrm>
-          <a:prstGeom prst="rect">
-            <a:avLst/>
-          </a:prstGeom>
-          <a:noFill/>
-          <a:ln/>
-        </p:spPr>
-        <p:txBody>
-          <a:bodyPr wrap="square" lIns="0" tIns="0" rIns="0" bIns="0" rtlCol="0" anchor="t"/>
-          <a:lstStyle/>
-          <a:p>
-            <a:pPr indent="0" marL="0">
-              <a:buNone/>
-            </a:pPr>
-            <a:r>
-              <a:rPr lang="en-US" sz="1600" b="1" dirty="0">
-                <a:solidFill>
-                  <a:schemeClr val="tx2"/>
-                </a:solidFill>
-              </a:rPr>
-              <a:t>And the map rarely helps: </a:t>
-            </a:r>
-            <a:pPr indent="0" marL="0">
-              <a:buNone/>
-            </a:pPr>
-            <a:r>
-              <a:rPr lang="en-US" sz="1600" dirty="0">
-                <a:solidFill>
-                  <a:schemeClr val="tx1"/>
-                </a:solidFill>
-              </a:rPr>
-              <a:t>OSM's difficulty tag covers </a:t>
-            </a:r>
-            <a:pPr indent="0" marL="0">
-              <a:buNone/>
-            </a:pPr>
-            <a:r>
-              <a:rPr lang="en-US" sz="1600" b="1" dirty="0">
-                <a:solidFill>
-                  <a:schemeClr val="accent2"/>
-                </a:solidFill>
-              </a:rPr>
-              <a:t>1.5% to 96%</a:t>
-            </a:r>
-            <a:pPr indent="0" marL="0">
-              <a:buNone/>
-            </a:pPr>
-            <a:r>
-              <a:rPr lang="en-US" sz="1600" dirty="0">
-                <a:solidFill>
-                  <a:schemeClr val="tx1"/>
-                </a:solidFill>
-              </a:rPr>
-              <a:t> of walked trail, depending on the region.</a:t>
-            </a:r>
-            <a:endParaRPr lang="en-US" sz="1600" dirty="0"/>
-          </a:p>
-        </p:txBody>
-      </p:sp>
-      <p:graphicFrame>
-        <p:nvGraphicFramePr>
-          <p:cNvPr id="14" name="Tag coverage chart" descr=""/>
-          <p:cNvGraphicFramePr/>
-          <p:nvPr/>
-        </p:nvGraphicFramePr>
-        <p:xfrm>
-          <a:off x="6446520" y="1234440"/>
-          <a:ext cx="5196535" cy="5029200"/>
-        </p:xfrm>
-        <a:graphic xmlns:a="http://schemas.openxmlformats.org/drawingml/2006/main">
-          <a:graphicData uri="http://schemas.openxmlformats.org/drawingml/2006/chart">
-            <c:chart xmlns:c="http://schemas.openxmlformats.org/drawingml/2006/chart" r:id="rId1"/>
-          </a:graphicData>
-        </a:graphic>
-      </p:graphicFrame>
+        </p:txBody>
+      </p:sp>
       <p:sp>
         <p:nvSpPr>
           <p:cNvPr id="25" name="Slide Number Placeholder 0"/>
@@ -3113,7 +2885,7 @@
                 <a:ea typeface="+mj-lt" pitchFamily="34" charset="-122"/>
                 <a:cs typeface="+mj-lt" pitchFamily="34" charset="-120"/>
               </a:rPr>
-              <a:t>Prior work stays inside one region</a:t>
+              <a:t>Goal: predict speed in regions the model never saw</a:t>
             </a:r>
             <a:endParaRPr lang="en-US" sz="3400" dirty="0"/>
           </a:p>
@@ -3121,18 +2893,54 @@
       </p:sp>
       <p:sp>
         <p:nvSpPr>
-          <p:cNvPr id="3" name="Prior card 1"/>
+          <p:cNvPr id="3" name="Prior label"/>
+          <p:cNvSpPr txBox="1"/>
+          <p:nvPr/>
+        </p:nvSpPr>
+        <p:spPr>
+          <a:xfrm>
+            <a:off x="548640" y="1463040"/>
+            <a:ext cx="4754880" cy="274320"/>
+          </a:xfrm>
+          <a:prstGeom prst="rect">
+            <a:avLst/>
+          </a:prstGeom>
+          <a:noFill/>
+          <a:ln/>
+        </p:spPr>
+        <p:txBody>
+          <a:bodyPr wrap="square" lIns="0" tIns="0" rIns="0" bIns="0" rtlCol="0" anchor="t"/>
+          <a:lstStyle/>
+          <a:p>
+            <a:pPr indent="0" marL="0">
+              <a:buNone/>
+            </a:pPr>
+            <a:r>
+              <a:rPr lang="en-US" sz="1200" b="1" spc="150" kern="0" dirty="0">
+                <a:solidFill>
+                  <a:schemeClr val="accent3"/>
+                </a:solidFill>
+              </a:rPr>
+              <a:t>WHAT'S BEEN DONE</a:t>
+            </a:r>
+            <a:endParaRPr lang="en-US" sz="1200" dirty="0"/>
+          </a:p>
+        </p:txBody>
+      </p:sp>
+      <p:sp>
+        <p:nvSpPr>
+          <p:cNvPr id="4" name="Prior card 1"/>
           <p:cNvSpPr/>
           <p:nvPr/>
         </p:nvSpPr>
         <p:spPr>
           <a:xfrm>
-            <a:off x="548640" y="1325880"/>
-            <a:ext cx="6126480" cy="859536"/>
+            <a:off x="548640" y="1874520"/>
+            <a:ext cx="4754880" cy="1005840"/>
           </a:xfrm>
           <a:prstGeom prst="roundRect">
             <a:avLst>
-              <a:gd name="adj" fmla="val 10638"/>
+              <a:gd name="adj" fmla="val 9091"/>
             </a:avLst>
           </a:prstGeom>
           <a:solidFill>
@@ -3143,14 +2951,14 @@
       </p:sp>
       <p:sp>
         <p:nvSpPr>
-          <p:cNvPr id="4" name="Prior 1"/>
+          <p:cNvPr id="5" name="Prior 1"/>
           <p:cNvSpPr txBox="1"/>
           <p:nvPr/>
         </p:nvSpPr>
         <p:spPr>
           <a:xfrm>
-            <a:off x="777240" y="1417320"/>
-            <a:ext cx="5715000" cy="731520"/>
+            <a:off x="777240" y="2039112"/>
+            <a:ext cx="4343400" cy="685800"/>
           </a:xfrm>
           <a:prstGeom prst="rect">
             <a:avLst/>
@@ -3166,45 +2974,45 @@
               <a:buNone/>
             </a:pPr>
             <a:r>
-              <a:rPr lang="en-US" sz="1600" b="1" dirty="0">
+              <a:rPr lang="en-US" sz="1800" b="1" dirty="0">
                 <a:solidFill>
                   <a:schemeClr val="tx2"/>
                 </a:solidFill>
               </a:rPr>
-              <a:t>Slope-only curves</a:t>
-            </a:r>
-            <a:endParaRPr lang="en-US" sz="1600" dirty="0"/>
-          </a:p>
-          <a:p>
-            <a:pPr indent="0" marL="0">
-              <a:buNone/>
-            </a:pPr>
-            <a:r>
-              <a:rPr lang="en-US" sz="1400" dirty="0">
-                <a:solidFill>
-                  <a:schemeClr val="tx1"/>
-                </a:solidFill>
-              </a:rPr>
-              <a:t>Tobler 1993; Campbell et al. 2019, 2022 (Strava, AllTrails): Tobler is too fast</a:t>
-            </a:r>
-            <a:endParaRPr lang="en-US" sz="1600" dirty="0"/>
-          </a:p>
-        </p:txBody>
-      </p:sp>
-      <p:sp>
-        <p:nvSpPr>
-          <p:cNvPr id="5" name="Prior card 2"/>
+              <a:t>Refit the slope curve</a:t>
+            </a:r>
+            <a:endParaRPr lang="en-US" sz="1800" dirty="0"/>
+          </a:p>
+          <a:p>
+            <a:pPr indent="0" marL="0">
+              <a:buNone/>
+            </a:pPr>
+            <a:r>
+              <a:rPr lang="en-US" sz="1300" dirty="0">
+                <a:solidFill>
+                  <a:schemeClr val="accent4"/>
+                </a:solidFill>
+              </a:rPr>
+              <a:t>with fitness-app data (Campbell et al. 2019, 2022)</a:t>
+            </a:r>
+            <a:endParaRPr lang="en-US" sz="1800" dirty="0"/>
+          </a:p>
+        </p:txBody>
+      </p:sp>
+      <p:sp>
+        <p:nvSpPr>
+          <p:cNvPr id="6" name="Prior card 2"/>
           <p:cNvSpPr/>
           <p:nvPr/>
         </p:nvSpPr>
         <p:spPr>
           <a:xfrm>
-            <a:off x="548640" y="2313432"/>
-            <a:ext cx="6126480" cy="859536"/>
+            <a:off x="548640" y="3108960"/>
+            <a:ext cx="4754880" cy="1005840"/>
           </a:xfrm>
           <a:prstGeom prst="roundRect">
             <a:avLst>
-              <a:gd name="adj" fmla="val 10638"/>
+              <a:gd name="adj" fmla="val 9091"/>
             </a:avLst>
           </a:prstGeom>
           <a:solidFill>
@@ -3215,14 +3023,14 @@
       </p:sp>
       <p:sp>
         <p:nvSpPr>
-          <p:cNvPr id="6" name="Prior 2"/>
+          <p:cNvPr id="7" name="Prior 2"/>
           <p:cNvSpPr txBox="1"/>
           <p:nvPr/>
         </p:nvSpPr>
         <p:spPr>
           <a:xfrm>
-            <a:off x="777240" y="2404872"/>
-            <a:ext cx="5715000" cy="731520"/>
+            <a:off x="777240" y="3273552"/>
+            <a:ext cx="4343400" cy="685800"/>
           </a:xfrm>
           <a:prstGeom prst="rect">
             <a:avLst/>
@@ -3238,236 +3046,92 @@
               <a:buNone/>
             </a:pPr>
             <a:r>
-              <a:rPr lang="en-US" sz="1600" b="1" dirty="0">
+              <a:rPr lang="en-US" sz="1800" b="1" dirty="0">
                 <a:solidFill>
                   <a:schemeClr val="tx2"/>
                 </a:solidFill>
               </a:rPr>
-              <a:t>Extra inputs, one study area</a:t>
-            </a:r>
-            <a:endParaRPr lang="en-US" sz="1600" dirty="0"/>
-          </a:p>
-          <a:p>
-            <a:pPr indent="0" marL="0">
-              <a:buNone/>
-            </a:pPr>
-            <a:r>
-              <a:rPr lang="en-US" sz="1400" dirty="0">
+              <a:t>Add map or lidar inputs</a:t>
+            </a:r>
+            <a:endParaRPr lang="en-US" sz="1800" dirty="0"/>
+          </a:p>
+          <a:p>
+            <a:pPr indent="0" marL="0">
+              <a:buNone/>
+            </a:pPr>
+            <a:r>
+              <a:rPr lang="en-US" sz="1300" dirty="0">
+                <a:solidFill>
+                  <a:schemeClr val="accent4"/>
+                </a:solidFill>
+              </a:rPr>
+              <a:t>Wood et al. 2023; STRIDE 2024; RasterNet (this lab, 2020)</a:t>
+            </a:r>
+            <a:endParaRPr lang="en-US" sz="1800" dirty="0"/>
+          </a:p>
+        </p:txBody>
+      </p:sp>
+      <p:sp>
+        <p:nvSpPr>
+          <p:cNvPr id="8" name="Gap"/>
+          <p:cNvSpPr txBox="1"/>
+          <p:nvPr/>
+        </p:nvSpPr>
+        <p:spPr>
+          <a:xfrm>
+            <a:off x="548640" y="4480560"/>
+            <a:ext cx="4754880" cy="731520"/>
+          </a:xfrm>
+          <a:prstGeom prst="rect">
+            <a:avLst/>
+          </a:prstGeom>
+          <a:noFill/>
+          <a:ln/>
+        </p:spPr>
+        <p:txBody>
+          <a:bodyPr wrap="square" lIns="0" tIns="0" rIns="0" bIns="0" rtlCol="0" anchor="t"/>
+          <a:lstStyle/>
+          <a:p>
+            <a:pPr indent="0" marL="0">
+              <a:buNone/>
+            </a:pPr>
+            <a:r>
+              <a:rPr lang="en-US" sz="1800" b="1" dirty="0">
+                <a:solidFill>
+                  <a:schemeClr val="accent2"/>
+                </a:solidFill>
+              </a:rPr>
+              <a:t>Gap: </a:t>
+            </a:r>
+            <a:pPr indent="0" marL="0">
+              <a:buNone/>
+            </a:pPr>
+            <a:r>
+              <a:rPr lang="en-US" sz="1800" dirty="0">
                 <a:solidFill>
                   <a:schemeClr val="tx1"/>
                 </a:solidFill>
               </a:rPr>
-              <a:t>Wood et al. 2023 (England &amp; Wales, OSM + lidar); Huang et al. 2026 (Hong Kong): random or cross-validated splits</a:t>
-            </a:r>
-            <a:endParaRPr lang="en-US" sz="1600" dirty="0"/>
-          </a:p>
-        </p:txBody>
-      </p:sp>
-      <p:sp>
-        <p:nvSpPr>
-          <p:cNvPr id="7" name="Prior card 3"/>
+              <a:t>always tested in the same area they were trained on.</a:t>
+            </a:r>
+            <a:endParaRPr lang="en-US" sz="1800" dirty="0"/>
+          </a:p>
+        </p:txBody>
+      </p:sp>
+      <p:sp>
+        <p:nvSpPr>
+          <p:cNvPr id="9" name="Goal card"/>
           <p:cNvSpPr/>
           <p:nvPr/>
         </p:nvSpPr>
         <p:spPr>
           <a:xfrm>
-            <a:off x="548640" y="3300984"/>
-            <a:ext cx="6126480" cy="859536"/>
+            <a:off x="5760720" y="1417320"/>
+            <a:ext cx="5882335" cy="4526280"/>
           </a:xfrm>
           <a:prstGeom prst="roundRect">
             <a:avLst>
-              <a:gd name="adj" fmla="val 10638"/>
-            </a:avLst>
-          </a:prstGeom>
-          <a:solidFill>
-            <a:schemeClr val="bg2"/>
-          </a:solidFill>
-          <a:ln/>
-        </p:spPr>
-      </p:sp>
-      <p:sp>
-        <p:nvSpPr>
-          <p:cNvPr id="8" name="Prior 3"/>
-          <p:cNvSpPr txBox="1"/>
-          <p:nvPr/>
-        </p:nvSpPr>
-        <p:spPr>
-          <a:xfrm>
-            <a:off x="777240" y="3392424"/>
-            <a:ext cx="5715000" cy="731520"/>
-          </a:xfrm>
-          <a:prstGeom prst="rect">
-            <a:avLst/>
-          </a:prstGeom>
-          <a:noFill/>
-          <a:ln/>
-        </p:spPr>
-        <p:txBody>
-          <a:bodyPr wrap="square" lIns="0" tIns="0" rIns="0" bIns="0" rtlCol="0" anchor="t"/>
-          <a:lstStyle/>
-          <a:p>
-            <a:pPr indent="0" marL="0">
-              <a:buNone/>
-            </a:pPr>
-            <a:r>
-              <a:rPr lang="en-US" sz="1600" b="1" dirty="0">
-                <a:solidFill>
-                  <a:schemeClr val="tx2"/>
-                </a:solidFill>
-              </a:rPr>
-              <a:t>Lidar model from field walks</a:t>
-            </a:r>
-            <a:endParaRPr lang="en-US" sz="1600" dirty="0"/>
-          </a:p>
-          <a:p>
-            <a:pPr indent="0" marL="0">
-              <a:buNone/>
-            </a:pPr>
-            <a:r>
-              <a:rPr lang="en-US" sz="1400" dirty="0">
-                <a:solidFill>
-                  <a:schemeClr val="tx1"/>
-                </a:solidFill>
-              </a:rPr>
-              <a:t>STRIDE, Campbell et al. 2024: slope, understory density, ground roughness</a:t>
-            </a:r>
-            <a:endParaRPr lang="en-US" sz="1600" dirty="0"/>
-          </a:p>
-        </p:txBody>
-      </p:sp>
-      <p:sp>
-        <p:nvSpPr>
-          <p:cNvPr id="9" name="Prior card 4"/>
-          <p:cNvSpPr/>
-          <p:nvPr/>
-        </p:nvSpPr>
-        <p:spPr>
-          <a:xfrm>
-            <a:off x="548640" y="4288536"/>
-            <a:ext cx="6126480" cy="859536"/>
-          </a:xfrm>
-          <a:prstGeom prst="roundRect">
-            <a:avLst>
-              <a:gd name="adj" fmla="val 10638"/>
-            </a:avLst>
-          </a:prstGeom>
-          <a:solidFill>
-            <a:schemeClr val="bg2"/>
-          </a:solidFill>
-          <a:ln/>
-        </p:spPr>
-      </p:sp>
-      <p:sp>
-        <p:nvSpPr>
-          <p:cNvPr id="10" name="Prior 4"/>
-          <p:cNvSpPr txBox="1"/>
-          <p:nvPr/>
-        </p:nvSpPr>
-        <p:spPr>
-          <a:xfrm>
-            <a:off x="777240" y="4379976"/>
-            <a:ext cx="5715000" cy="731520"/>
-          </a:xfrm>
-          <a:prstGeom prst="rect">
-            <a:avLst/>
-          </a:prstGeom>
-          <a:noFill/>
-          <a:ln/>
-        </p:spPr>
-        <p:txBody>
-          <a:bodyPr wrap="square" lIns="0" tIns="0" rIns="0" bIns="0" rtlCol="0" anchor="t"/>
-          <a:lstStyle/>
-          <a:p>
-            <a:pPr indent="0" marL="0">
-              <a:buNone/>
-            </a:pPr>
-            <a:r>
-              <a:rPr lang="en-US" sz="1600" b="1" dirty="0">
-                <a:solidFill>
-                  <a:schemeClr val="tx2"/>
-                </a:solidFill>
-              </a:rPr>
-              <a:t>This lab</a:t>
-            </a:r>
-            <a:endParaRPr lang="en-US" sz="1600" dirty="0"/>
-          </a:p>
-          <a:p>
-            <a:pPr indent="0" marL="0">
-              <a:buNone/>
-            </a:pPr>
-            <a:r>
-              <a:rPr lang="en-US" sz="1400" dirty="0">
-                <a:solidFill>
-                  <a:schemeClr val="tx1"/>
-                </a:solidFill>
-              </a:rPr>
-              <a:t>RasterNet, Hadzic et al. 2020: road speed from lidar and overhead imagery</a:t>
-            </a:r>
-            <a:endParaRPr lang="en-US" sz="1600" dirty="0"/>
-          </a:p>
-        </p:txBody>
-      </p:sp>
-      <p:sp>
-        <p:nvSpPr>
-          <p:cNvPr id="11" name="Gap"/>
-          <p:cNvSpPr txBox="1"/>
-          <p:nvPr/>
-        </p:nvSpPr>
-        <p:spPr>
-          <a:xfrm>
-            <a:off x="548640" y="5394960"/>
-            <a:ext cx="6126480" cy="685800"/>
-          </a:xfrm>
-          <a:prstGeom prst="rect">
-            <a:avLst/>
-          </a:prstGeom>
-          <a:noFill/>
-          <a:ln/>
-        </p:spPr>
-        <p:txBody>
-          <a:bodyPr wrap="square" lIns="0" tIns="0" rIns="0" bIns="0" rtlCol="0" anchor="t"/>
-          <a:lstStyle/>
-          <a:p>
-            <a:pPr indent="0" marL="0">
-              <a:buNone/>
-            </a:pPr>
-            <a:r>
-              <a:rPr lang="en-US" sz="1600" b="1" dirty="0">
-                <a:solidFill>
-                  <a:schemeClr val="accent2"/>
-                </a:solidFill>
-              </a:rPr>
-              <a:t>Missing: </a:t>
-            </a:r>
-            <a:pPr indent="0" marL="0">
-              <a:buNone/>
-            </a:pPr>
-            <a:r>
-              <a:rPr lang="en-US" sz="1600" dirty="0">
-                <a:solidFill>
-                  <a:schemeClr val="tx1"/>
-                </a:solidFill>
-              </a:rPr>
-              <a:t>a test in regions the model never saw, and map tags vs remote sensing head to head.</a:t>
-            </a:r>
-            <a:endParaRPr lang="en-US" sz="1600" dirty="0"/>
-          </a:p>
-        </p:txBody>
-      </p:sp>
-      <p:sp>
-        <p:nvSpPr>
-          <p:cNvPr id="12" name="Goal card"/>
-          <p:cNvSpPr/>
-          <p:nvPr/>
-        </p:nvSpPr>
-        <p:spPr>
-          <a:xfrm>
-            <a:off x="6995160" y="1325880"/>
-            <a:ext cx="4647895" cy="4800600"/>
-          </a:xfrm>
-          <a:prstGeom prst="roundRect">
-            <a:avLst>
-              <a:gd name="adj" fmla="val 1967"/>
+              <a:gd name="adj" fmla="val 2020"/>
             </a:avLst>
           </a:prstGeom>
           <a:solidFill>
@@ -3478,14 +3142,14 @@
       </p:sp>
       <p:sp>
         <p:nvSpPr>
-          <p:cNvPr id="13" name="Goal label"/>
+          <p:cNvPr id="10" name="Goal label"/>
           <p:cNvSpPr txBox="1"/>
           <p:nvPr/>
         </p:nvSpPr>
         <p:spPr>
           <a:xfrm>
-            <a:off x="7269480" y="1554480"/>
-            <a:ext cx="4099255" cy="274320"/>
+            <a:off x="6080760" y="1645920"/>
+            <a:ext cx="5242255" cy="274320"/>
           </a:xfrm>
           <a:prstGeom prst="rect">
             <a:avLst/>
@@ -3506,7 +3170,7 @@
                   <a:schemeClr val="accent5"/>
                 </a:solidFill>
               </a:rPr>
-              <a:t>OUR GOAL</a:t>
+              <a:t>OUR TEST</a:t>
             </a:r>
             <a:endParaRPr lang="en-US" sz="1200" dirty="0"/>
           </a:p>
@@ -3514,14 +3178,14 @@
       </p:sp>
       <p:sp>
         <p:nvSpPr>
-          <p:cNvPr id="14" name="Goal"/>
+          <p:cNvPr id="11" name="Goal"/>
           <p:cNvSpPr txBox="1"/>
           <p:nvPr/>
         </p:nvSpPr>
         <p:spPr>
           <a:xfrm>
-            <a:off x="7269480" y="1874520"/>
-            <a:ext cx="4099255" cy="1737360"/>
+            <a:off x="6080760" y="1965960"/>
+            <a:ext cx="5242255" cy="777240"/>
           </a:xfrm>
           <a:prstGeom prst="rect">
             <a:avLst/>
@@ -3537,7 +3201,7 @@
               <a:buNone/>
             </a:pPr>
             <a:r>
-              <a:rPr lang="en-US" sz="2000" dirty="0">
+              <a:rPr lang="en-US" sz="2200" dirty="0">
                 <a:solidFill>
                   <a:schemeClr val="bg1"/>
                 </a:solidFill>
@@ -3545,22 +3209,382 @@
                 <a:ea typeface="+mj-lt" pitchFamily="34" charset="-122"/>
                 <a:cs typeface="+mj-lt" pitchFamily="34" charset="-120"/>
               </a:rPr>
-              <a:t>Predict the speed of every 50 m of trail, with its uncertainty, from what can be seen from above. Test it on regions the model never saw: train on 16, test on the 17th.</a:t>
-            </a:r>
-            <a:endParaRPr lang="en-US" sz="2000" dirty="0"/>
-          </a:p>
-        </p:txBody>
-      </p:sp>
-      <p:sp>
-        <p:nvSpPr>
-          <p:cNvPr id="15" name="Arms label"/>
+              <a:t>Train on 16 regions, predict the 17th. Repeat for each region.</a:t>
+            </a:r>
+            <a:endParaRPr lang="en-US" sz="2200" dirty="0"/>
+          </a:p>
+        </p:txBody>
+      </p:sp>
+      <p:sp>
+        <p:nvSpPr>
+          <p:cNvPr id="12" name="Training region 1"/>
+          <p:cNvSpPr/>
+          <p:nvPr/>
+        </p:nvSpPr>
+        <p:spPr>
+          <a:xfrm>
+            <a:off x="6080760" y="2926080"/>
+            <a:ext cx="201168" cy="201168"/>
+          </a:xfrm>
+          <a:prstGeom prst="ellipse">
+            <a:avLst/>
+          </a:prstGeom>
+          <a:solidFill>
+            <a:schemeClr val="accent5"/>
+          </a:solidFill>
+          <a:ln/>
+        </p:spPr>
+      </p:sp>
+      <p:sp>
+        <p:nvSpPr>
+          <p:cNvPr id="13" name="Training region 2"/>
+          <p:cNvSpPr/>
+          <p:nvPr/>
+        </p:nvSpPr>
+        <p:spPr>
+          <a:xfrm>
+            <a:off x="6345936" y="2926080"/>
+            <a:ext cx="201168" cy="201168"/>
+          </a:xfrm>
+          <a:prstGeom prst="ellipse">
+            <a:avLst/>
+          </a:prstGeom>
+          <a:solidFill>
+            <a:schemeClr val="accent5"/>
+          </a:solidFill>
+          <a:ln/>
+        </p:spPr>
+      </p:sp>
+      <p:sp>
+        <p:nvSpPr>
+          <p:cNvPr id="14" name="Training region 3"/>
+          <p:cNvSpPr/>
+          <p:nvPr/>
+        </p:nvSpPr>
+        <p:spPr>
+          <a:xfrm>
+            <a:off x="6611112" y="2926080"/>
+            <a:ext cx="201168" cy="201168"/>
+          </a:xfrm>
+          <a:prstGeom prst="ellipse">
+            <a:avLst/>
+          </a:prstGeom>
+          <a:solidFill>
+            <a:schemeClr val="accent5"/>
+          </a:solidFill>
+          <a:ln/>
+        </p:spPr>
+      </p:sp>
+      <p:sp>
+        <p:nvSpPr>
+          <p:cNvPr id="15" name="Training region 4"/>
+          <p:cNvSpPr/>
+          <p:nvPr/>
+        </p:nvSpPr>
+        <p:spPr>
+          <a:xfrm>
+            <a:off x="6876288" y="2926080"/>
+            <a:ext cx="201168" cy="201168"/>
+          </a:xfrm>
+          <a:prstGeom prst="ellipse">
+            <a:avLst/>
+          </a:prstGeom>
+          <a:solidFill>
+            <a:schemeClr val="accent5"/>
+          </a:solidFill>
+          <a:ln/>
+        </p:spPr>
+      </p:sp>
+      <p:sp>
+        <p:nvSpPr>
+          <p:cNvPr id="16" name="Training region 5"/>
+          <p:cNvSpPr/>
+          <p:nvPr/>
+        </p:nvSpPr>
+        <p:spPr>
+          <a:xfrm>
+            <a:off x="7141464" y="2926080"/>
+            <a:ext cx="201168" cy="201168"/>
+          </a:xfrm>
+          <a:prstGeom prst="ellipse">
+            <a:avLst/>
+          </a:prstGeom>
+          <a:solidFill>
+            <a:schemeClr val="accent5"/>
+          </a:solidFill>
+          <a:ln/>
+        </p:spPr>
+      </p:sp>
+      <p:sp>
+        <p:nvSpPr>
+          <p:cNvPr id="17" name="Training region 6"/>
+          <p:cNvSpPr/>
+          <p:nvPr/>
+        </p:nvSpPr>
+        <p:spPr>
+          <a:xfrm>
+            <a:off x="7406640" y="2926080"/>
+            <a:ext cx="201168" cy="201168"/>
+          </a:xfrm>
+          <a:prstGeom prst="ellipse">
+            <a:avLst/>
+          </a:prstGeom>
+          <a:solidFill>
+            <a:schemeClr val="accent5"/>
+          </a:solidFill>
+          <a:ln/>
+        </p:spPr>
+      </p:sp>
+      <p:sp>
+        <p:nvSpPr>
+          <p:cNvPr id="18" name="Training region 7"/>
+          <p:cNvSpPr/>
+          <p:nvPr/>
+        </p:nvSpPr>
+        <p:spPr>
+          <a:xfrm>
+            <a:off x="7671816" y="2926080"/>
+            <a:ext cx="201168" cy="201168"/>
+          </a:xfrm>
+          <a:prstGeom prst="ellipse">
+            <a:avLst/>
+          </a:prstGeom>
+          <a:solidFill>
+            <a:schemeClr val="accent5"/>
+          </a:solidFill>
+          <a:ln/>
+        </p:spPr>
+      </p:sp>
+      <p:sp>
+        <p:nvSpPr>
+          <p:cNvPr id="19" name="Training region 8"/>
+          <p:cNvSpPr/>
+          <p:nvPr/>
+        </p:nvSpPr>
+        <p:spPr>
+          <a:xfrm>
+            <a:off x="7936992" y="2926080"/>
+            <a:ext cx="201168" cy="201168"/>
+          </a:xfrm>
+          <a:prstGeom prst="ellipse">
+            <a:avLst/>
+          </a:prstGeom>
+          <a:solidFill>
+            <a:schemeClr val="accent5"/>
+          </a:solidFill>
+          <a:ln/>
+        </p:spPr>
+      </p:sp>
+      <p:sp>
+        <p:nvSpPr>
+          <p:cNvPr id="20" name="Training region 9"/>
+          <p:cNvSpPr/>
+          <p:nvPr/>
+        </p:nvSpPr>
+        <p:spPr>
+          <a:xfrm>
+            <a:off x="8202168" y="2926080"/>
+            <a:ext cx="201168" cy="201168"/>
+          </a:xfrm>
+          <a:prstGeom prst="ellipse">
+            <a:avLst/>
+          </a:prstGeom>
+          <a:solidFill>
+            <a:schemeClr val="accent5"/>
+          </a:solidFill>
+          <a:ln/>
+        </p:spPr>
+      </p:sp>
+      <p:sp>
+        <p:nvSpPr>
+          <p:cNvPr id="21" name="Training region 10"/>
+          <p:cNvSpPr/>
+          <p:nvPr/>
+        </p:nvSpPr>
+        <p:spPr>
+          <a:xfrm>
+            <a:off x="8467344" y="2926080"/>
+            <a:ext cx="201168" cy="201168"/>
+          </a:xfrm>
+          <a:prstGeom prst="ellipse">
+            <a:avLst/>
+          </a:prstGeom>
+          <a:solidFill>
+            <a:schemeClr val="accent5"/>
+          </a:solidFill>
+          <a:ln/>
+        </p:spPr>
+      </p:sp>
+      <p:sp>
+        <p:nvSpPr>
+          <p:cNvPr id="22" name="Training region 11"/>
+          <p:cNvSpPr/>
+          <p:nvPr/>
+        </p:nvSpPr>
+        <p:spPr>
+          <a:xfrm>
+            <a:off x="8732520" y="2926080"/>
+            <a:ext cx="201168" cy="201168"/>
+          </a:xfrm>
+          <a:prstGeom prst="ellipse">
+            <a:avLst/>
+          </a:prstGeom>
+          <a:solidFill>
+            <a:schemeClr val="accent5"/>
+          </a:solidFill>
+          <a:ln/>
+        </p:spPr>
+      </p:sp>
+      <p:sp>
+        <p:nvSpPr>
+          <p:cNvPr id="23" name="Training region 12"/>
+          <p:cNvSpPr/>
+          <p:nvPr/>
+        </p:nvSpPr>
+        <p:spPr>
+          <a:xfrm>
+            <a:off x="8997696" y="2926080"/>
+            <a:ext cx="201168" cy="201168"/>
+          </a:xfrm>
+          <a:prstGeom prst="ellipse">
+            <a:avLst/>
+          </a:prstGeom>
+          <a:solidFill>
+            <a:schemeClr val="accent5"/>
+          </a:solidFill>
+          <a:ln/>
+        </p:spPr>
+      </p:sp>
+      <p:sp>
+        <p:nvSpPr>
+          <p:cNvPr id="24" name="Training region 13"/>
+          <p:cNvSpPr/>
+          <p:nvPr/>
+        </p:nvSpPr>
+        <p:spPr>
+          <a:xfrm>
+            <a:off x="9262872" y="2926080"/>
+            <a:ext cx="201168" cy="201168"/>
+          </a:xfrm>
+          <a:prstGeom prst="ellipse">
+            <a:avLst/>
+          </a:prstGeom>
+          <a:solidFill>
+            <a:schemeClr val="accent5"/>
+          </a:solidFill>
+          <a:ln/>
+        </p:spPr>
+      </p:sp>
+      <p:sp>
+        <p:nvSpPr>
+          <p:cNvPr id="25" name="Training region 14"/>
+          <p:cNvSpPr/>
+          <p:nvPr/>
+        </p:nvSpPr>
+        <p:spPr>
+          <a:xfrm>
+            <a:off x="9528048" y="2926080"/>
+            <a:ext cx="201168" cy="201168"/>
+          </a:xfrm>
+          <a:prstGeom prst="ellipse">
+            <a:avLst/>
+          </a:prstGeom>
+          <a:solidFill>
+            <a:schemeClr val="accent5"/>
+          </a:solidFill>
+          <a:ln/>
+        </p:spPr>
+      </p:sp>
+      <p:sp>
+        <p:nvSpPr>
+          <p:cNvPr id="26" name="Training region 15"/>
+          <p:cNvSpPr/>
+          <p:nvPr/>
+        </p:nvSpPr>
+        <p:spPr>
+          <a:xfrm>
+            <a:off x="9793224" y="2926080"/>
+            <a:ext cx="201168" cy="201168"/>
+          </a:xfrm>
+          <a:prstGeom prst="ellipse">
+            <a:avLst/>
+          </a:prstGeom>
+          <a:solidFill>
+            <a:schemeClr val="accent5"/>
+          </a:solidFill>
+          <a:ln/>
+        </p:spPr>
+      </p:sp>
+      <p:sp>
+        <p:nvSpPr>
+          <p:cNvPr id="27" name="Training region 16"/>
+          <p:cNvSpPr/>
+          <p:nvPr/>
+        </p:nvSpPr>
+        <p:spPr>
+          <a:xfrm>
+            <a:off x="10058400" y="2926080"/>
+            <a:ext cx="201168" cy="201168"/>
+          </a:xfrm>
+          <a:prstGeom prst="ellipse">
+            <a:avLst/>
+          </a:prstGeom>
+          <a:solidFill>
+            <a:schemeClr val="accent5"/>
+          </a:solidFill>
+          <a:ln/>
+        </p:spPr>
+      </p:sp>
+      <p:sp>
+        <p:nvSpPr>
+          <p:cNvPr id="28" name="Train to test arrow"/>
+          <p:cNvSpPr/>
+          <p:nvPr/>
+        </p:nvSpPr>
+        <p:spPr>
+          <a:xfrm>
+            <a:off x="10415016" y="2935224"/>
+            <a:ext cx="292608" cy="182880"/>
+          </a:xfrm>
+          <a:prstGeom prst="rightArrow">
+            <a:avLst/>
+          </a:prstGeom>
+          <a:solidFill>
+            <a:schemeClr val="accent5"/>
+          </a:solidFill>
+          <a:ln/>
+        </p:spPr>
+      </p:sp>
+      <p:sp>
+        <p:nvSpPr>
+          <p:cNvPr id="29" name="Test region"/>
+          <p:cNvSpPr/>
+          <p:nvPr/>
+        </p:nvSpPr>
+        <p:spPr>
+          <a:xfrm>
+            <a:off x="10844784" y="2889504"/>
+            <a:ext cx="274320" cy="274320"/>
+          </a:xfrm>
+          <a:prstGeom prst="ellipse">
+            <a:avLst/>
+          </a:prstGeom>
+          <a:solidFill>
+            <a:schemeClr val="accent2"/>
+          </a:solidFill>
+          <a:ln/>
+        </p:spPr>
+      </p:sp>
+      <p:sp>
+        <p:nvSpPr>
+          <p:cNvPr id="30" name="Train label"/>
           <p:cNvSpPr txBox="1"/>
           <p:nvPr/>
         </p:nvSpPr>
         <p:spPr>
           <a:xfrm>
-            <a:off x="7269480" y="3657600"/>
-            <a:ext cx="4099255" cy="320040"/>
+            <a:off x="6080760" y="3246120"/>
+            <a:ext cx="4178808" cy="274320"/>
           </a:xfrm>
           <a:prstGeom prst="rect">
             <a:avLst/>
@@ -3572,35 +3596,107 @@
           <a:bodyPr wrap="square" lIns="0" tIns="0" rIns="0" bIns="0" rtlCol="0" anchor="t"/>
           <a:lstStyle/>
           <a:p>
-            <a:pPr indent="0" marL="0">
-              <a:buNone/>
-            </a:pPr>
-            <a:r>
-              <a:rPr lang="en-US" sz="1400" dirty="0">
+            <a:pPr algn="ctr" indent="0" marL="0">
+              <a:buNone/>
+            </a:pPr>
+            <a:r>
+              <a:rPr lang="en-US" sz="1300" dirty="0">
                 <a:solidFill>
                   <a:schemeClr val="accent5"/>
                 </a:solidFill>
               </a:rPr>
-              <a:t>Four models, same method, different inputs</a:t>
-            </a:r>
-            <a:endParaRPr lang="en-US" sz="1400" dirty="0"/>
-          </a:p>
-        </p:txBody>
-      </p:sp>
-      <p:sp>
-        <p:nvSpPr>
-          <p:cNvPr id="16" name="Arm Tobler"/>
+              <a:t>train on 16 regions</a:t>
+            </a:r>
+            <a:endParaRPr lang="en-US" sz="1300" dirty="0"/>
+          </a:p>
+        </p:txBody>
+      </p:sp>
+      <p:sp>
+        <p:nvSpPr>
+          <p:cNvPr id="31" name="Test label"/>
+          <p:cNvSpPr txBox="1"/>
+          <p:nvPr/>
+        </p:nvSpPr>
+        <p:spPr>
+          <a:xfrm>
+            <a:off x="10524744" y="3246120"/>
+            <a:ext cx="914400" cy="274320"/>
+          </a:xfrm>
+          <a:prstGeom prst="rect">
+            <a:avLst/>
+          </a:prstGeom>
+          <a:noFill/>
+          <a:ln/>
+        </p:spPr>
+        <p:txBody>
+          <a:bodyPr wrap="square" lIns="0" tIns="0" rIns="0" bIns="0" rtlCol="0" anchor="t"/>
+          <a:lstStyle/>
+          <a:p>
+            <a:pPr algn="ctr" indent="0" marL="0">
+              <a:buNone/>
+            </a:pPr>
+            <a:r>
+              <a:rPr lang="en-US" sz="1300" b="1" dirty="0">
+                <a:solidFill>
+                  <a:schemeClr val="accent2"/>
+                </a:solidFill>
+              </a:rPr>
+              <a:t>test</a:t>
+            </a:r>
+            <a:endParaRPr lang="en-US" sz="1300" dirty="0"/>
+          </a:p>
+        </p:txBody>
+      </p:sp>
+      <p:sp>
+        <p:nvSpPr>
+          <p:cNvPr id="32" name="Arms label"/>
+          <p:cNvSpPr txBox="1"/>
+          <p:nvPr/>
+        </p:nvSpPr>
+        <p:spPr>
+          <a:xfrm>
+            <a:off x="6080760" y="3657600"/>
+            <a:ext cx="5242255" cy="320040"/>
+          </a:xfrm>
+          <a:prstGeom prst="rect">
+            <a:avLst/>
+          </a:prstGeom>
+          <a:noFill/>
+          <a:ln/>
+        </p:spPr>
+        <p:txBody>
+          <a:bodyPr wrap="square" lIns="0" tIns="0" rIns="0" bIns="0" rtlCol="0" anchor="t"/>
+          <a:lstStyle/>
+          <a:p>
+            <a:pPr indent="0" marL="0">
+              <a:buNone/>
+            </a:pPr>
+            <a:r>
+              <a:rPr lang="en-US" sz="1500" dirty="0">
+                <a:solidFill>
+                  <a:schemeClr val="accent5"/>
+                </a:solidFill>
+              </a:rPr>
+              <a:t>Four models, same learning, different inputs:</a:t>
+            </a:r>
+            <a:endParaRPr lang="en-US" sz="1500" dirty="0"/>
+          </a:p>
+        </p:txBody>
+      </p:sp>
+      <p:sp>
+        <p:nvSpPr>
+          <p:cNvPr id="33" name="Arm Slope only"/>
           <p:cNvSpPr/>
           <p:nvPr/>
         </p:nvSpPr>
         <p:spPr>
           <a:xfrm>
-            <a:off x="7269480" y="4069080"/>
-            <a:ext cx="1958188" cy="822960"/>
+            <a:off x="6080760" y="4069080"/>
+            <a:ext cx="2529688" cy="731520"/>
           </a:xfrm>
           <a:prstGeom prst="roundRect">
             <a:avLst>
-              <a:gd name="adj" fmla="val 11111"/>
+              <a:gd name="adj" fmla="val 12500"/>
             </a:avLst>
           </a:prstGeom>
           <a:solidFill>
@@ -3611,14 +3707,14 @@
       </p:sp>
       <p:sp>
         <p:nvSpPr>
-          <p:cNvPr id="17" name="Arm Tobler text"/>
+          <p:cNvPr id="34" name="Arm Slope only text"/>
           <p:cNvSpPr txBox="1"/>
           <p:nvPr/>
         </p:nvSpPr>
         <p:spPr>
           <a:xfrm>
-            <a:off x="7406640" y="4160520"/>
-            <a:ext cx="1683868" cy="685800"/>
+            <a:off x="6217920" y="4142232"/>
+            <a:ext cx="2255368" cy="621792"/>
           </a:xfrm>
           <a:prstGeom prst="rect">
             <a:avLst/>
@@ -3639,7 +3735,7 @@
                   <a:schemeClr val="bg1"/>
                 </a:solidFill>
               </a:rPr>
-              <a:t>Tobler</a:t>
+              <a:t>Slope only</a:t>
             </a:r>
             <a:endParaRPr lang="en-US" sz="1500" dirty="0"/>
           </a:p>
@@ -3653,7 +3749,7 @@
                   <a:schemeClr val="bg1"/>
                 </a:solidFill>
               </a:rPr>
-              <a:t>slope only</a:t>
+              <a:t>like Tobler</a:t>
             </a:r>
             <a:endParaRPr lang="en-US" sz="1500" dirty="0"/>
           </a:p>
@@ -3661,18 +3757,18 @@
       </p:sp>
       <p:sp>
         <p:nvSpPr>
-          <p:cNvPr id="18" name="Arm Tags"/>
+          <p:cNvPr id="35" name="Arm Map tags"/>
           <p:cNvSpPr/>
           <p:nvPr/>
         </p:nvSpPr>
         <p:spPr>
           <a:xfrm>
-            <a:off x="9410548" y="4069080"/>
-            <a:ext cx="1958188" cy="822960"/>
+            <a:off x="8793328" y="4069080"/>
+            <a:ext cx="2529688" cy="731520"/>
           </a:xfrm>
           <a:prstGeom prst="roundRect">
             <a:avLst>
-              <a:gd name="adj" fmla="val 11111"/>
+              <a:gd name="adj" fmla="val 12500"/>
             </a:avLst>
           </a:prstGeom>
           <a:solidFill>
@@ -3683,14 +3779,14 @@
       </p:sp>
       <p:sp>
         <p:nvSpPr>
-          <p:cNvPr id="19" name="Arm Tags text"/>
+          <p:cNvPr id="36" name="Arm Map tags text"/>
           <p:cNvSpPr txBox="1"/>
           <p:nvPr/>
         </p:nvSpPr>
         <p:spPr>
           <a:xfrm>
-            <a:off x="9547708" y="4160520"/>
-            <a:ext cx="1683868" cy="685800"/>
+            <a:off x="8930488" y="4142232"/>
+            <a:ext cx="2255368" cy="621792"/>
           </a:xfrm>
           <a:prstGeom prst="rect">
             <a:avLst/>
@@ -3711,7 +3807,7 @@
                   <a:schemeClr val="bg1"/>
                 </a:solidFill>
               </a:rPr>
-              <a:t>Tags</a:t>
+              <a:t>Map tags</a:t>
             </a:r>
             <a:endParaRPr lang="en-US" sz="1500" dirty="0"/>
           </a:p>
@@ -3733,18 +3829,18 @@
       </p:sp>
       <p:sp>
         <p:nvSpPr>
-          <p:cNvPr id="20" name="Arm Remote sensing"/>
+          <p:cNvPr id="37" name="Arm Remote sensing"/>
           <p:cNvSpPr/>
           <p:nvPr/>
         </p:nvSpPr>
         <p:spPr>
           <a:xfrm>
-            <a:off x="7269480" y="5029200"/>
-            <a:ext cx="1958188" cy="822960"/>
+            <a:off x="6080760" y="4937760"/>
+            <a:ext cx="2529688" cy="731520"/>
           </a:xfrm>
           <a:prstGeom prst="roundRect">
             <a:avLst>
-              <a:gd name="adj" fmla="val 11111"/>
+              <a:gd name="adj" fmla="val 12500"/>
             </a:avLst>
           </a:prstGeom>
           <a:solidFill>
@@ -3755,14 +3851,14 @@
       </p:sp>
       <p:sp>
         <p:nvSpPr>
-          <p:cNvPr id="21" name="Arm Remote sensing text"/>
+          <p:cNvPr id="38" name="Arm Remote sensing text"/>
           <p:cNvSpPr txBox="1"/>
           <p:nvPr/>
         </p:nvSpPr>
         <p:spPr>
           <a:xfrm>
-            <a:off x="7406640" y="5120640"/>
-            <a:ext cx="1683868" cy="685800"/>
+            <a:off x="6217920" y="5010912"/>
+            <a:ext cx="2255368" cy="621792"/>
           </a:xfrm>
           <a:prstGeom prst="rect">
             <a:avLst/>
@@ -3797,7 +3893,7 @@
                   <a:schemeClr val="bg1"/>
                 </a:solidFill>
               </a:rPr>
-              <a:t>lidar terrain, vegetation, embeddings</a:t>
+              <a:t>lidar terrain, vegetation</a:t>
             </a:r>
             <a:endParaRPr lang="en-US" sz="1500" dirty="0"/>
           </a:p>
@@ -3805,18 +3901,18 @@
       </p:sp>
       <p:sp>
         <p:nvSpPr>
-          <p:cNvPr id="22" name="Arm Both"/>
+          <p:cNvPr id="39" name="Arm Both"/>
           <p:cNvSpPr/>
           <p:nvPr/>
         </p:nvSpPr>
         <p:spPr>
           <a:xfrm>
-            <a:off x="9410548" y="5029200"/>
-            <a:ext cx="1958188" cy="822960"/>
+            <a:off x="8793328" y="4937760"/>
+            <a:ext cx="2529688" cy="731520"/>
           </a:xfrm>
           <a:prstGeom prst="roundRect">
             <a:avLst>
-              <a:gd name="adj" fmla="val 11111"/>
+              <a:gd name="adj" fmla="val 12500"/>
             </a:avLst>
           </a:prstGeom>
           <a:solidFill>
@@ -3827,14 +3923,14 @@
       </p:sp>
       <p:sp>
         <p:nvSpPr>
-          <p:cNvPr id="23" name="Arm Both text"/>
+          <p:cNvPr id="40" name="Arm Both text"/>
           <p:cNvSpPr txBox="1"/>
           <p:nvPr/>
         </p:nvSpPr>
         <p:spPr>
           <a:xfrm>
-            <a:off x="9547708" y="5120640"/>
-            <a:ext cx="1683868" cy="685800"/>
+            <a:off x="8930488" y="5010912"/>
+            <a:ext cx="2255368" cy="621792"/>
           </a:xfrm>
           <a:prstGeom prst="rect">
             <a:avLst/>
@@ -3869,7 +3965,7 @@
                   <a:schemeClr val="bg1"/>
                 </a:solidFill>
               </a:rPr>
-              <a:t>everything</a:t>
+              <a:t>tags + remote sensing</a:t>
             </a:r>
             <a:endParaRPr lang="en-US" sz="1500" dirty="0"/>
           </a:p>
@@ -3980,7 +4076,7 @@
                 <a:ea typeface="+mj-lt" pitchFamily="34" charset="-122"/>
                 <a:cs typeface="+mj-lt" pitchFamily="34" charset="-120"/>
               </a:rPr>
-              <a:t>17 regions, 290,640 measured trail segments</a:t>
+              <a:t>Data: 1,992 real hikes in 17 regions</a:t>
             </a:r>
             <a:endParaRPr lang="en-US" sz="3400" dirty="0"/>
           </a:p>
@@ -3988,7 +4084,7 @@
       </p:sp>
       <p:pic>
         <p:nvPicPr>
-          <p:cNvPr id="3" name="Map of the 17 regions" descr="/Users/brian/Desktop/GeoAI/paper/figures/fig_map.png">    </p:cNvPr>
+          <p:cNvPr id="3" name="Map of the 17 regions" descr="/Users/brian/Desktop/GeoAI/meeting_plots/oct23_lab/assets/slide_map.png">    </p:cNvPr>
           <p:cNvPicPr>
             <a:picLocks noChangeAspect="1"/>
           </p:cNvPicPr>
@@ -4003,7 +4099,7 @@
         <p:spPr>
           <a:xfrm>
             <a:off x="548640" y="1280160"/>
-            <a:ext cx="6400800" cy="3304491"/>
+            <a:ext cx="6949440" cy="3413678"/>
           </a:xfrm>
           <a:prstGeom prst="rect">
             <a:avLst/>
@@ -4018,8 +4114,8 @@
         </p:nvSpPr>
         <p:spPr>
           <a:xfrm>
-            <a:off x="548640" y="4645152"/>
-            <a:ext cx="6400800" cy="411480"/>
+            <a:off x="548640" y="4739558"/>
+            <a:ext cx="6949440" cy="274320"/>
           </a:xfrm>
           <a:prstGeom prst="rect">
             <a:avLst/>
@@ -4035,27 +4131,27 @@
               <a:buNone/>
             </a:pPr>
             <a:r>
-              <a:rPr lang="en-US" sz="1100" dirty="0">
+              <a:rPr lang="en-US" sz="1200" dirty="0">
                 <a:solidFill>
                   <a:schemeClr val="accent4"/>
                 </a:solidFill>
               </a:rPr>
-              <a:t>Circle area = walking hours. Blue: full OSM download plus the lab's crawl; orange: crawl only. Inset: White Mountains segments by speed.</a:t>
-            </a:r>
-            <a:endParaRPr lang="en-US" sz="1100" dirty="0"/>
-          </a:p>
-        </p:txBody>
-      </p:sp>
-      <p:sp>
-        <p:nvSpPr>
-          <p:cNvPr id="5" name="Data stat 1 value"/>
+              <a:t>Circle size = hours of walking</a:t>
+            </a:r>
+            <a:endParaRPr lang="en-US" sz="1200" dirty="0"/>
+          </a:p>
+        </p:txBody>
+      </p:sp>
+      <p:sp>
+        <p:nvSpPr>
+          <p:cNvPr id="5" name="Hikes value"/>
           <p:cNvSpPr txBox="1"/>
           <p:nvPr/>
         </p:nvSpPr>
         <p:spPr>
           <a:xfrm>
-            <a:off x="7269480" y="1371600"/>
-            <a:ext cx="2103120" cy="640080"/>
+            <a:off x="8001000" y="1508760"/>
+            <a:ext cx="3642055" cy="741680"/>
           </a:xfrm>
           <a:prstGeom prst="rect">
             <a:avLst/>
@@ -4071,7 +4167,7 @@
               <a:buNone/>
             </a:pPr>
             <a:r>
-              <a:rPr lang="en-US" sz="3600" b="1" dirty="0">
+              <a:rPr lang="en-US" sz="4400" b="1" dirty="0">
                 <a:solidFill>
                   <a:schemeClr val="tx2"/>
                 </a:solidFill>
@@ -4079,22 +4175,22 @@
                 <a:ea typeface="+mj-lt" pitchFamily="34" charset="-122"/>
                 <a:cs typeface="+mj-lt" pitchFamily="34" charset="-120"/>
               </a:rPr>
-              <a:t>290,640</a:t>
-            </a:r>
-            <a:endParaRPr lang="en-US" sz="3600" dirty="0"/>
-          </a:p>
-        </p:txBody>
-      </p:sp>
-      <p:sp>
-        <p:nvSpPr>
-          <p:cNvPr id="6" name="Data stat 1 label"/>
+              <a:t>1,992</a:t>
+            </a:r>
+            <a:endParaRPr lang="en-US" sz="4400" dirty="0"/>
+          </a:p>
+        </p:txBody>
+      </p:sp>
+      <p:sp>
+        <p:nvSpPr>
+          <p:cNvPr id="6" name="Hikes label"/>
           <p:cNvSpPr txBox="1"/>
           <p:nvPr/>
         </p:nvSpPr>
         <p:spPr>
           <a:xfrm>
-            <a:off x="7269480" y="2011680"/>
-            <a:ext cx="2103120" cy="457200"/>
+            <a:off x="8001000" y="2250440"/>
+            <a:ext cx="3642055" cy="685800"/>
           </a:xfrm>
           <a:prstGeom prst="rect">
             <a:avLst/>
@@ -4115,7 +4211,7 @@
                   <a:schemeClr val="tx1"/>
                 </a:solidFill>
               </a:rPr>
-              <a:t>walking segments, 50 m each</a:t>
+              <a:t>hikes, from public GPS traces</a:t>
             </a:r>
             <a:endParaRPr lang="en-US" sz="1500" dirty="0"/>
           </a:p>
@@ -4123,14 +4219,14 @@
       </p:sp>
       <p:sp>
         <p:nvSpPr>
-          <p:cNvPr id="7" name="Data stat 2 value"/>
+          <p:cNvPr id="7" name="Segments value"/>
           <p:cNvSpPr txBox="1"/>
           <p:nvPr/>
         </p:nvSpPr>
         <p:spPr>
           <a:xfrm>
-            <a:off x="9601200" y="1371600"/>
-            <a:ext cx="2103120" cy="640080"/>
+            <a:off x="8001000" y="3017520"/>
+            <a:ext cx="3642055" cy="741680"/>
           </a:xfrm>
           <a:prstGeom prst="rect">
             <a:avLst/>
@@ -4146,7 +4242,7 @@
               <a:buNone/>
             </a:pPr>
             <a:r>
-              <a:rPr lang="en-US" sz="3600" b="1" dirty="0">
+              <a:rPr lang="en-US" sz="4400" b="1" dirty="0">
                 <a:solidFill>
                   <a:schemeClr val="tx2"/>
                 </a:solidFill>
@@ -4154,22 +4250,22 @@
                 <a:ea typeface="+mj-lt" pitchFamily="34" charset="-122"/>
                 <a:cs typeface="+mj-lt" pitchFamily="34" charset="-120"/>
               </a:rPr>
-              <a:t>1,992</a:t>
-            </a:r>
-            <a:endParaRPr lang="en-US" sz="3600" dirty="0"/>
-          </a:p>
-        </p:txBody>
-      </p:sp>
-      <p:sp>
-        <p:nvSpPr>
-          <p:cNvPr id="8" name="Data stat 2 label"/>
+              <a:t>290,640</a:t>
+            </a:r>
+            <a:endParaRPr lang="en-US" sz="4400" dirty="0"/>
+          </a:p>
+        </p:txBody>
+      </p:sp>
+      <p:sp>
+        <p:nvSpPr>
+          <p:cNvPr id="8" name="Segments label"/>
           <p:cNvSpPr txBox="1"/>
           <p:nvPr/>
         </p:nvSpPr>
         <p:spPr>
           <a:xfrm>
-            <a:off x="9601200" y="2011680"/>
-            <a:ext cx="2103120" cy="457200"/>
+            <a:off x="8001000" y="3759200"/>
+            <a:ext cx="3642055" cy="685800"/>
           </a:xfrm>
           <a:prstGeom prst="rect">
             <a:avLst/>
@@ -4190,7 +4286,7 @@
                   <a:schemeClr val="tx1"/>
                 </a:solidFill>
               </a:rPr>
-              <a:t>hikes</a:t>
+              <a:t>trail segments of 50 m, each with a measured speed</a:t>
             </a:r>
             <a:endParaRPr lang="en-US" sz="1500" dirty="0"/>
           </a:p>
@@ -4198,192 +4294,14 @@
       </p:sp>
       <p:sp>
         <p:nvSpPr>
-          <p:cNvPr id="9" name="Data stat 3 value"/>
-          <p:cNvSpPr txBox="1"/>
-          <p:nvPr/>
-        </p:nvSpPr>
-        <p:spPr>
-          <a:xfrm>
-            <a:off x="7269480" y="2971800"/>
-            <a:ext cx="2103120" cy="640080"/>
-          </a:xfrm>
-          <a:prstGeom prst="rect">
-            <a:avLst/>
-          </a:prstGeom>
-          <a:noFill/>
-          <a:ln/>
-        </p:spPr>
-        <p:txBody>
-          <a:bodyPr wrap="square" lIns="0" tIns="0" rIns="0" bIns="0" rtlCol="0" anchor="t"/>
-          <a:lstStyle/>
-          <a:p>
-            <a:pPr indent="0" marL="0">
-              <a:buNone/>
-            </a:pPr>
-            <a:r>
-              <a:rPr lang="en-US" sz="3600" b="1" dirty="0">
-                <a:solidFill>
-                  <a:schemeClr val="tx2"/>
-                </a:solidFill>
-                <a:latin typeface="+mj-lt" pitchFamily="34" charset="0"/>
-                <a:ea typeface="+mj-lt" pitchFamily="34" charset="-122"/>
-                <a:cs typeface="+mj-lt" pitchFamily="34" charset="-120"/>
-              </a:rPr>
-              <a:t>4,702</a:t>
-            </a:r>
-            <a:pPr indent="0" marL="0">
-              <a:buNone/>
-            </a:pPr>
-            <a:r>
-              <a:rPr lang="en-US" sz="2000" b="1" dirty="0">
-                <a:solidFill>
-                  <a:schemeClr val="tx2"/>
-                </a:solidFill>
-                <a:latin typeface="+mj-lt" pitchFamily="34" charset="0"/>
-                <a:ea typeface="+mj-lt" pitchFamily="34" charset="-122"/>
-                <a:cs typeface="+mj-lt" pitchFamily="34" charset="-120"/>
-              </a:rPr>
-              <a:t> h</a:t>
-            </a:r>
-            <a:endParaRPr lang="en-US" sz="3600" dirty="0"/>
-          </a:p>
-        </p:txBody>
-      </p:sp>
-      <p:sp>
-        <p:nvSpPr>
-          <p:cNvPr id="10" name="Data stat 3 label"/>
-          <p:cNvSpPr txBox="1"/>
-          <p:nvPr/>
-        </p:nvSpPr>
-        <p:spPr>
-          <a:xfrm>
-            <a:off x="7269480" y="3611880"/>
-            <a:ext cx="2103120" cy="457200"/>
-          </a:xfrm>
-          <a:prstGeom prst="rect">
-            <a:avLst/>
-          </a:prstGeom>
-          <a:noFill/>
-          <a:ln/>
-        </p:spPr>
-        <p:txBody>
-          <a:bodyPr wrap="square" lIns="0" tIns="0" rIns="0" bIns="0" rtlCol="0" anchor="t"/>
-          <a:lstStyle/>
-          <a:p>
-            <a:pPr indent="0" marL="0">
-              <a:buNone/>
-            </a:pPr>
-            <a:r>
-              <a:rPr lang="en-US" sz="1500" dirty="0">
-                <a:solidFill>
-                  <a:schemeClr val="tx1"/>
-                </a:solidFill>
-              </a:rPr>
-              <a:t>of walking</a:t>
-            </a:r>
-            <a:endParaRPr lang="en-US" sz="1500" dirty="0"/>
-          </a:p>
-        </p:txBody>
-      </p:sp>
-      <p:sp>
-        <p:nvSpPr>
-          <p:cNvPr id="11" name="Data stat 4 value"/>
-          <p:cNvSpPr txBox="1"/>
-          <p:nvPr/>
-        </p:nvSpPr>
-        <p:spPr>
-          <a:xfrm>
-            <a:off x="9601200" y="2971800"/>
-            <a:ext cx="2103120" cy="640080"/>
-          </a:xfrm>
-          <a:prstGeom prst="rect">
-            <a:avLst/>
-          </a:prstGeom>
-          <a:noFill/>
-          <a:ln/>
-        </p:spPr>
-        <p:txBody>
-          <a:bodyPr wrap="square" lIns="0" tIns="0" rIns="0" bIns="0" rtlCol="0" anchor="t"/>
-          <a:lstStyle/>
-          <a:p>
-            <a:pPr indent="0" marL="0">
-              <a:buNone/>
-            </a:pPr>
-            <a:r>
-              <a:rPr lang="en-US" sz="3600" b="1" dirty="0">
-                <a:solidFill>
-                  <a:schemeClr val="tx2"/>
-                </a:solidFill>
-                <a:latin typeface="+mj-lt" pitchFamily="34" charset="0"/>
-                <a:ea typeface="+mj-lt" pitchFamily="34" charset="-122"/>
-                <a:cs typeface="+mj-lt" pitchFamily="34" charset="-120"/>
-              </a:rPr>
-              <a:t>14,532</a:t>
-            </a:r>
-            <a:pPr indent="0" marL="0">
-              <a:buNone/>
-            </a:pPr>
-            <a:r>
-              <a:rPr lang="en-US" sz="2000" b="1" dirty="0">
-                <a:solidFill>
-                  <a:schemeClr val="tx2"/>
-                </a:solidFill>
-                <a:latin typeface="+mj-lt" pitchFamily="34" charset="0"/>
-                <a:ea typeface="+mj-lt" pitchFamily="34" charset="-122"/>
-                <a:cs typeface="+mj-lt" pitchFamily="34" charset="-120"/>
-              </a:rPr>
-              <a:t> km</a:t>
-            </a:r>
-            <a:endParaRPr lang="en-US" sz="3600" dirty="0"/>
-          </a:p>
-        </p:txBody>
-      </p:sp>
-      <p:sp>
-        <p:nvSpPr>
-          <p:cNvPr id="12" name="Data stat 4 label"/>
-          <p:cNvSpPr txBox="1"/>
-          <p:nvPr/>
-        </p:nvSpPr>
-        <p:spPr>
-          <a:xfrm>
-            <a:off x="9601200" y="3611880"/>
-            <a:ext cx="2103120" cy="457200"/>
-          </a:xfrm>
-          <a:prstGeom prst="rect">
-            <a:avLst/>
-          </a:prstGeom>
-          <a:noFill/>
-          <a:ln/>
-        </p:spPr>
-        <p:txBody>
-          <a:bodyPr wrap="square" lIns="0" tIns="0" rIns="0" bIns="0" rtlCol="0" anchor="t"/>
-          <a:lstStyle/>
-          <a:p>
-            <a:pPr indent="0" marL="0">
-              <a:buNone/>
-            </a:pPr>
-            <a:r>
-              <a:rPr lang="en-US" sz="1500" dirty="0">
-                <a:solidFill>
-                  <a:schemeClr val="tx1"/>
-                </a:solidFill>
-              </a:rPr>
-              <a:t>of trail walked</a:t>
-            </a:r>
-            <a:endParaRPr lang="en-US" sz="1500" dirty="0"/>
-          </a:p>
-        </p:txBody>
-      </p:sp>
-      <p:sp>
-        <p:nvSpPr>
-          <p:cNvPr id="13" name="Pipeline step 1"/>
+          <p:cNvPr id="9" name="Pipeline step 1"/>
           <p:cNvSpPr/>
           <p:nvPr/>
         </p:nvSpPr>
         <p:spPr>
           <a:xfrm>
             <a:off x="548640" y="5257800"/>
-            <a:ext cx="1828800" cy="868680"/>
+            <a:ext cx="3362858" cy="868680"/>
           </a:xfrm>
           <a:prstGeom prst="roundRect">
             <a:avLst>
@@ -4398,14 +4316,14 @@
       </p:sp>
       <p:sp>
         <p:nvSpPr>
-          <p:cNvPr id="14" name="Pipeline step 1 text"/>
+          <p:cNvPr id="10" name="Pipeline step 1 text"/>
           <p:cNvSpPr txBox="1"/>
           <p:nvPr/>
         </p:nvSpPr>
         <p:spPr>
           <a:xfrm>
-            <a:off x="685800" y="5257800"/>
-            <a:ext cx="1554480" cy="868680"/>
+            <a:off x="731520" y="5257800"/>
+            <a:ext cx="2997098" cy="868680"/>
           </a:xfrm>
           <a:prstGeom prst="rect">
             <a:avLst/>
@@ -4421,27 +4339,27 @@
               <a:buNone/>
             </a:pPr>
             <a:r>
-              <a:rPr lang="en-US" sz="1400" dirty="0">
+              <a:rPr lang="en-US" sz="1600" dirty="0">
                 <a:solidFill>
                   <a:schemeClr val="tx2"/>
                 </a:solidFill>
               </a:rPr>
-              <a:t>Public OSM GPS traces</a:t>
-            </a:r>
-            <a:endParaRPr lang="en-US" sz="1400" dirty="0"/>
-          </a:p>
-        </p:txBody>
-      </p:sp>
-      <p:sp>
-        <p:nvSpPr>
-          <p:cNvPr id="15" name="Pipeline arrow 1"/>
+              <a:t>Public GPS traces from OpenStreetMap</a:t>
+            </a:r>
+            <a:endParaRPr lang="en-US" sz="1600" dirty="0"/>
+          </a:p>
+        </p:txBody>
+      </p:sp>
+      <p:sp>
+        <p:nvSpPr>
+          <p:cNvPr id="11" name="Pipeline arrow 1"/>
           <p:cNvSpPr/>
           <p:nvPr/>
         </p:nvSpPr>
         <p:spPr>
           <a:xfrm>
-            <a:off x="2423160" y="5577840"/>
-            <a:ext cx="164592" cy="228600"/>
+            <a:off x="4039514" y="5550408"/>
+            <a:ext cx="246888" cy="274320"/>
           </a:xfrm>
           <a:prstGeom prst="rightArrow">
             <a:avLst/>
@@ -4454,14 +4372,14 @@
       </p:sp>
       <p:sp>
         <p:nvSpPr>
-          <p:cNvPr id="16" name="Pipeline step 2"/>
+          <p:cNvPr id="12" name="Pipeline step 2"/>
           <p:cNvSpPr/>
           <p:nvPr/>
         </p:nvSpPr>
         <p:spPr>
           <a:xfrm>
-            <a:off x="2633472" y="5257800"/>
-            <a:ext cx="1828800" cy="868680"/>
+            <a:off x="4414418" y="5257800"/>
+            <a:ext cx="3362858" cy="868680"/>
           </a:xfrm>
           <a:prstGeom prst="roundRect">
             <a:avLst>
@@ -4476,14 +4394,14 @@
       </p:sp>
       <p:sp>
         <p:nvSpPr>
-          <p:cNvPr id="17" name="Pipeline step 2 text"/>
+          <p:cNvPr id="13" name="Pipeline step 2 text"/>
           <p:cNvSpPr txBox="1"/>
           <p:nvPr/>
         </p:nvSpPr>
         <p:spPr>
           <a:xfrm>
-            <a:off x="2770632" y="5257800"/>
-            <a:ext cx="1554480" cy="868680"/>
+            <a:off x="4597298" y="5257800"/>
+            <a:ext cx="2997098" cy="868680"/>
           </a:xfrm>
           <a:prstGeom prst="rect">
             <a:avLst/>
@@ -4499,27 +4417,27 @@
               <a:buNone/>
             </a:pPr>
             <a:r>
-              <a:rPr lang="en-US" sz="1400" dirty="0">
+              <a:rPr lang="en-US" sz="1600" dirty="0">
                 <a:solidFill>
                   <a:schemeClr val="tx2"/>
                 </a:solidFill>
               </a:rPr>
-              <a:t>Clean and remove stops</a:t>
-            </a:r>
-            <a:endParaRPr lang="en-US" sz="1400" dirty="0"/>
-          </a:p>
-        </p:txBody>
-      </p:sp>
-      <p:sp>
-        <p:nvSpPr>
-          <p:cNvPr id="18" name="Pipeline arrow 2"/>
+              <a:t>Clean, remove stops, snap to the trail map</a:t>
+            </a:r>
+            <a:endParaRPr lang="en-US" sz="1600" dirty="0"/>
+          </a:p>
+        </p:txBody>
+      </p:sp>
+      <p:sp>
+        <p:nvSpPr>
+          <p:cNvPr id="14" name="Pipeline arrow 2"/>
           <p:cNvSpPr/>
           <p:nvPr/>
         </p:nvSpPr>
         <p:spPr>
           <a:xfrm>
-            <a:off x="4507992" y="5577840"/>
-            <a:ext cx="164592" cy="228600"/>
+            <a:off x="7905293" y="5550408"/>
+            <a:ext cx="246888" cy="274320"/>
           </a:xfrm>
           <a:prstGeom prst="rightArrow">
             <a:avLst/>
@@ -4532,14 +4450,14 @@
       </p:sp>
       <p:sp>
         <p:nvSpPr>
-          <p:cNvPr id="19" name="Pipeline step 3"/>
+          <p:cNvPr id="15" name="Pipeline step 3"/>
           <p:cNvSpPr/>
           <p:nvPr/>
         </p:nvSpPr>
         <p:spPr>
           <a:xfrm>
-            <a:off x="4718304" y="5257800"/>
-            <a:ext cx="1828800" cy="868680"/>
+            <a:off x="8280197" y="5257800"/>
+            <a:ext cx="3362858" cy="868680"/>
           </a:xfrm>
           <a:prstGeom prst="roundRect">
             <a:avLst>
@@ -4554,14 +4472,14 @@
       </p:sp>
       <p:sp>
         <p:nvSpPr>
-          <p:cNvPr id="20" name="Pipeline step 3 text"/>
+          <p:cNvPr id="16" name="Pipeline step 3 text"/>
           <p:cNvSpPr txBox="1"/>
           <p:nvPr/>
         </p:nvSpPr>
         <p:spPr>
           <a:xfrm>
-            <a:off x="4855464" y="5257800"/>
-            <a:ext cx="1554480" cy="868680"/>
+            <a:off x="8463077" y="5257800"/>
+            <a:ext cx="2997098" cy="868680"/>
           </a:xfrm>
           <a:prstGeom prst="rect">
             <a:avLst/>
@@ -4577,170 +4495,14 @@
               <a:buNone/>
             </a:pPr>
             <a:r>
-              <a:rPr lang="en-US" sz="1400" dirty="0">
+              <a:rPr lang="en-US" sz="1600" dirty="0">
                 <a:solidFill>
                   <a:schemeClr val="tx2"/>
                 </a:solidFill>
               </a:rPr>
-              <a:t>Match to the trail map</a:t>
-            </a:r>
-            <a:endParaRPr lang="en-US" sz="1400" dirty="0"/>
-          </a:p>
-        </p:txBody>
-      </p:sp>
-      <p:sp>
-        <p:nvSpPr>
-          <p:cNvPr id="21" name="Pipeline arrow 3"/>
-          <p:cNvSpPr/>
-          <p:nvPr/>
-        </p:nvSpPr>
-        <p:spPr>
-          <a:xfrm>
-            <a:off x="6592824" y="5577840"/>
-            <a:ext cx="164592" cy="228600"/>
-          </a:xfrm>
-          <a:prstGeom prst="rightArrow">
-            <a:avLst/>
-          </a:prstGeom>
-          <a:solidFill>
-            <a:schemeClr val="accent3"/>
-          </a:solidFill>
-          <a:ln/>
-        </p:spPr>
-      </p:sp>
-      <p:sp>
-        <p:nvSpPr>
-          <p:cNvPr id="22" name="Pipeline step 4"/>
-          <p:cNvSpPr/>
-          <p:nvPr/>
-        </p:nvSpPr>
-        <p:spPr>
-          <a:xfrm>
-            <a:off x="6803136" y="5257800"/>
-            <a:ext cx="1828800" cy="868680"/>
-          </a:xfrm>
-          <a:prstGeom prst="roundRect">
-            <a:avLst>
-              <a:gd name="adj" fmla="val 10526"/>
-            </a:avLst>
-          </a:prstGeom>
-          <a:solidFill>
-            <a:schemeClr val="bg2"/>
-          </a:solidFill>
-          <a:ln/>
-        </p:spPr>
-      </p:sp>
-      <p:sp>
-        <p:nvSpPr>
-          <p:cNvPr id="23" name="Pipeline step 4 text"/>
-          <p:cNvSpPr txBox="1"/>
-          <p:nvPr/>
-        </p:nvSpPr>
-        <p:spPr>
-          <a:xfrm>
-            <a:off x="6940296" y="5257800"/>
-            <a:ext cx="1554480" cy="868680"/>
-          </a:xfrm>
-          <a:prstGeom prst="rect">
-            <a:avLst/>
-          </a:prstGeom>
-          <a:noFill/>
-          <a:ln/>
-        </p:spPr>
-        <p:txBody>
-          <a:bodyPr wrap="square" lIns="0" tIns="0" rIns="0" bIns="0" rtlCol="0" anchor="ctr"/>
-          <a:lstStyle/>
-          <a:p>
-            <a:pPr algn="ctr" indent="0" marL="0">
-              <a:buNone/>
-            </a:pPr>
-            <a:r>
-              <a:rPr lang="en-US" sz="1400" dirty="0">
-                <a:solidFill>
-                  <a:schemeClr val="tx2"/>
-                </a:solidFill>
-              </a:rPr>
-              <a:t>Cut into 50 m segments</a:t>
-            </a:r>
-            <a:endParaRPr lang="en-US" sz="1400" dirty="0"/>
-          </a:p>
-        </p:txBody>
-      </p:sp>
-      <p:sp>
-        <p:nvSpPr>
-          <p:cNvPr id="24" name="Pipeline arrow 4"/>
-          <p:cNvSpPr/>
-          <p:nvPr/>
-        </p:nvSpPr>
-        <p:spPr>
-          <a:xfrm>
-            <a:off x="8677656" y="5577840"/>
-            <a:ext cx="164592" cy="228600"/>
-          </a:xfrm>
-          <a:prstGeom prst="rightArrow">
-            <a:avLst/>
-          </a:prstGeom>
-          <a:solidFill>
-            <a:schemeClr val="accent3"/>
-          </a:solidFill>
-          <a:ln/>
-        </p:spPr>
-      </p:sp>
-      <p:sp>
-        <p:nvSpPr>
-          <p:cNvPr id="25" name="Pipeline step 5"/>
-          <p:cNvSpPr/>
-          <p:nvPr/>
-        </p:nvSpPr>
-        <p:spPr>
-          <a:xfrm>
-            <a:off x="8887968" y="5257800"/>
-            <a:ext cx="2743200" cy="868680"/>
-          </a:xfrm>
-          <a:prstGeom prst="roundRect">
-            <a:avLst>
-              <a:gd name="adj" fmla="val 10526"/>
-            </a:avLst>
-          </a:prstGeom>
-          <a:solidFill>
-            <a:schemeClr val="bg2"/>
-          </a:solidFill>
-          <a:ln/>
-        </p:spPr>
-      </p:sp>
-      <p:sp>
-        <p:nvSpPr>
-          <p:cNvPr id="26" name="Pipeline step 5 text"/>
-          <p:cNvSpPr txBox="1"/>
-          <p:nvPr/>
-        </p:nvSpPr>
-        <p:spPr>
-          <a:xfrm>
-            <a:off x="9025128" y="5257800"/>
-            <a:ext cx="2468880" cy="868680"/>
-          </a:xfrm>
-          <a:prstGeom prst="rect">
-            <a:avLst/>
-          </a:prstGeom>
-          <a:noFill/>
-          <a:ln/>
-        </p:spPr>
-        <p:txBody>
-          <a:bodyPr wrap="square" lIns="0" tIns="0" rIns="0" bIns="0" rtlCol="0" anchor="ctr"/>
-          <a:lstStyle/>
-          <a:p>
-            <a:pPr algn="ctr" indent="0" marL="0">
-              <a:buNone/>
-            </a:pPr>
-            <a:r>
-              <a:rPr lang="en-US" sz="1400" b="1" dirty="0">
-                <a:solidFill>
-                  <a:schemeClr val="tx2"/>
-                </a:solidFill>
-              </a:rPr>
-              <a:t>Add slope, tags, lidar terrain, vegetation, embeddings</a:t>
-            </a:r>
-            <a:endParaRPr lang="en-US" sz="1400" dirty="0"/>
+              <a:t>50 m segments with slope, map tags and lidar</a:t>
+            </a:r>
+            <a:endParaRPr lang="en-US" sz="1600" dirty="0"/>
           </a:p>
         </p:txBody>
       </p:sp>
@@ -4849,7 +4611,7 @@
                 <a:ea typeface="+mj-lt" pitchFamily="34" charset="-122"/>
                 <a:cs typeface="+mj-lt" pitchFamily="34" charset="-120"/>
               </a:rPr>
-              <a:t>Tobler is too fast and too peaked</a:t>
+              <a:t>Tobler's formula is too fast for real hikers</a:t>
             </a:r>
             <a:endParaRPr lang="en-US" sz="3400" dirty="0"/>
           </a:p>
@@ -4857,7 +4619,7 @@
       </p:sp>
       <p:pic>
         <p:nvPicPr>
-          <p:cNvPr id="3" name="Speed vs slope figure" descr="/Users/brian/Desktop/GeoAI/paper/figures/fig_curve.png">    </p:cNvPr>
+          <p:cNvPr id="3" name="Speed vs slope chart" descr="/Users/brian/Desktop/GeoAI/meeting_plots/oct23_lab/assets/slide_curve.png">    </p:cNvPr>
           <p:cNvPicPr>
             <a:picLocks noChangeAspect="1"/>
           </p:cNvPicPr>
@@ -4872,7 +4634,7 @@
         <p:spPr>
           <a:xfrm>
             <a:off x="548640" y="1234440"/>
-            <a:ext cx="5897880" cy="4972917"/>
+            <a:ext cx="6400800" cy="4800600"/>
           </a:xfrm>
           <a:prstGeom prst="rect">
             <a:avLst/>
@@ -4887,8 +4649,8 @@
         </p:nvSpPr>
         <p:spPr>
           <a:xfrm>
-            <a:off x="6949440" y="1371600"/>
-            <a:ext cx="4693615" cy="690880"/>
+            <a:off x="7498080" y="1737360"/>
+            <a:ext cx="4144975" cy="868680"/>
           </a:xfrm>
           <a:prstGeom prst="rect">
             <a:avLst/>
@@ -4904,7 +4666,7 @@
               <a:buNone/>
             </a:pPr>
             <a:r>
-              <a:rPr lang="en-US" sz="4000" b="1" dirty="0">
+              <a:rPr lang="en-US" sz="5400" b="1" dirty="0">
                 <a:solidFill>
                   <a:schemeClr val="accent1"/>
                 </a:solidFill>
@@ -4918,7 +4680,7 @@
               <a:buNone/>
             </a:pPr>
             <a:r>
-              <a:rPr lang="en-US" sz="2200" b="1" dirty="0">
+              <a:rPr lang="en-US" sz="3000" b="1" dirty="0">
                 <a:solidFill>
                   <a:schemeClr val="accent1"/>
                 </a:solidFill>
@@ -4928,7 +4690,7 @@
               </a:rPr>
               <a:t> km/h</a:t>
             </a:r>
-            <a:endParaRPr lang="en-US" sz="4000" dirty="0"/>
+            <a:endParaRPr lang="en-US" sz="5400" dirty="0"/>
           </a:p>
         </p:txBody>
       </p:sp>
@@ -4940,8 +4702,8 @@
         </p:nvSpPr>
         <p:spPr>
           <a:xfrm>
-            <a:off x="6949440" y="2062480"/>
-            <a:ext cx="4693615" cy="777240"/>
+            <a:off x="7498080" y="2606040"/>
+            <a:ext cx="4144975" cy="777240"/>
           </a:xfrm>
           <a:prstGeom prst="rect">
             <a:avLst/>
@@ -4962,7 +4724,7 @@
                   <a:schemeClr val="tx1"/>
                 </a:solidFill>
               </a:rPr>
-              <a:t>real peak walking speed, on level to gently descending trail</a:t>
+              <a:t>real hikers' top speed</a:t>
             </a:r>
             <a:endParaRPr lang="en-US" sz="1500" dirty="0"/>
           </a:p>
@@ -4976,7 +4738,7 @@
                   <a:schemeClr val="accent4"/>
                 </a:solidFill>
               </a:rPr>
-              <a:t>Tobler: 6 km/h</a:t>
+              <a:t>Tobler says 6 km/h</a:t>
             </a:r>
             <a:endParaRPr lang="en-US" sz="1500" dirty="0"/>
           </a:p>
@@ -4984,14 +4746,14 @@
       </p:sp>
       <p:sp>
         <p:nvSpPr>
-          <p:cNvPr id="6" name="Downhill value"/>
+          <p:cNvPr id="6" name="Tobler regions value"/>
           <p:cNvSpPr txBox="1"/>
           <p:nvPr/>
         </p:nvSpPr>
         <p:spPr>
           <a:xfrm>
-            <a:off x="6949440" y="3017520"/>
-            <a:ext cx="4693615" cy="690880"/>
+            <a:off x="7498080" y="3703320"/>
+            <a:ext cx="4144975" cy="868680"/>
           </a:xfrm>
           <a:prstGeom prst="rect">
             <a:avLst/>
@@ -5007,30 +4769,30 @@
               <a:buNone/>
             </a:pPr>
             <a:r>
-              <a:rPr lang="en-US" sz="4000" b="1" dirty="0">
-                <a:solidFill>
-                  <a:schemeClr val="accent1"/>
+              <a:rPr lang="en-US" sz="5400" b="1" dirty="0">
+                <a:solidFill>
+                  <a:schemeClr val="tx2"/>
                 </a:solidFill>
                 <a:latin typeface="+mj-lt" pitchFamily="34" charset="0"/>
                 <a:ea typeface="+mj-lt" pitchFamily="34" charset="-122"/>
                 <a:cs typeface="+mj-lt" pitchFamily="34" charset="-120"/>
               </a:rPr>
-              <a:t>8–23%</a:t>
-            </a:r>
-            <a:endParaRPr lang="en-US" sz="4000" dirty="0"/>
-          </a:p>
-        </p:txBody>
-      </p:sp>
-      <p:sp>
-        <p:nvSpPr>
-          <p:cNvPr id="7" name="Downhill label"/>
+              <a:t>17 of 17</a:t>
+            </a:r>
+            <a:endParaRPr lang="en-US" sz="5400" dirty="0"/>
+          </a:p>
+        </p:txBody>
+      </p:sp>
+      <p:sp>
+        <p:nvSpPr>
+          <p:cNvPr id="7" name="Tobler regions label"/>
           <p:cNvSpPr txBox="1"/>
           <p:nvPr/>
         </p:nvSpPr>
         <p:spPr>
           <a:xfrm>
-            <a:off x="6949440" y="3708400"/>
-            <a:ext cx="4693615" cy="777240"/>
+            <a:off x="7498080" y="4572000"/>
+            <a:ext cx="4144975" cy="685800"/>
           </a:xfrm>
           <a:prstGeom prst="rect">
             <a:avLst/>
@@ -5051,110 +4813,7 @@
                   <a:schemeClr val="tx1"/>
                 </a:solidFill>
               </a:rPr>
-              <a:t>faster downhill than uphill, same hiker on the same trail</a:t>
-            </a:r>
-            <a:endParaRPr lang="en-US" sz="1500" dirty="0"/>
-          </a:p>
-          <a:p>
-            <a:pPr indent="0" marL="0">
-              <a:buNone/>
-            </a:pPr>
-            <a:r>
-              <a:rPr lang="en-US" sz="1400" i="1" dirty="0">
-                <a:solidFill>
-                  <a:schemeClr val="accent4"/>
-                </a:solidFill>
-              </a:rPr>
-              <a:t>Tobler: 42% at every grade</a:t>
-            </a:r>
-            <a:endParaRPr lang="en-US" sz="1500" dirty="0"/>
-          </a:p>
-        </p:txBody>
-      </p:sp>
-      <p:sp>
-        <p:nvSpPr>
-          <p:cNvPr id="8" name="Tobler regions value"/>
-          <p:cNvSpPr txBox="1"/>
-          <p:nvPr/>
-        </p:nvSpPr>
-        <p:spPr>
-          <a:xfrm>
-            <a:off x="6949440" y="4663440"/>
-            <a:ext cx="4693615" cy="690880"/>
-          </a:xfrm>
-          <a:prstGeom prst="rect">
-            <a:avLst/>
-          </a:prstGeom>
-          <a:noFill/>
-          <a:ln/>
-        </p:spPr>
-        <p:txBody>
-          <a:bodyPr wrap="square" lIns="0" tIns="0" rIns="0" bIns="0" rtlCol="0" anchor="t"/>
-          <a:lstStyle/>
-          <a:p>
-            <a:pPr indent="0" marL="0">
-              <a:buNone/>
-            </a:pPr>
-            <a:r>
-              <a:rPr lang="en-US" sz="4000" b="1" dirty="0">
-                <a:solidFill>
-                  <a:schemeClr val="tx2"/>
-                </a:solidFill>
-                <a:latin typeface="+mj-lt" pitchFamily="34" charset="0"/>
-                <a:ea typeface="+mj-lt" pitchFamily="34" charset="-122"/>
-                <a:cs typeface="+mj-lt" pitchFamily="34" charset="-120"/>
-              </a:rPr>
-              <a:t>17 of 17</a:t>
-            </a:r>
-            <a:endParaRPr lang="en-US" sz="4000" dirty="0"/>
-          </a:p>
-        </p:txBody>
-      </p:sp>
-      <p:sp>
-        <p:nvSpPr>
-          <p:cNvPr id="9" name="Tobler regions label"/>
-          <p:cNvSpPr txBox="1"/>
-          <p:nvPr/>
-        </p:nvSpPr>
-        <p:spPr>
-          <a:xfrm>
-            <a:off x="6949440" y="5354320"/>
-            <a:ext cx="4693615" cy="777240"/>
-          </a:xfrm>
-          <a:prstGeom prst="rect">
-            <a:avLst/>
-          </a:prstGeom>
-          <a:noFill/>
-          <a:ln/>
-        </p:spPr>
-        <p:txBody>
-          <a:bodyPr wrap="square" lIns="0" tIns="0" rIns="0" bIns="0" rtlCol="0" anchor="t"/>
-          <a:lstStyle/>
-          <a:p>
-            <a:pPr indent="0" marL="0">
-              <a:buNone/>
-            </a:pPr>
-            <a:r>
-              <a:rPr lang="en-US" sz="1500" dirty="0">
-                <a:solidFill>
-                  <a:schemeClr val="tx1"/>
-                </a:solidFill>
-              </a:rPr>
-              <a:t>regions where Tobler predicts worse than a curve fitted to the other regions</a:t>
-            </a:r>
-            <a:endParaRPr lang="en-US" sz="1500" dirty="0"/>
-          </a:p>
-          <a:p>
-            <a:pPr indent="0" marL="0">
-              <a:buNone/>
-            </a:pPr>
-            <a:r>
-              <a:rPr lang="en-US" sz="1400" i="1" dirty="0">
-                <a:solidFill>
-                  <a:schemeClr val="accent4"/>
-                </a:solidFill>
-              </a:rPr>
-              <a:t>12.5% worse overall (CRPS score)</a:t>
+              <a:t>regions where Tobler predicts worse than a curve fitted to real hikes</a:t>
             </a:r>
             <a:endParaRPr lang="en-US" sz="1500" dirty="0"/>
           </a:p>
@@ -5273,7 +4932,7 @@
       </p:sp>
       <p:pic>
         <p:nvPicPr>
-          <p:cNvPr id="3" name="Skill by model and by region" descr="/Users/brian/Desktop/GeoAI/paper/figures/fig_skill_regions.png">    </p:cNvPr>
+          <p:cNvPr id="3" name="Terrain vs tags in each held-out region" descr="/Users/brian/Desktop/GeoAI/meeting_plots/oct23_lab/assets/slide_regions.png">    </p:cNvPr>
           <p:cNvPicPr>
             <a:picLocks noChangeAspect="1"/>
           </p:cNvPicPr>
@@ -5287,8 +4946,8 @@
         </p:blipFill>
         <p:spPr>
           <a:xfrm>
-            <a:off x="548640" y="1143000"/>
-            <a:ext cx="11094415" cy="3563898"/>
+            <a:off x="548640" y="1188720"/>
+            <a:ext cx="6263640" cy="4876691"/>
           </a:xfrm>
           <a:prstGeom prst="rect">
             <a:avLst/>
@@ -5297,14 +4956,14 @@
       </p:pic>
       <p:sp>
         <p:nvSpPr>
-          <p:cNvPr id="4" name="Terrain skill value"/>
+          <p:cNvPr id="4" name="Regions won value"/>
           <p:cNvSpPr txBox="1"/>
           <p:nvPr/>
         </p:nvSpPr>
         <p:spPr>
           <a:xfrm>
-            <a:off x="548640" y="4846320"/>
-            <a:ext cx="3503066" cy="563880"/>
+            <a:off x="7269480" y="1554480"/>
+            <a:ext cx="4373575" cy="868680"/>
           </a:xfrm>
           <a:prstGeom prst="rect">
             <a:avLst/>
@@ -5320,7 +4979,7 @@
               <a:buNone/>
             </a:pPr>
             <a:r>
-              <a:rPr lang="en-US" sz="3000" b="1" dirty="0">
+              <a:rPr lang="en-US" sz="5400" b="1" dirty="0">
                 <a:solidFill>
                   <a:schemeClr val="accent1"/>
                 </a:solidFill>
@@ -5328,22 +4987,22 @@
                 <a:ea typeface="+mj-lt" pitchFamily="34" charset="-122"/>
                 <a:cs typeface="+mj-lt" pitchFamily="34" charset="-120"/>
               </a:rPr>
-              <a:t>+2.1 to +2.8%</a:t>
-            </a:r>
-            <a:endParaRPr lang="en-US" sz="3000" dirty="0"/>
-          </a:p>
-        </p:txBody>
-      </p:sp>
-      <p:sp>
-        <p:nvSpPr>
-          <p:cNvPr id="5" name="Terrain skill label"/>
+              <a:t>16 of 17</a:t>
+            </a:r>
+            <a:endParaRPr lang="en-US" sz="5400" dirty="0"/>
+          </a:p>
+        </p:txBody>
+      </p:sp>
+      <p:sp>
+        <p:nvSpPr>
+          <p:cNvPr id="5" name="Regions won label"/>
           <p:cNvSpPr txBox="1"/>
           <p:nvPr/>
         </p:nvSpPr>
         <p:spPr>
           <a:xfrm>
-            <a:off x="548640" y="5410200"/>
-            <a:ext cx="3503066" cy="457200"/>
+            <a:off x="7269480" y="2423160"/>
+            <a:ext cx="4373575" cy="685800"/>
           </a:xfrm>
           <a:prstGeom prst="rect">
             <a:avLst/>
@@ -5364,7 +5023,7 @@
                   <a:schemeClr val="tx1"/>
                 </a:solidFill>
               </a:rPr>
-              <a:t>terrain, in regions the model never saw</a:t>
+              <a:t>new regions where terrain predicts better than map tags</a:t>
             </a:r>
             <a:endParaRPr lang="en-US" sz="1500" dirty="0"/>
           </a:p>
@@ -5372,14 +5031,14 @@
       </p:sp>
       <p:sp>
         <p:nvSpPr>
-          <p:cNvPr id="6" name="Regions won value"/>
+          <p:cNvPr id="6" name="Terrain gain value"/>
           <p:cNvSpPr txBox="1"/>
           <p:nvPr/>
         </p:nvSpPr>
         <p:spPr>
           <a:xfrm>
-            <a:off x="4344314" y="4846320"/>
-            <a:ext cx="3503066" cy="563880"/>
+            <a:off x="7269480" y="3474720"/>
+            <a:ext cx="4373575" cy="868680"/>
           </a:xfrm>
           <a:prstGeom prst="rect">
             <a:avLst/>
@@ -5395,30 +5054,30 @@
               <a:buNone/>
             </a:pPr>
             <a:r>
-              <a:rPr lang="en-US" sz="3000" b="1" dirty="0">
-                <a:solidFill>
-                  <a:schemeClr val="tx2"/>
+              <a:rPr lang="en-US" sz="5400" b="1" dirty="0">
+                <a:solidFill>
+                  <a:schemeClr val="accent1"/>
                 </a:solidFill>
                 <a:latin typeface="+mj-lt" pitchFamily="34" charset="0"/>
                 <a:ea typeface="+mj-lt" pitchFamily="34" charset="-122"/>
                 <a:cs typeface="+mj-lt" pitchFamily="34" charset="-120"/>
               </a:rPr>
-              <a:t>16 of 17</a:t>
-            </a:r>
-            <a:endParaRPr lang="en-US" sz="3000" dirty="0"/>
-          </a:p>
-        </p:txBody>
-      </p:sp>
-      <p:sp>
-        <p:nvSpPr>
-          <p:cNvPr id="7" name="Regions won label"/>
+              <a:t>2–3%</a:t>
+            </a:r>
+            <a:endParaRPr lang="en-US" sz="5400" dirty="0"/>
+          </a:p>
+        </p:txBody>
+      </p:sp>
+      <p:sp>
+        <p:nvSpPr>
+          <p:cNvPr id="7" name="Terrain gain label"/>
           <p:cNvSpPr txBox="1"/>
           <p:nvPr/>
         </p:nvSpPr>
         <p:spPr>
           <a:xfrm>
-            <a:off x="4344314" y="5410200"/>
-            <a:ext cx="3503066" cy="457200"/>
+            <a:off x="7269480" y="4343400"/>
+            <a:ext cx="4373575" cy="777240"/>
           </a:xfrm>
           <a:prstGeom prst="rect">
             <a:avLst/>
@@ -5439,22 +5098,36 @@
                   <a:schemeClr val="tx1"/>
                 </a:solidFill>
               </a:rPr>
-              <a:t>held-out regions where terrain beats tags</a:t>
+              <a:t>terrain's gain over slope alone</a:t>
             </a:r>
             <a:endParaRPr lang="en-US" sz="1500" dirty="0"/>
           </a:p>
-        </p:txBody>
-      </p:sp>
-      <p:sp>
-        <p:nvSpPr>
-          <p:cNvPr id="8" name="Tag skill value"/>
+          <a:p>
+            <a:pPr indent="0" marL="0">
+              <a:buNone/>
+            </a:pPr>
+            <a:r>
+              <a:rPr lang="en-US" sz="1400" i="1" dirty="0">
+                <a:solidFill>
+                  <a:schemeClr val="accent4"/>
+                </a:solidFill>
+              </a:rPr>
+              <a:t>map tags: under 1%</a:t>
+            </a:r>
+            <a:endParaRPr lang="en-US" sz="1500" dirty="0"/>
+          </a:p>
+        </p:txBody>
+      </p:sp>
+      <p:sp>
+        <p:nvSpPr>
+          <p:cNvPr id="8" name="How to read"/>
           <p:cNvSpPr txBox="1"/>
           <p:nvPr/>
         </p:nvSpPr>
         <p:spPr>
           <a:xfrm>
-            <a:off x="8139989" y="4846320"/>
-            <a:ext cx="3503066" cy="563880"/>
+            <a:off x="7269480" y="5349240"/>
+            <a:ext cx="4373575" cy="548640"/>
           </a:xfrm>
           <a:prstGeom prst="rect">
             <a:avLst/>
@@ -5470,89 +5143,14 @@
               <a:buNone/>
             </a:pPr>
             <a:r>
-              <a:rPr lang="en-US" sz="3000" b="1" dirty="0">
-                <a:solidFill>
-                  <a:schemeClr val="accent2"/>
-                </a:solidFill>
-                <a:latin typeface="+mj-lt" pitchFamily="34" charset="0"/>
-                <a:ea typeface="+mj-lt" pitchFamily="34" charset="-122"/>
-                <a:cs typeface="+mj-lt" pitchFamily="34" charset="-120"/>
-              </a:rPr>
-              <a:t>+0.4 to +0.9%</a:t>
-            </a:r>
-            <a:endParaRPr lang="en-US" sz="3000" dirty="0"/>
-          </a:p>
-        </p:txBody>
-      </p:sp>
-      <p:sp>
-        <p:nvSpPr>
-          <p:cNvPr id="9" name="Tag skill label"/>
-          <p:cNvSpPr txBox="1"/>
-          <p:nvPr/>
-        </p:nvSpPr>
-        <p:spPr>
-          <a:xfrm>
-            <a:off x="8139989" y="5410200"/>
-            <a:ext cx="3503066" cy="457200"/>
-          </a:xfrm>
-          <a:prstGeom prst="rect">
-            <a:avLst/>
-          </a:prstGeom>
-          <a:noFill/>
-          <a:ln/>
-        </p:spPr>
-        <p:txBody>
-          <a:bodyPr wrap="square" lIns="0" tIns="0" rIns="0" bIns="0" rtlCol="0" anchor="t"/>
-          <a:lstStyle/>
-          <a:p>
-            <a:pPr indent="0" marL="0">
-              <a:buNone/>
-            </a:pPr>
-            <a:r>
-              <a:rPr lang="en-US" sz="1500" dirty="0">
-                <a:solidFill>
-                  <a:schemeClr val="tx1"/>
-                </a:solidFill>
-              </a:rPr>
-              <a:t>OSM tags, in regions the model never saw</a:t>
-            </a:r>
-            <a:endParaRPr lang="en-US" sz="1500" dirty="0"/>
-          </a:p>
-        </p:txBody>
-      </p:sp>
-      <p:sp>
-        <p:nvSpPr>
-          <p:cNvPr id="10" name="Skill note"/>
-          <p:cNvSpPr txBox="1"/>
-          <p:nvPr/>
-        </p:nvSpPr>
-        <p:spPr>
-          <a:xfrm>
-            <a:off x="548640" y="5870448"/>
-            <a:ext cx="11094415" cy="457200"/>
-          </a:xfrm>
-          <a:prstGeom prst="rect">
-            <a:avLst/>
-          </a:prstGeom>
-          <a:noFill/>
-          <a:ln/>
-        </p:spPr>
-        <p:txBody>
-          <a:bodyPr wrap="square" lIns="0" tIns="0" rIns="0" bIns="0" rtlCol="0" anchor="t"/>
-          <a:lstStyle/>
-          <a:p>
-            <a:pPr indent="0" marL="0">
-              <a:buNone/>
-            </a:pPr>
-            <a:r>
-              <a:rPr lang="en-US" sz="1200" dirty="0">
+              <a:rPr lang="en-US" sz="1400" i="1" dirty="0">
                 <a:solidFill>
                   <a:schemeClr val="accent4"/>
                 </a:solidFill>
               </a:rPr>
-              <a:t>Skill: how much better a model's predicted speed distribution scores (CRPS) than a slope-only curve refitted to our data. It holds for newer hikes, every GPS rate, whole zones held out and hikers the model never saw; vegetation and satellite embeddings don't transfer.</a:t>
-            </a:r>
-            <a:endParaRPr lang="en-US" sz="1200" dirty="0"/>
+              <a:t>Each row: train on the other 16 regions, test on this one.</a:t>
+            </a:r>
+            <a:endParaRPr lang="en-US" sz="1400" dirty="0"/>
           </a:p>
         </p:txBody>
       </p:sp>
@@ -5687,7 +5285,7 @@
                 <a:ea typeface="+mj-lt" pitchFamily="34" charset="-122"/>
                 <a:cs typeface="+mj-lt" pitchFamily="34" charset="-120"/>
               </a:rPr>
-              <a:t>Next: Tobler with learned constants</a:t>
+              <a:t>Next steps</a:t>
             </a:r>
             <a:endParaRPr lang="en-US" sz="3400" dirty="0"/>
           </a:p>
@@ -5695,524 +5293,281 @@
       </p:sp>
       <p:sp>
         <p:nvSpPr>
-          <p:cNvPr id="4" name="Done chip 1"/>
+          <p:cNvPr id="4" name="Done so far"/>
+          <p:cNvSpPr txBox="1"/>
+          <p:nvPr/>
+        </p:nvSpPr>
+        <p:spPr>
+          <a:xfrm>
+            <a:off x="548640" y="1234440"/>
+            <a:ext cx="11094415" cy="365760"/>
+          </a:xfrm>
+          <a:prstGeom prst="rect">
+            <a:avLst/>
+          </a:prstGeom>
+          <a:noFill/>
+          <a:ln/>
+        </p:spPr>
+        <p:txBody>
+          <a:bodyPr wrap="square" lIns="0" tIns="0" rIns="0" bIns="0" rtlCol="0" anchor="t"/>
+          <a:lstStyle/>
+          <a:p>
+            <a:pPr indent="0" marL="0">
+              <a:buNone/>
+            </a:pPr>
+            <a:r>
+              <a:rPr lang="en-US" sz="1600" b="1" dirty="0">
+                <a:solidFill>
+                  <a:schemeClr val="accent5"/>
+                </a:solidFill>
+              </a:rPr>
+              <a:t>Done so far: </a:t>
+            </a:r>
+            <a:pPr indent="0" marL="0">
+              <a:buNone/>
+            </a:pPr>
+            <a:r>
+              <a:rPr lang="en-US" sz="1600" dirty="0">
+                <a:solidFill>
+                  <a:schemeClr val="accent5"/>
+                </a:solidFill>
+              </a:rPr>
+              <a:t>the dataset, the four-model comparison and a first paper draft.</a:t>
+            </a:r>
+            <a:endParaRPr lang="en-US" sz="1600" dirty="0"/>
+          </a:p>
+        </p:txBody>
+      </p:sp>
+      <p:sp>
+        <p:nvSpPr>
+          <p:cNvPr id="5" name="Next 1 when"/>
+          <p:cNvSpPr txBox="1"/>
+          <p:nvPr/>
+        </p:nvSpPr>
+        <p:spPr>
+          <a:xfrm>
+            <a:off x="548640" y="2093976"/>
+            <a:ext cx="2286000" cy="411480"/>
+          </a:xfrm>
+          <a:prstGeom prst="rect">
+            <a:avLst/>
+          </a:prstGeom>
+          <a:noFill/>
+          <a:ln/>
+        </p:spPr>
+        <p:txBody>
+          <a:bodyPr wrap="square" lIns="0" tIns="0" rIns="0" bIns="0" rtlCol="0" anchor="t"/>
+          <a:lstStyle/>
+          <a:p>
+            <a:pPr indent="0" marL="0">
+              <a:buNone/>
+            </a:pPr>
+            <a:r>
+              <a:rPr lang="en-US" sz="1800" b="1" dirty="0">
+                <a:solidFill>
+                  <a:schemeClr val="accent5"/>
+                </a:solidFill>
+              </a:rPr>
+              <a:t>Weeks 10–11</a:t>
+            </a:r>
+            <a:endParaRPr lang="en-US" sz="1800" dirty="0"/>
+          </a:p>
+        </p:txBody>
+      </p:sp>
+      <p:sp>
+        <p:nvSpPr>
+          <p:cNvPr id="6" name="Next 1 what"/>
+          <p:cNvSpPr txBox="1"/>
+          <p:nvPr/>
+        </p:nvSpPr>
+        <p:spPr>
+          <a:xfrm>
+            <a:off x="2971800" y="2057400"/>
+            <a:ext cx="8671255" cy="502920"/>
+          </a:xfrm>
+          <a:prstGeom prst="rect">
+            <a:avLst/>
+          </a:prstGeom>
+          <a:noFill/>
+          <a:ln/>
+        </p:spPr>
+        <p:txBody>
+          <a:bodyPr wrap="square" lIns="0" tIns="0" rIns="0" bIns="0" rtlCol="0" anchor="t"/>
+          <a:lstStyle/>
+          <a:p>
+            <a:pPr indent="0" marL="0">
+              <a:buNone/>
+            </a:pPr>
+            <a:r>
+              <a:rPr lang="en-US" sz="2200" dirty="0">
+                <a:solidFill>
+                  <a:schemeClr val="bg1"/>
+                </a:solidFill>
+              </a:rPr>
+              <a:t>Learn Tobler's constants from terrain, with uncertainty</a:t>
+            </a:r>
+            <a:endParaRPr lang="en-US" sz="2200" dirty="0"/>
+          </a:p>
+        </p:txBody>
+      </p:sp>
+      <p:sp>
+        <p:nvSpPr>
+          <p:cNvPr id="7" name="Next 2 when"/>
+          <p:cNvSpPr txBox="1"/>
+          <p:nvPr/>
+        </p:nvSpPr>
+        <p:spPr>
+          <a:xfrm>
+            <a:off x="548640" y="2871216"/>
+            <a:ext cx="2286000" cy="411480"/>
+          </a:xfrm>
+          <a:prstGeom prst="rect">
+            <a:avLst/>
+          </a:prstGeom>
+          <a:noFill/>
+          <a:ln/>
+        </p:spPr>
+        <p:txBody>
+          <a:bodyPr wrap="square" lIns="0" tIns="0" rIns="0" bIns="0" rtlCol="0" anchor="t"/>
+          <a:lstStyle/>
+          <a:p>
+            <a:pPr indent="0" marL="0">
+              <a:buNone/>
+            </a:pPr>
+            <a:r>
+              <a:rPr lang="en-US" sz="1800" b="1" dirty="0">
+                <a:solidFill>
+                  <a:schemeClr val="accent5"/>
+                </a:solidFill>
+              </a:rPr>
+              <a:t>Week 12</a:t>
+            </a:r>
+            <a:endParaRPr lang="en-US" sz="1800" dirty="0"/>
+          </a:p>
+        </p:txBody>
+      </p:sp>
+      <p:sp>
+        <p:nvSpPr>
+          <p:cNvPr id="8" name="Next 2 what"/>
+          <p:cNvSpPr txBox="1"/>
+          <p:nvPr/>
+        </p:nvSpPr>
+        <p:spPr>
+          <a:xfrm>
+            <a:off x="2971800" y="2834640"/>
+            <a:ext cx="8671255" cy="502920"/>
+          </a:xfrm>
+          <a:prstGeom prst="rect">
+            <a:avLst/>
+          </a:prstGeom>
+          <a:noFill/>
+          <a:ln/>
+        </p:spPr>
+        <p:txBody>
+          <a:bodyPr wrap="square" lIns="0" tIns="0" rIns="0" bIns="0" rtlCol="0" anchor="t"/>
+          <a:lstStyle/>
+          <a:p>
+            <a:pPr indent="0" marL="0">
+              <a:buNone/>
+            </a:pPr>
+            <a:r>
+              <a:rPr lang="en-US" sz="2200" dirty="0">
+                <a:solidFill>
+                  <a:schemeClr val="bg1"/>
+                </a:solidFill>
+              </a:rPr>
+              <a:t>Add aerial imagery (NAIP) with a pretrained encoder</a:t>
+            </a:r>
+            <a:endParaRPr lang="en-US" sz="2200" dirty="0"/>
+          </a:p>
+        </p:txBody>
+      </p:sp>
+      <p:sp>
+        <p:nvSpPr>
+          <p:cNvPr id="9" name="Next 3 when"/>
+          <p:cNvSpPr txBox="1"/>
+          <p:nvPr/>
+        </p:nvSpPr>
+        <p:spPr>
+          <a:xfrm>
+            <a:off x="548640" y="3648456"/>
+            <a:ext cx="2286000" cy="411480"/>
+          </a:xfrm>
+          <a:prstGeom prst="rect">
+            <a:avLst/>
+          </a:prstGeom>
+          <a:noFill/>
+          <a:ln/>
+        </p:spPr>
+        <p:txBody>
+          <a:bodyPr wrap="square" lIns="0" tIns="0" rIns="0" bIns="0" rtlCol="0" anchor="t"/>
+          <a:lstStyle/>
+          <a:p>
+            <a:pPr indent="0" marL="0">
+              <a:buNone/>
+            </a:pPr>
+            <a:r>
+              <a:rPr lang="en-US" sz="1800" b="1" dirty="0">
+                <a:solidFill>
+                  <a:schemeClr val="accent5"/>
+                </a:solidFill>
+              </a:rPr>
+              <a:t>January</a:t>
+            </a:r>
+            <a:endParaRPr lang="en-US" sz="1800" dirty="0"/>
+          </a:p>
+        </p:txBody>
+      </p:sp>
+      <p:sp>
+        <p:nvSpPr>
+          <p:cNvPr id="10" name="Next 3 what"/>
+          <p:cNvSpPr txBox="1"/>
+          <p:nvPr/>
+        </p:nvSpPr>
+        <p:spPr>
+          <a:xfrm>
+            <a:off x="2971800" y="3611880"/>
+            <a:ext cx="8671255" cy="502920"/>
+          </a:xfrm>
+          <a:prstGeom prst="rect">
+            <a:avLst/>
+          </a:prstGeom>
+          <a:noFill/>
+          <a:ln/>
+        </p:spPr>
+        <p:txBody>
+          <a:bodyPr wrap="square" lIns="0" tIns="0" rIns="0" bIns="0" rtlCol="0" anchor="t"/>
+          <a:lstStyle/>
+          <a:p>
+            <a:pPr indent="0" marL="0">
+              <a:buNone/>
+            </a:pPr>
+            <a:r>
+              <a:rPr lang="en-US" sz="2200" dirty="0">
+                <a:solidFill>
+                  <a:schemeClr val="bg1"/>
+                </a:solidFill>
+              </a:rPr>
+              <a:t>Paper to IGARSS 2027</a:t>
+            </a:r>
+            <a:endParaRPr lang="en-US" sz="2200" dirty="0"/>
+          </a:p>
+        </p:txBody>
+      </p:sp>
+      <p:sp>
+        <p:nvSpPr>
+          <p:cNvPr id="11" name="Question card"/>
           <p:cNvSpPr/>
           <p:nvPr/>
         </p:nvSpPr>
         <p:spPr>
           <a:xfrm>
-            <a:off x="548640" y="1325880"/>
-            <a:ext cx="1600200" cy="457200"/>
+            <a:off x="548640" y="4617720"/>
+            <a:ext cx="11094415" cy="1143000"/>
           </a:xfrm>
           <a:prstGeom prst="roundRect">
             <a:avLst>
-              <a:gd name="adj" fmla="val 20000"/>
-            </a:avLst>
-          </a:prstGeom>
-          <a:solidFill>
-            <a:schemeClr val="accent3"/>
-          </a:solidFill>
-          <a:ln/>
-        </p:spPr>
-      </p:sp>
-      <p:sp>
-        <p:nvSpPr>
-          <p:cNvPr id="5" name="Done chip 1 text"/>
-          <p:cNvSpPr txBox="1"/>
-          <p:nvPr/>
-        </p:nvSpPr>
-        <p:spPr>
-          <a:xfrm>
-            <a:off x="548640" y="1325880"/>
-            <a:ext cx="1600200" cy="457200"/>
-          </a:xfrm>
-          <a:prstGeom prst="rect">
-            <a:avLst/>
-          </a:prstGeom>
-          <a:noFill/>
-          <a:ln/>
-        </p:spPr>
-        <p:txBody>
-          <a:bodyPr wrap="square" lIns="0" tIns="0" rIns="0" bIns="0" rtlCol="0" anchor="ctr"/>
-          <a:lstStyle/>
-          <a:p>
-            <a:pPr algn="ctr" indent="0" marL="0">
-              <a:buNone/>
-            </a:pPr>
-            <a:r>
-              <a:rPr lang="en-US" sz="1400" b="1" dirty="0">
-                <a:solidFill>
-                  <a:schemeClr val="bg1"/>
-                </a:solidFill>
-              </a:rPr>
-              <a:t>✓  T1 dataset</a:t>
-            </a:r>
-            <a:endParaRPr lang="en-US" sz="1400" dirty="0"/>
-          </a:p>
-        </p:txBody>
-      </p:sp>
-      <p:sp>
-        <p:nvSpPr>
-          <p:cNvPr id="6" name="Done chip 2"/>
-          <p:cNvSpPr/>
-          <p:nvPr/>
-        </p:nvSpPr>
-        <p:spPr>
-          <a:xfrm>
-            <a:off x="2368296" y="1325880"/>
-            <a:ext cx="1874520" cy="457200"/>
-          </a:xfrm>
-          <a:prstGeom prst="roundRect">
-            <a:avLst>
-              <a:gd name="adj" fmla="val 20000"/>
-            </a:avLst>
-          </a:prstGeom>
-          <a:solidFill>
-            <a:schemeClr val="accent3"/>
-          </a:solidFill>
-          <a:ln/>
-        </p:spPr>
-      </p:sp>
-      <p:sp>
-        <p:nvSpPr>
-          <p:cNvPr id="7" name="Done chip 2 text"/>
-          <p:cNvSpPr txBox="1"/>
-          <p:nvPr/>
-        </p:nvSpPr>
-        <p:spPr>
-          <a:xfrm>
-            <a:off x="2368296" y="1325880"/>
-            <a:ext cx="1874520" cy="457200"/>
-          </a:xfrm>
-          <a:prstGeom prst="rect">
-            <a:avLst/>
-          </a:prstGeom>
-          <a:noFill/>
-          <a:ln/>
-        </p:spPr>
-        <p:txBody>
-          <a:bodyPr wrap="square" lIns="0" tIns="0" rIns="0" bIns="0" rtlCol="0" anchor="ctr"/>
-          <a:lstStyle/>
-          <a:p>
-            <a:pPr algn="ctr" indent="0" marL="0">
-              <a:buNone/>
-            </a:pPr>
-            <a:r>
-              <a:rPr lang="en-US" sz="1400" b="1" dirty="0">
-                <a:solidFill>
-                  <a:schemeClr val="bg1"/>
-                </a:solidFill>
-              </a:rPr>
-              <a:t>✓  T2 covariates</a:t>
-            </a:r>
-            <a:endParaRPr lang="en-US" sz="1400" dirty="0"/>
-          </a:p>
-        </p:txBody>
-      </p:sp>
-      <p:sp>
-        <p:nvSpPr>
-          <p:cNvPr id="8" name="Done chip 3"/>
-          <p:cNvSpPr/>
-          <p:nvPr/>
-        </p:nvSpPr>
-        <p:spPr>
-          <a:xfrm>
-            <a:off x="4462272" y="1325880"/>
-            <a:ext cx="2880360" cy="457200"/>
-          </a:xfrm>
-          <a:prstGeom prst="roundRect">
-            <a:avLst>
-              <a:gd name="adj" fmla="val 20000"/>
-            </a:avLst>
-          </a:prstGeom>
-          <a:solidFill>
-            <a:schemeClr val="accent3"/>
-          </a:solidFill>
-          <a:ln/>
-        </p:spPr>
-      </p:sp>
-      <p:sp>
-        <p:nvSpPr>
-          <p:cNvPr id="9" name="Done chip 3 text"/>
-          <p:cNvSpPr txBox="1"/>
-          <p:nvPr/>
-        </p:nvSpPr>
-        <p:spPr>
-          <a:xfrm>
-            <a:off x="4462272" y="1325880"/>
-            <a:ext cx="2880360" cy="457200"/>
-          </a:xfrm>
-          <a:prstGeom prst="rect">
-            <a:avLst/>
-          </a:prstGeom>
-          <a:noFill/>
-          <a:ln/>
-        </p:spPr>
-        <p:txBody>
-          <a:bodyPr wrap="square" lIns="0" tIns="0" rIns="0" bIns="0" rtlCol="0" anchor="ctr"/>
-          <a:lstStyle/>
-          <a:p>
-            <a:pPr algn="ctr" indent="0" marL="0">
-              <a:buNone/>
-            </a:pPr>
-            <a:r>
-              <a:rPr lang="en-US" sz="1400" b="1" dirty="0">
-                <a:solidFill>
-                  <a:schemeClr val="bg1"/>
-                </a:solidFill>
-              </a:rPr>
-              <a:t>✓  T3 four-model comparison</a:t>
-            </a:r>
-            <a:endParaRPr lang="en-US" sz="1400" dirty="0"/>
-          </a:p>
-        </p:txBody>
-      </p:sp>
-      <p:sp>
-        <p:nvSpPr>
-          <p:cNvPr id="10" name="Done chip 4"/>
-          <p:cNvSpPr/>
-          <p:nvPr/>
-        </p:nvSpPr>
-        <p:spPr>
-          <a:xfrm>
-            <a:off x="7562088" y="1325880"/>
-            <a:ext cx="2057400" cy="457200"/>
-          </a:xfrm>
-          <a:prstGeom prst="roundRect">
-            <a:avLst>
-              <a:gd name="adj" fmla="val 20000"/>
-            </a:avLst>
-          </a:prstGeom>
-          <a:solidFill>
-            <a:schemeClr val="accent3"/>
-          </a:solidFill>
-          <a:ln/>
-        </p:spPr>
-      </p:sp>
-      <p:sp>
-        <p:nvSpPr>
-          <p:cNvPr id="11" name="Done chip 4 text"/>
-          <p:cNvSpPr txBox="1"/>
-          <p:nvPr/>
-        </p:nvSpPr>
-        <p:spPr>
-          <a:xfrm>
-            <a:off x="7562088" y="1325880"/>
-            <a:ext cx="2057400" cy="457200"/>
-          </a:xfrm>
-          <a:prstGeom prst="rect">
-            <a:avLst/>
-          </a:prstGeom>
-          <a:noFill/>
-          <a:ln/>
-        </p:spPr>
-        <p:txBody>
-          <a:bodyPr wrap="square" lIns="0" tIns="0" rIns="0" bIns="0" rtlCol="0" anchor="ctr"/>
-          <a:lstStyle/>
-          <a:p>
-            <a:pPr algn="ctr" indent="0" marL="0">
-              <a:buNone/>
-            </a:pPr>
-            <a:r>
-              <a:rPr lang="en-US" sz="1400" b="1" dirty="0">
-                <a:solidFill>
-                  <a:schemeClr val="bg1"/>
-                </a:solidFill>
-              </a:rPr>
-              <a:t>✓  T4 slope curves</a:t>
-            </a:r>
-            <a:endParaRPr lang="en-US" sz="1400" dirty="0"/>
-          </a:p>
-        </p:txBody>
-      </p:sp>
-      <p:sp>
-        <p:nvSpPr>
-          <p:cNvPr id="12" name="Done chip 5"/>
-          <p:cNvSpPr/>
-          <p:nvPr/>
-        </p:nvSpPr>
-        <p:spPr>
-          <a:xfrm>
-            <a:off x="9838944" y="1325880"/>
-            <a:ext cx="1783080" cy="457200"/>
-          </a:xfrm>
-          <a:prstGeom prst="roundRect">
-            <a:avLst>
-              <a:gd name="adj" fmla="val 20000"/>
-            </a:avLst>
-          </a:prstGeom>
-          <a:solidFill>
-            <a:schemeClr val="accent3"/>
-          </a:solidFill>
-          <a:ln/>
-        </p:spPr>
-      </p:sp>
-      <p:sp>
-        <p:nvSpPr>
-          <p:cNvPr id="13" name="Done chip 5 text"/>
-          <p:cNvSpPr txBox="1"/>
-          <p:nvPr/>
-        </p:nvSpPr>
-        <p:spPr>
-          <a:xfrm>
-            <a:off x="9838944" y="1325880"/>
-            <a:ext cx="1783080" cy="457200"/>
-          </a:xfrm>
-          <a:prstGeom prst="rect">
-            <a:avLst/>
-          </a:prstGeom>
-          <a:noFill/>
-          <a:ln/>
-        </p:spPr>
-        <p:txBody>
-          <a:bodyPr wrap="square" lIns="0" tIns="0" rIns="0" bIns="0" rtlCol="0" anchor="ctr"/>
-          <a:lstStyle/>
-          <a:p>
-            <a:pPr algn="ctr" indent="0" marL="0">
-              <a:buNone/>
-            </a:pPr>
-            <a:r>
-              <a:rPr lang="en-US" sz="1400" b="1" dirty="0">
-                <a:solidFill>
-                  <a:schemeClr val="bg1"/>
-                </a:solidFill>
-              </a:rPr>
-              <a:t>✓  Paper draft 0</a:t>
-            </a:r>
-            <a:endParaRPr lang="en-US" sz="1400" dirty="0"/>
-          </a:p>
-        </p:txBody>
-      </p:sp>
-      <p:sp>
-        <p:nvSpPr>
-          <p:cNvPr id="14" name="Next 1 when"/>
-          <p:cNvSpPr txBox="1"/>
-          <p:nvPr/>
-        </p:nvSpPr>
-        <p:spPr>
-          <a:xfrm>
-            <a:off x="548640" y="2276856"/>
-            <a:ext cx="2286000" cy="365760"/>
-          </a:xfrm>
-          <a:prstGeom prst="rect">
-            <a:avLst/>
-          </a:prstGeom>
-          <a:noFill/>
-          <a:ln/>
-        </p:spPr>
-        <p:txBody>
-          <a:bodyPr wrap="square" lIns="0" tIns="0" rIns="0" bIns="0" rtlCol="0" anchor="t"/>
-          <a:lstStyle/>
-          <a:p>
-            <a:pPr indent="0" marL="0">
-              <a:buNone/>
-            </a:pPr>
-            <a:r>
-              <a:rPr lang="en-US" sz="1600" b="1" dirty="0">
-                <a:solidFill>
-                  <a:schemeClr val="accent5"/>
-                </a:solidFill>
-              </a:rPr>
-              <a:t>Weeks 10–11</a:t>
-            </a:r>
-            <a:endParaRPr lang="en-US" sz="1600" dirty="0"/>
-          </a:p>
-        </p:txBody>
-      </p:sp>
-      <p:sp>
-        <p:nvSpPr>
-          <p:cNvPr id="15" name="Next 1 what"/>
-          <p:cNvSpPr txBox="1"/>
-          <p:nvPr/>
-        </p:nvSpPr>
-        <p:spPr>
-          <a:xfrm>
-            <a:off x="2971800" y="2240280"/>
-            <a:ext cx="8671255" cy="777240"/>
-          </a:xfrm>
-          <a:prstGeom prst="rect">
-            <a:avLst/>
-          </a:prstGeom>
-          <a:noFill/>
-          <a:ln/>
-        </p:spPr>
-        <p:txBody>
-          <a:bodyPr wrap="square" lIns="0" tIns="0" rIns="0" bIns="0" rtlCol="0" anchor="t"/>
-          <a:lstStyle/>
-          <a:p>
-            <a:pPr indent="0" marL="0">
-              <a:buNone/>
-            </a:pPr>
-            <a:r>
-              <a:rPr lang="en-US" sz="1800" dirty="0">
-                <a:solidFill>
-                  <a:schemeClr val="bg1"/>
-                </a:solidFill>
-              </a:rPr>
-              <a:t>Tobler's form with its constants learned from terrain, plus a variance head (PyTorch). Gate 2, 6 Nov: does it beat boosted trees?</a:t>
-            </a:r>
-            <a:endParaRPr lang="en-US" sz="1800" dirty="0"/>
-          </a:p>
-        </p:txBody>
-      </p:sp>
-      <p:sp>
-        <p:nvSpPr>
-          <p:cNvPr id="16" name="Next 2 when"/>
-          <p:cNvSpPr txBox="1"/>
-          <p:nvPr/>
-        </p:nvSpPr>
-        <p:spPr>
-          <a:xfrm>
-            <a:off x="548640" y="3236976"/>
-            <a:ext cx="2286000" cy="365760"/>
-          </a:xfrm>
-          <a:prstGeom prst="rect">
-            <a:avLst/>
-          </a:prstGeom>
-          <a:noFill/>
-          <a:ln/>
-        </p:spPr>
-        <p:txBody>
-          <a:bodyPr wrap="square" lIns="0" tIns="0" rIns="0" bIns="0" rtlCol="0" anchor="t"/>
-          <a:lstStyle/>
-          <a:p>
-            <a:pPr indent="0" marL="0">
-              <a:buNone/>
-            </a:pPr>
-            <a:r>
-              <a:rPr lang="en-US" sz="1600" b="1" dirty="0">
-                <a:solidFill>
-                  <a:schemeClr val="accent5"/>
-                </a:solidFill>
-              </a:rPr>
-              <a:t>Week 12</a:t>
-            </a:r>
-            <a:endParaRPr lang="en-US" sz="1600" dirty="0"/>
-          </a:p>
-        </p:txBody>
-      </p:sp>
-      <p:sp>
-        <p:nvSpPr>
-          <p:cNvPr id="17" name="Next 2 what"/>
-          <p:cNvSpPr txBox="1"/>
-          <p:nvPr/>
-        </p:nvSpPr>
-        <p:spPr>
-          <a:xfrm>
-            <a:off x="2971800" y="3200400"/>
-            <a:ext cx="8671255" cy="777240"/>
-          </a:xfrm>
-          <a:prstGeom prst="rect">
-            <a:avLst/>
-          </a:prstGeom>
-          <a:noFill/>
-          <a:ln/>
-        </p:spPr>
-        <p:txBody>
-          <a:bodyPr wrap="square" lIns="0" tIns="0" rIns="0" bIns="0" rtlCol="0" anchor="t"/>
-          <a:lstStyle/>
-          <a:p>
-            <a:pPr indent="0" marL="0">
-              <a:buNone/>
-            </a:pPr>
-            <a:r>
-              <a:rPr lang="en-US" sz="1800" dirty="0">
-                <a:solidFill>
-                  <a:schemeClr val="bg1"/>
-                </a:solidFill>
-              </a:rPr>
-              <a:t>NAIP aerial imagery: a frozen pretrained encoder with a small head.</a:t>
-            </a:r>
-            <a:endParaRPr lang="en-US" sz="1800" dirty="0"/>
-          </a:p>
-        </p:txBody>
-      </p:sp>
-      <p:sp>
-        <p:nvSpPr>
-          <p:cNvPr id="18" name="Next 3 when"/>
-          <p:cNvSpPr txBox="1"/>
-          <p:nvPr/>
-        </p:nvSpPr>
-        <p:spPr>
-          <a:xfrm>
-            <a:off x="548640" y="3968496"/>
-            <a:ext cx="2286000" cy="365760"/>
-          </a:xfrm>
-          <a:prstGeom prst="rect">
-            <a:avLst/>
-          </a:prstGeom>
-          <a:noFill/>
-          <a:ln/>
-        </p:spPr>
-        <p:txBody>
-          <a:bodyPr wrap="square" lIns="0" tIns="0" rIns="0" bIns="0" rtlCol="0" anchor="t"/>
-          <a:lstStyle/>
-          <a:p>
-            <a:pPr indent="0" marL="0">
-              <a:buNone/>
-            </a:pPr>
-            <a:r>
-              <a:rPr lang="en-US" sz="1600" b="1" dirty="0">
-                <a:solidFill>
-                  <a:schemeClr val="accent5"/>
-                </a:solidFill>
-              </a:rPr>
-              <a:t>Week 13 to 11 Jan</a:t>
-            </a:r>
-            <a:endParaRPr lang="en-US" sz="1600" dirty="0"/>
-          </a:p>
-        </p:txBody>
-      </p:sp>
-      <p:sp>
-        <p:nvSpPr>
-          <p:cNvPr id="19" name="Next 3 what"/>
-          <p:cNvSpPr txBox="1"/>
-          <p:nvPr/>
-        </p:nvSpPr>
-        <p:spPr>
-          <a:xfrm>
-            <a:off x="2971800" y="3931920"/>
-            <a:ext cx="8671255" cy="777240"/>
-          </a:xfrm>
-          <a:prstGeom prst="rect">
-            <a:avLst/>
-          </a:prstGeom>
-          <a:noFill/>
-          <a:ln/>
-        </p:spPr>
-        <p:txBody>
-          <a:bodyPr wrap="square" lIns="0" tIns="0" rIns="0" bIns="0" rtlCol="0" anchor="t"/>
-          <a:lstStyle/>
-          <a:p>
-            <a:pPr indent="0" marL="0">
-              <a:buNone/>
-            </a:pPr>
-            <a:r>
-              <a:rPr lang="en-US" sz="1800" dirty="0">
-                <a:solidFill>
-                  <a:schemeClr val="bg1"/>
-                </a:solidFill>
-              </a:rPr>
-              <a:t>Full paper draft, then IGARSS 2027 and its Student Paper Competition.</a:t>
-            </a:r>
-            <a:endParaRPr lang="en-US" sz="1800" dirty="0"/>
-          </a:p>
-        </p:txBody>
-      </p:sp>
-      <p:sp>
-        <p:nvSpPr>
-          <p:cNvPr id="20" name="Question card"/>
-          <p:cNvSpPr/>
-          <p:nvPr/>
-        </p:nvSpPr>
-        <p:spPr>
-          <a:xfrm>
-            <a:off x="548640" y="4892040"/>
-            <a:ext cx="11094415" cy="1005840"/>
-          </a:xfrm>
-          <a:prstGeom prst="roundRect">
-            <a:avLst>
-              <a:gd name="adj" fmla="val 9091"/>
+              <a:gd name="adj" fmla="val 8000"/>
             </a:avLst>
           </a:prstGeom>
           <a:solidFill>
@@ -6225,14 +5580,14 @@
       </p:sp>
       <p:sp>
         <p:nvSpPr>
-          <p:cNvPr id="21" name="Question"/>
+          <p:cNvPr id="12" name="Question"/>
           <p:cNvSpPr txBox="1"/>
           <p:nvPr/>
         </p:nvSpPr>
         <p:spPr>
           <a:xfrm>
-            <a:off x="822960" y="4892040"/>
-            <a:ext cx="10545775" cy="1005840"/>
+            <a:off x="868680" y="4617720"/>
+            <a:ext cx="10454335" cy="1143000"/>
           </a:xfrm>
           <a:prstGeom prst="rect">
             <a:avLst/>
@@ -6248,25 +5603,25 @@
               <a:buNone/>
             </a:pPr>
             <a:r>
-              <a:rPr lang="en-US" sz="1800" b="1" dirty="0">
+              <a:rPr lang="en-US" sz="2000" b="1" dirty="0">
                 <a:solidFill>
                   <a:schemeClr val="bg1"/>
                 </a:solidFill>
               </a:rPr>
-              <a:t>Question for the lab: </a:t>
-            </a:r>
-            <a:pPr indent="0" marL="0">
-              <a:buNone/>
-            </a:pPr>
-            <a:r>
-              <a:rPr lang="en-US" sz="1800" dirty="0">
+              <a:t>Question for you: </a:t>
+            </a:r>
+            <a:pPr indent="0" marL="0">
+              <a:buNone/>
+            </a:pPr>
+            <a:r>
+              <a:rPr lang="en-US" sz="2000" dirty="0">
                 <a:solidFill>
                   <a:schemeClr val="bg1"/>
                 </a:solidFill>
               </a:rPr>
-              <a:t>which pretrained aerial-imagery encoder would you use for 1 m NAIP chips along trails?</a:t>
-            </a:r>
-            <a:endParaRPr lang="en-US" sz="1800" dirty="0"/>
+              <a:t>which pretrained encoder would you use for 1 m aerial imagery along trails?</a:t>
+            </a:r>
+            <a:endParaRPr lang="en-US" sz="2000" dirty="0"/>
           </a:p>
         </p:txBody>
       </p:sp>

</xml_diff>

<commit_message>
Lab deck slide 6: zero line labeled 'slope alone', stat says 'improvement'; plain-words speaker notes with answers to likely follow-ups
QA sheet corrected: the '2-3% sounds small' answer overstated the
person-and-day share (only ~26% of the variance left after slope is
between hikes), and the cut-details list had the tag numbers swapped
(+0.9% additive / +0.4% trees). New answers: what terrain is, why tags
don't carry over, whether terrain's lead is real.

Co-Authored-By: Claude Opus 5.5 <noreply@anthropic.com>
</commit_message>
<xml_diff>
--- a/meeting_plots/oct23_lab/Zhou_LabMeeting_23Oct.pptx
+++ b/meeting_plots/oct23_lab/Zhou_LabMeeting_23Oct.pptx
@@ -113,29 +113,29 @@
   <p:extLst>
     <p:ext uri="{521415D9-36F7-43E2-AB2F-B90AF26B5E84}">
       <p14:sectionLst xmlns:p14="http://schemas.microsoft.com/office/powerpoint/2010/main">
-        <p14:section name="Introduction" id="{7f881998-8734-1d41-334a-84f690222abd}">
+        <p14:section name="Introduction" id="{f4595bab-608b-9153-ddd0-6a31b9221a88}">
           <p14:sldIdLst>
             <p14:sldId id="256"/>
           </p14:sldIdLst>
         </p14:section>
-        <p14:section name="Problem and goal" id="{682bfd78-cec6-dcd8-c678-70eb091723b0}">
+        <p14:section name="Problem and goal" id="{3fffb743-a316-a8cd-6edd-3c1ea0cf5542}">
           <p14:sldIdLst>
             <p14:sldId id="257"/>
             <p14:sldId id="258"/>
           </p14:sldIdLst>
         </p14:section>
-        <p14:section name="Data" id="{790c32de-8408-63d5-b131-1a6870d9b38c}">
+        <p14:section name="Data" id="{79f46390-53fd-5a76-1040-4aa4bdffbf82}">
           <p14:sldIdLst>
             <p14:sldId id="259"/>
           </p14:sldIdLst>
         </p14:section>
-        <p14:section name="Findings" id="{41ee531d-3375-953c-8ae0-f98808053dad}">
+        <p14:section name="Findings" id="{1bec45c6-fd73-d371-cd9e-4f3f0e5fa84a}">
           <p14:sldIdLst>
             <p14:sldId id="260"/>
             <p14:sldId id="261"/>
           </p14:sldIdLst>
         </p14:section>
-        <p14:section name="Next steps" id="{dd8d1044-a34d-703f-a098-fdb9682d4286}">
+        <p14:section name="Next steps" id="{2b1e0444-fbd9-d4f6-0d20-d01bc07435d5}">
           <p14:sldIdLst>
             <p14:sldId id="262"/>
           </p14:sldIdLst>
@@ -984,7 +984,7 @@
           <a:p>
             <a:r>
               <a:rPr lang="en-US" dirty="0"/>
-              <a:t>The main result. Each row is one region the model never saw; further right means better predictions than slope alone. Blue is terrain from elevation data, orange is the map's tags. Terrain wins in 16 of 17 regions: about 2 to 3% better than slope alone, while the tags gain under 1%. (If asked: the score is CRPS on the predicted speed distribution, and RMSE agrees; it holds with all of a region's hikers removed from training; vegetation and satellite embeddings help inside a region but don't transfer.)</a:t>
+              <a:t>This is the main result. Each row is one region the model never saw: it learned from the other 16 and was tested on this one. The black line at zero is slope alone, the curve from the last slide; dots to the right are better predictions. Blue adds terrain from lidar elevation maps, mostly the hidden ups and downs inside each 50-meter stretch that the average slope misses. Orange adds what the map says about the trail, like its difficulty grade and surface. Blue beats orange in 16 of 17 regions and is right of zero in every one. Orange is left of zero in five: there, tags learned elsewhere actually misled the model. Overall, terrain is 2 to 3% better than slope alone; tags, under 1%. (If asked why so small: speed is noisy; after slope, a quarter of what's left differs between hikes and the rest from stretch to stretch, and nothing we tried does much better; against Tobler, terrain is about 13% better. The score is CRPS, which grades the whole predicted range of speeds, and RMSE agrees. Terrain's lead over tags is +0.7 to +2.2 points, 95% interval. It holds with every hiker from the test region removed from training. Yosemite, the one exception, isn't investigated yet.)</a:t>
             </a:r>
             <a:endParaRPr lang="en-US" dirty="0"/>
           </a:p>
@@ -5098,7 +5098,7 @@
                   <a:schemeClr val="tx1"/>
                 </a:solidFill>
               </a:rPr>
-              <a:t>terrain's gain over slope alone</a:t>
+              <a:t>terrain's improvement over slope alone</a:t>
             </a:r>
             <a:endParaRPr lang="en-US" sz="1500" dirty="0"/>
           </a:p>

</xml_diff>

<commit_message>
Lab deck slide 7: 'rough first draft', week 12 'if time', IGARSS due date; plain-words speaker notes with answers to likely follow-ups; three Q&A answers for it
Co-Authored-By: Claude Opus 5.5 <noreply@anthropic.com>
</commit_message>
<xml_diff>
--- a/meeting_plots/oct23_lab/Zhou_LabMeeting_23Oct.pptx
+++ b/meeting_plots/oct23_lab/Zhou_LabMeeting_23Oct.pptx
@@ -113,29 +113,29 @@
   <p:extLst>
     <p:ext uri="{521415D9-36F7-43E2-AB2F-B90AF26B5E84}">
       <p14:sectionLst xmlns:p14="http://schemas.microsoft.com/office/powerpoint/2010/main">
-        <p14:section name="Introduction" id="{f4595bab-608b-9153-ddd0-6a31b9221a88}">
+        <p14:section name="Introduction" id="{c069a990-6601-58c8-02e1-b3cb2f9fffef}">
           <p14:sldIdLst>
             <p14:sldId id="256"/>
           </p14:sldIdLst>
         </p14:section>
-        <p14:section name="Problem and goal" id="{3fffb743-a316-a8cd-6edd-3c1ea0cf5542}">
+        <p14:section name="Problem and goal" id="{94988862-8f6e-8e91-9a61-4f7d6da89785}">
           <p14:sldIdLst>
             <p14:sldId id="257"/>
             <p14:sldId id="258"/>
           </p14:sldIdLst>
         </p14:section>
-        <p14:section name="Data" id="{79f46390-53fd-5a76-1040-4aa4bdffbf82}">
+        <p14:section name="Data" id="{1d0ded29-6df7-6709-9e56-9c5c45811cea}">
           <p14:sldIdLst>
             <p14:sldId id="259"/>
           </p14:sldIdLst>
         </p14:section>
-        <p14:section name="Findings" id="{1bec45c6-fd73-d371-cd9e-4f3f0e5fa84a}">
+        <p14:section name="Findings" id="{f7a2f580-aa4b-f924-8b80-8432ff73cee8}">
           <p14:sldIdLst>
             <p14:sldId id="260"/>
             <p14:sldId id="261"/>
           </p14:sldIdLst>
         </p14:section>
-        <p14:section name="Next steps" id="{2b1e0444-fbd9-d4f6-0d20-d01bc07435d5}">
+        <p14:section name="Next steps" id="{4e9aa8c5-e808-b160-022d-81c3e134b605}">
           <p14:sldIdLst>
             <p14:sldId id="262"/>
           </p14:sldIdLst>
@@ -1072,7 +1072,7 @@
           <a:p>
             <a:r>
               <a:rPr lang="en-US" dirty="0"/>
-              <a:t>So far: the dataset, the four-model comparison, and a first paper draft. Next, in weeks 10 and 11: keep Tobler's shape but learn its constants from the terrain, with an uncertainty estimate. Week 12: add aerial imagery. Then the paper for IGARSS in January. One question for you: which pretrained encoder would you use for 1 m aerial imagery along trails? (If asked: the check on 6 November is whether that model beats boosted trees.)</a:t>
+              <a:t>So far: the dataset, the four-model comparison, and a rough first draft of the paper. Next, in weeks 10 and 11: keep Tobler's formula, but let a small neural network learn its numbers from the terrain, so smooth and steppy trail get their own numbers. It also says how sure it is. On November 6 we check whether it beats the boosted trees. Week 12, if there's time: add aerial photos through a pretrained image model. Then the paper goes to IGARSS; the deadline is January 11. One question for you: which pretrained encoder would you use for 1-meter aerial imagery along trails? Thank you. (If asked: Why Tobler's form and not just the trees? It gives numbers the field can use, like how Tobler's steepness constant changes from smooth to steppy trail. Why would photos help when the satellite embeddings didn't? They might not: the 10 m embeddings mostly told the model which place it was in, while 1 m photos see the trail itself; the new-region test decides. NAIP covers only the US, so North Shore drops out of that test. The draft was written with Claude's help from our results, and I'm rewriting it in my own words.)</a:t>
             </a:r>
             <a:endParaRPr lang="en-US" dirty="0"/>
           </a:p>
@@ -5332,7 +5332,7 @@
                   <a:schemeClr val="accent5"/>
                 </a:solidFill>
               </a:rPr>
-              <a:t>the dataset, the four-model comparison and a first paper draft.</a:t>
+              <a:t>the dataset, the four-model comparison and a rough first draft of the paper.</a:t>
             </a:r>
             <a:endParaRPr lang="en-US" sz="1600" dirty="0"/>
           </a:p>
@@ -5440,7 +5440,7 @@
                   <a:schemeClr val="accent5"/>
                 </a:solidFill>
               </a:rPr>
-              <a:t>Week 12</a:t>
+              <a:t>Week 12, if time</a:t>
             </a:r>
             <a:endParaRPr lang="en-US" sz="1800" dirty="0"/>
           </a:p>
@@ -5548,7 +5548,7 @@
                   <a:schemeClr val="bg1"/>
                 </a:solidFill>
               </a:rPr>
-              <a:t>Paper to IGARSS 2027</a:t>
+              <a:t>Submit the paper to IGARSS 2027 (due 11 Jan)</a:t>
             </a:r>
             <a:endParaRPr lang="en-US" sz="2200" dirty="0"/>
           </a:p>

</xml_diff>